<commit_message>
docs(meetings): add 6.18/6.29 supervisor meetings, transcription tool, and updated notes
- supervisor 6.18 meeting: audio, transcript (txt/srt/timed), photos
- supervisor 6.29 meeting: photos
- transcribe.py: local mlx-whisper meeting transcription helper
- rename personal notes 2026-05-22/06-02 -> 5-22/6-02 (+ en)
- add 7.3 / 7.10 slides and 7.10 practice write-ups; update 6.18.pptx

Co-authored-by: Cursor <cursoragent@cursor.com>
</commit_message>
<xml_diff>
--- a/meetings/我/6.18.pptx
+++ b/meetings/我/6.18.pptx
@@ -5,29 +5,22 @@
     <p:sldMasterId id="2147483648" r:id="rId1"/>
   </p:sldMasterIdLst>
   <p:notesMasterIdLst>
-    <p:notesMasterId r:id="rId20"/>
+    <p:notesMasterId r:id="rId4"/>
   </p:notesMasterIdLst>
   <p:handoutMasterIdLst>
-    <p:handoutMasterId r:id="rId21"/>
+    <p:handoutMasterId r:id="rId14"/>
   </p:handoutMasterIdLst>
   <p:sldIdLst>
-    <p:sldId id="256" r:id="rId3"/>
-    <p:sldId id="257" r:id="rId4"/>
-    <p:sldId id="260" r:id="rId5"/>
-    <p:sldId id="259" r:id="rId6"/>
-    <p:sldId id="258" r:id="rId7"/>
-    <p:sldId id="262" r:id="rId8"/>
-    <p:sldId id="263" r:id="rId9"/>
-    <p:sldId id="266" r:id="rId10"/>
-    <p:sldId id="267" r:id="rId11"/>
-    <p:sldId id="268" r:id="rId12"/>
-    <p:sldId id="261" r:id="rId13"/>
-    <p:sldId id="269" r:id="rId14"/>
-    <p:sldId id="270" r:id="rId15"/>
-    <p:sldId id="271" r:id="rId16"/>
-    <p:sldId id="272" r:id="rId17"/>
-    <p:sldId id="273" r:id="rId18"/>
-    <p:sldId id="274" r:id="rId19"/>
+    <p:sldId id="275" r:id="rId3"/>
+    <p:sldId id="257" r:id="rId5"/>
+    <p:sldId id="260" r:id="rId6"/>
+    <p:sldId id="279" r:id="rId7"/>
+    <p:sldId id="280" r:id="rId8"/>
+    <p:sldId id="262" r:id="rId9"/>
+    <p:sldId id="263" r:id="rId10"/>
+    <p:sldId id="266" r:id="rId11"/>
+    <p:sldId id="267" r:id="rId12"/>
+    <p:sldId id="268" r:id="rId13"/>
   </p:sldIdLst>
   <p:sldSz cx="12192000" cy="6858000"/>
   <p:notesSz cx="6858000" cy="9144000"/>
@@ -648,6 +641,132 @@
     </a:lvl9pPr>
   </p:notesStyle>
 </p:notesMaster>
+</file>
+
+<file path=ppt/notesSlides/notesSlide1.xml><?xml version="1.0" encoding="utf-8"?>
+<p:notes xmlns:a="http://schemas.openxmlformats.org/drawingml/2006/main" xmlns:r="http://schemas.openxmlformats.org/officeDocument/2006/relationships" xmlns:p="http://schemas.openxmlformats.org/presentationml/2006/main">
+  <p:cSld>
+    <p:spTree>
+      <p:nvGrpSpPr>
+        <p:cNvPr id="1" name=""/>
+        <p:cNvGrpSpPr/>
+        <p:nvPr/>
+      </p:nvGrpSpPr>
+      <p:grpSpPr>
+        <a:xfrm>
+          <a:off x="0" y="0"/>
+          <a:ext cx="0" cy="0"/>
+          <a:chOff x="0" y="0"/>
+          <a:chExt cx="0" cy="0"/>
+        </a:xfrm>
+      </p:grpSpPr>
+      <p:sp>
+        <p:nvSpPr>
+          <p:cNvPr id="2" name="幻灯片图像占位符 1"/>
+          <p:cNvSpPr>
+            <a:spLocks noGrp="1" noRot="1" noChangeAspect="1"/>
+          </p:cNvSpPr>
+          <p:nvPr>
+            <p:ph type="sldImg"/>
+          </p:nvPr>
+        </p:nvSpPr>
+        <p:spPr/>
+      </p:sp>
+      <p:sp>
+        <p:nvSpPr>
+          <p:cNvPr id="3" name="备注占位符 2"/>
+          <p:cNvSpPr>
+            <a:spLocks noGrp="1"/>
+          </p:cNvSpPr>
+          <p:nvPr>
+            <p:ph type="body" idx="1"/>
+          </p:nvPr>
+        </p:nvSpPr>
+        <p:spPr/>
+        <p:txBody>
+          <a:bodyPr/>
+          <a:lstStyle/>
+          <a:p>
+            <a:endParaRPr kumimoji="1" lang="zh-CN" altLang="en-US" dirty="0"/>
+          </a:p>
+        </p:txBody>
+      </p:sp>
+      <p:sp>
+        <p:nvSpPr>
+          <p:cNvPr id="4" name="灯片编号占位符 3"/>
+          <p:cNvSpPr>
+            <a:spLocks noGrp="1"/>
+          </p:cNvSpPr>
+          <p:nvPr>
+            <p:ph type="sldNum" sz="quarter" idx="5"/>
+          </p:nvPr>
+        </p:nvSpPr>
+        <p:spPr/>
+        <p:txBody>
+          <a:bodyPr/>
+          <a:lstStyle/>
+          <a:p>
+            <a:fld id="{A6837353-30EB-4A48-80EB-173D804AEFBD}" type="slidenum">
+              <a:rPr lang="zh-CN" altLang="en-US" smtClean="0"/>
+            </a:fld>
+            <a:endParaRPr lang="zh-CN" altLang="en-US"/>
+          </a:p>
+        </p:txBody>
+      </p:sp>
+    </p:spTree>
+  </p:cSld>
+  <p:clrMapOvr>
+    <a:masterClrMapping/>
+  </p:clrMapOvr>
+</p:notes>
+</file>
+
+<file path=ppt/notesSlides/notesSlide2.xml><?xml version="1.0" encoding="utf-8"?>
+<p:notes xmlns:a="http://schemas.openxmlformats.org/drawingml/2006/main" xmlns:r="http://schemas.openxmlformats.org/officeDocument/2006/relationships" xmlns:p="http://schemas.openxmlformats.org/presentationml/2006/main">
+  <p:cSld>
+    <p:spTree>
+      <p:nvGrpSpPr>
+        <p:cNvPr id="1" name=""/>
+        <p:cNvGrpSpPr/>
+        <p:nvPr/>
+      </p:nvGrpSpPr>
+      <p:grpSpPr/>
+      <p:sp>
+        <p:nvSpPr>
+          <p:cNvPr id="2" name="幻灯片图像占位符 1"/>
+          <p:cNvSpPr>
+            <a:spLocks noGrp="1"/>
+          </p:cNvSpPr>
+          <p:nvPr>
+            <p:ph type="sldImg" idx="2"/>
+          </p:nvPr>
+        </p:nvSpPr>
+        <p:spPr/>
+      </p:sp>
+      <p:sp>
+        <p:nvSpPr>
+          <p:cNvPr id="3" name="文本占位符 2"/>
+          <p:cNvSpPr>
+            <a:spLocks noGrp="1"/>
+          </p:cNvSpPr>
+          <p:nvPr>
+            <p:ph type="body" idx="3"/>
+          </p:nvPr>
+        </p:nvSpPr>
+        <p:spPr/>
+        <p:txBody>
+          <a:bodyPr/>
+          <a:p>
+            <a:endParaRPr lang="zh-CN" altLang="en-US"/>
+          </a:p>
+        </p:txBody>
+      </p:sp>
+    </p:spTree>
+  </p:cSld>
+  <p:clrMapOvr>
+    <a:masterClrMapping/>
+  </p:clrMapOvr>
+</p:notes>
 </file>
 
 <file path=ppt/slideLayouts/slideLayout1.xml><?xml version="1.0" encoding="utf-8"?>
@@ -3608,50 +3727,327 @@
       </p:grpSpPr>
       <p:sp>
         <p:nvSpPr>
-          <p:cNvPr id="2" name="标题 1"/>
-          <p:cNvSpPr>
-            <a:spLocks noGrp="1"/>
-          </p:cNvSpPr>
-          <p:nvPr>
-            <p:ph type="ctrTitle"/>
-            <p:custDataLst>
-              <p:tags r:id="rId1"/>
-            </p:custDataLst>
-          </p:nvPr>
-        </p:nvSpPr>
-        <p:spPr/>
-        <p:txBody>
-          <a:bodyPr/>
-          <a:p>
-            <a:endParaRPr lang="zh-CN" altLang="zh-CN"/>
-          </a:p>
-        </p:txBody>
-      </p:sp>
-      <p:sp>
-        <p:nvSpPr>
           <p:cNvPr id="3" name="副标题 2"/>
           <p:cNvSpPr>
             <a:spLocks noGrp="1"/>
           </p:cNvSpPr>
           <p:nvPr>
             <p:ph type="subTitle" idx="1"/>
-            <p:custDataLst>
-              <p:tags r:id="rId2"/>
-            </p:custDataLst>
           </p:nvPr>
         </p:nvSpPr>
-        <p:spPr/>
-        <p:txBody>
-          <a:bodyPr/>
-          <a:p>
-            <a:endParaRPr lang="zh-CN" altLang="en-US"/>
+        <p:spPr>
+          <a:xfrm>
+            <a:off x="1797050" y="1416685"/>
+            <a:ext cx="9144000" cy="1856105"/>
+          </a:xfrm>
+        </p:spPr>
+        <p:txBody>
+          <a:bodyPr>
+            <a:normAutofit fontScale="90000" lnSpcReduction="10000"/>
+          </a:bodyPr>
+          <a:lstStyle/>
+          <a:p>
+            <a:r>
+              <a:rPr lang="en-GB" altLang="zh-CN" sz="5400" b="1" dirty="0">
+                <a:solidFill>
+                  <a:schemeClr val="tx1"/>
+                </a:solidFill>
+                <a:latin typeface="Times New Roman" panose="02020503050405090304" charset="0"/>
+                <a:cs typeface="Times New Roman" panose="02020503050405090304" charset="0"/>
+              </a:rPr>
+              <a:t>Week</a:t>
+            </a:r>
+            <a:r>
+              <a:rPr lang="en-US" sz="5400" b="1" dirty="0">
+                <a:solidFill>
+                  <a:schemeClr val="tx1"/>
+                </a:solidFill>
+                <a:latin typeface="Times New Roman" panose="02020503050405090304" charset="0"/>
+                <a:cs typeface="Times New Roman" panose="02020503050405090304" charset="0"/>
+              </a:rPr>
+              <a:t>ly</a:t>
+            </a:r>
+            <a:r>
+              <a:rPr lang="en-GB" altLang="zh-CN" sz="5400" b="1" dirty="0">
+                <a:solidFill>
+                  <a:schemeClr val="tx1"/>
+                </a:solidFill>
+                <a:latin typeface="Times New Roman" panose="02020503050405090304" charset="0"/>
+                <a:cs typeface="Times New Roman" panose="02020503050405090304" charset="0"/>
+              </a:rPr>
+              <a:t> </a:t>
+            </a:r>
+            <a:endParaRPr lang="en-GB" altLang="zh-CN" sz="5400" b="1" dirty="0">
+              <a:solidFill>
+                <a:schemeClr val="tx1"/>
+              </a:solidFill>
+              <a:latin typeface="Times New Roman" panose="02020503050405090304" charset="0"/>
+              <a:cs typeface="Times New Roman" panose="02020503050405090304" charset="0"/>
+            </a:endParaRPr>
+          </a:p>
+          <a:p>
+            <a:r>
+              <a:rPr lang="en-GB" altLang="zh-CN" sz="5400" b="1" dirty="0">
+                <a:solidFill>
+                  <a:schemeClr val="tx1"/>
+                </a:solidFill>
+                <a:latin typeface="Times New Roman" panose="02020503050405090304" charset="0"/>
+                <a:cs typeface="Times New Roman" panose="02020503050405090304" charset="0"/>
+              </a:rPr>
+              <a:t>Report</a:t>
+            </a:r>
+            <a:endParaRPr lang="en-GB" altLang="zh-CN" sz="5400" b="1" dirty="0">
+              <a:solidFill>
+                <a:schemeClr val="tx1"/>
+              </a:solidFill>
+              <a:latin typeface="Times New Roman" panose="02020503050405090304" charset="0"/>
+              <a:cs typeface="Times New Roman" panose="02020503050405090304" charset="0"/>
+            </a:endParaRPr>
+          </a:p>
+          <a:p>
+            <a:endParaRPr lang="en-GB" altLang="zh-CN" sz="5400" b="1" dirty="0">
+              <a:solidFill>
+                <a:schemeClr val="tx1"/>
+              </a:solidFill>
+              <a:latin typeface="Times New Roman" panose="02020503050405090304" charset="0"/>
+              <a:cs typeface="Times New Roman" panose="02020503050405090304" charset="0"/>
+            </a:endParaRPr>
+          </a:p>
+        </p:txBody>
+      </p:sp>
+      <p:sp>
+        <p:nvSpPr>
+          <p:cNvPr id="4" name="副标题 2"/>
+          <p:cNvSpPr txBox="1"/>
+          <p:nvPr/>
+        </p:nvSpPr>
+        <p:spPr>
+          <a:xfrm>
+            <a:off x="9550400" y="5644222"/>
+            <a:ext cx="2288200" cy="809318"/>
+          </a:xfrm>
+          <a:prstGeom prst="rect">
+            <a:avLst/>
+          </a:prstGeom>
+        </p:spPr>
+        <p:txBody>
+          <a:bodyPr vert="horz" lIns="91440" tIns="45720" rIns="91440" bIns="45720" rtlCol="0">
+            <a:normAutofit/>
+          </a:bodyPr>
+          <a:lstStyle>
+            <a:lvl1pPr marL="0" indent="0" algn="ctr" defTabSz="914400" rtl="0" eaLnBrk="1" latinLnBrk="0" hangingPunct="1">
+              <a:lnSpc>
+                <a:spcPct val="90000"/>
+              </a:lnSpc>
+              <a:spcBef>
+                <a:spcPts val="1000"/>
+              </a:spcBef>
+              <a:buFont typeface="Arial" panose="020B0604020202090204" pitchFamily="34" charset="0"/>
+              <a:buNone/>
+              <a:defRPr sz="2400" kern="1200">
+                <a:solidFill>
+                  <a:schemeClr val="tx1"/>
+                </a:solidFill>
+                <a:latin typeface="+mn-lt"/>
+                <a:ea typeface="+mn-ea"/>
+                <a:cs typeface="+mn-cs"/>
+              </a:defRPr>
+            </a:lvl1pPr>
+            <a:lvl2pPr marL="457200" indent="0" algn="ctr" defTabSz="914400" rtl="0" eaLnBrk="1" latinLnBrk="0" hangingPunct="1">
+              <a:lnSpc>
+                <a:spcPct val="90000"/>
+              </a:lnSpc>
+              <a:spcBef>
+                <a:spcPts val="500"/>
+              </a:spcBef>
+              <a:buFont typeface="Arial" panose="020B0604020202090204" pitchFamily="34" charset="0"/>
+              <a:buNone/>
+              <a:defRPr sz="2000" kern="1200">
+                <a:solidFill>
+                  <a:schemeClr val="tx1"/>
+                </a:solidFill>
+                <a:latin typeface="+mn-lt"/>
+                <a:ea typeface="+mn-ea"/>
+                <a:cs typeface="+mn-cs"/>
+              </a:defRPr>
+            </a:lvl2pPr>
+            <a:lvl3pPr marL="914400" indent="0" algn="ctr" defTabSz="914400" rtl="0" eaLnBrk="1" latinLnBrk="0" hangingPunct="1">
+              <a:lnSpc>
+                <a:spcPct val="90000"/>
+              </a:lnSpc>
+              <a:spcBef>
+                <a:spcPts val="500"/>
+              </a:spcBef>
+              <a:buFont typeface="Arial" panose="020B0604020202090204" pitchFamily="34" charset="0"/>
+              <a:buNone/>
+              <a:defRPr sz="1800" kern="1200">
+                <a:solidFill>
+                  <a:schemeClr val="tx1"/>
+                </a:solidFill>
+                <a:latin typeface="+mn-lt"/>
+                <a:ea typeface="+mn-ea"/>
+                <a:cs typeface="+mn-cs"/>
+              </a:defRPr>
+            </a:lvl3pPr>
+            <a:lvl4pPr marL="1371600" indent="0" algn="ctr" defTabSz="914400" rtl="0" eaLnBrk="1" latinLnBrk="0" hangingPunct="1">
+              <a:lnSpc>
+                <a:spcPct val="90000"/>
+              </a:lnSpc>
+              <a:spcBef>
+                <a:spcPts val="500"/>
+              </a:spcBef>
+              <a:buFont typeface="Arial" panose="020B0604020202090204" pitchFamily="34" charset="0"/>
+              <a:buNone/>
+              <a:defRPr sz="1600" kern="1200">
+                <a:solidFill>
+                  <a:schemeClr val="tx1"/>
+                </a:solidFill>
+                <a:latin typeface="+mn-lt"/>
+                <a:ea typeface="+mn-ea"/>
+                <a:cs typeface="+mn-cs"/>
+              </a:defRPr>
+            </a:lvl4pPr>
+            <a:lvl5pPr marL="1828800" indent="0" algn="ctr" defTabSz="914400" rtl="0" eaLnBrk="1" latinLnBrk="0" hangingPunct="1">
+              <a:lnSpc>
+                <a:spcPct val="90000"/>
+              </a:lnSpc>
+              <a:spcBef>
+                <a:spcPts val="500"/>
+              </a:spcBef>
+              <a:buFont typeface="Arial" panose="020B0604020202090204" pitchFamily="34" charset="0"/>
+              <a:buNone/>
+              <a:defRPr sz="1600" kern="1200">
+                <a:solidFill>
+                  <a:schemeClr val="tx1"/>
+                </a:solidFill>
+                <a:latin typeface="+mn-lt"/>
+                <a:ea typeface="+mn-ea"/>
+                <a:cs typeface="+mn-cs"/>
+              </a:defRPr>
+            </a:lvl5pPr>
+            <a:lvl6pPr marL="2286000" indent="0" algn="ctr" defTabSz="914400" rtl="0" eaLnBrk="1" latinLnBrk="0" hangingPunct="1">
+              <a:lnSpc>
+                <a:spcPct val="90000"/>
+              </a:lnSpc>
+              <a:spcBef>
+                <a:spcPts val="500"/>
+              </a:spcBef>
+              <a:buFont typeface="Arial" panose="020B0604020202090204" pitchFamily="34" charset="0"/>
+              <a:buNone/>
+              <a:defRPr sz="1600" kern="1200">
+                <a:solidFill>
+                  <a:schemeClr val="tx1"/>
+                </a:solidFill>
+                <a:latin typeface="+mn-lt"/>
+                <a:ea typeface="+mn-ea"/>
+                <a:cs typeface="+mn-cs"/>
+              </a:defRPr>
+            </a:lvl6pPr>
+            <a:lvl7pPr marL="2743200" indent="0" algn="ctr" defTabSz="914400" rtl="0" eaLnBrk="1" latinLnBrk="0" hangingPunct="1">
+              <a:lnSpc>
+                <a:spcPct val="90000"/>
+              </a:lnSpc>
+              <a:spcBef>
+                <a:spcPts val="500"/>
+              </a:spcBef>
+              <a:buFont typeface="Arial" panose="020B0604020202090204" pitchFamily="34" charset="0"/>
+              <a:buNone/>
+              <a:defRPr sz="1600" kern="1200">
+                <a:solidFill>
+                  <a:schemeClr val="tx1"/>
+                </a:solidFill>
+                <a:latin typeface="+mn-lt"/>
+                <a:ea typeface="+mn-ea"/>
+                <a:cs typeface="+mn-cs"/>
+              </a:defRPr>
+            </a:lvl7pPr>
+            <a:lvl8pPr marL="3200400" indent="0" algn="ctr" defTabSz="914400" rtl="0" eaLnBrk="1" latinLnBrk="0" hangingPunct="1">
+              <a:lnSpc>
+                <a:spcPct val="90000"/>
+              </a:lnSpc>
+              <a:spcBef>
+                <a:spcPts val="500"/>
+              </a:spcBef>
+              <a:buFont typeface="Arial" panose="020B0604020202090204" pitchFamily="34" charset="0"/>
+              <a:buNone/>
+              <a:defRPr sz="1600" kern="1200">
+                <a:solidFill>
+                  <a:schemeClr val="tx1"/>
+                </a:solidFill>
+                <a:latin typeface="+mn-lt"/>
+                <a:ea typeface="+mn-ea"/>
+                <a:cs typeface="+mn-cs"/>
+              </a:defRPr>
+            </a:lvl8pPr>
+            <a:lvl9pPr marL="3657600" indent="0" algn="ctr" defTabSz="914400" rtl="0" eaLnBrk="1" latinLnBrk="0" hangingPunct="1">
+              <a:lnSpc>
+                <a:spcPct val="90000"/>
+              </a:lnSpc>
+              <a:spcBef>
+                <a:spcPts val="500"/>
+              </a:spcBef>
+              <a:buFont typeface="Arial" panose="020B0604020202090204" pitchFamily="34" charset="0"/>
+              <a:buNone/>
+              <a:defRPr sz="1600" kern="1200">
+                <a:solidFill>
+                  <a:schemeClr val="tx1"/>
+                </a:solidFill>
+                <a:latin typeface="+mn-lt"/>
+                <a:ea typeface="+mn-ea"/>
+                <a:cs typeface="+mn-cs"/>
+              </a:defRPr>
+            </a:lvl9pPr>
+          </a:lstStyle>
+          <a:p>
+            <a:r>
+              <a:rPr lang="en-US" altLang="zh-CN" sz="1800" dirty="0" err="1">
+                <a:latin typeface="Times New Roman" panose="02020503050405090304" charset="0"/>
+                <a:cs typeface="Times New Roman" panose="02020503050405090304" charset="0"/>
+              </a:rPr>
+              <a:t>Ruixin</a:t>
+            </a:r>
+            <a:r>
+              <a:rPr lang="zh-CN" altLang="en-US" sz="1800" dirty="0">
+                <a:latin typeface="Times New Roman" panose="02020503050405090304" charset="0"/>
+                <a:cs typeface="Times New Roman" panose="02020503050405090304" charset="0"/>
+              </a:rPr>
+              <a:t> </a:t>
+            </a:r>
+            <a:r>
+              <a:rPr lang="en-US" altLang="zh-CN" sz="1800" dirty="0">
+                <a:latin typeface="Times New Roman" panose="02020503050405090304" charset="0"/>
+                <a:cs typeface="Times New Roman" panose="02020503050405090304" charset="0"/>
+              </a:rPr>
+              <a:t>Peng</a:t>
+            </a:r>
+            <a:endParaRPr lang="en-US" altLang="zh-CN" sz="1800" dirty="0">
+              <a:latin typeface="Times New Roman" panose="02020503050405090304" charset="0"/>
+              <a:cs typeface="Times New Roman" panose="02020503050405090304" charset="0"/>
+            </a:endParaRPr>
+          </a:p>
+          <a:p>
+            <a:r>
+              <a:rPr lang="en-US" altLang="en-GB" sz="1800" dirty="0">
+                <a:latin typeface="Times New Roman" panose="02020503050405090304" charset="0"/>
+                <a:cs typeface="Times New Roman" panose="02020503050405090304" charset="0"/>
+              </a:rPr>
+              <a:t>June 18</a:t>
+            </a:r>
+            <a:r>
+              <a:rPr lang="en-GB" altLang="zh-CN" sz="1800" dirty="0">
+                <a:latin typeface="Times New Roman" panose="02020503050405090304" charset="0"/>
+                <a:cs typeface="Times New Roman" panose="02020503050405090304" charset="0"/>
+              </a:rPr>
+              <a:t>, 2026</a:t>
+            </a:r>
+            <a:endParaRPr lang="en-GB" altLang="zh-CN" sz="1800" dirty="0">
+              <a:latin typeface="Times New Roman" panose="02020503050405090304" charset="0"/>
+              <a:cs typeface="Times New Roman" panose="02020503050405090304" charset="0"/>
+            </a:endParaRPr>
           </a:p>
         </p:txBody>
       </p:sp>
     </p:spTree>
-    <p:custDataLst>
-      <p:tags r:id="rId3"/>
-    </p:custDataLst>
   </p:cSld>
   <p:clrMapOvr>
     <a:masterClrMapping/>
@@ -3676,86 +4072,118 @@
           <a:chExt cx="0" cy="0"/>
         </a:xfrm>
       </p:grpSpPr>
-      <p:sp>
-        <p:nvSpPr>
-          <p:cNvPr id="2" name="标题 1"/>
-          <p:cNvSpPr>
-            <a:spLocks noGrp="1"/>
-          </p:cNvSpPr>
-          <p:nvPr>
-            <p:ph type="ctrTitle"/>
-            <p:custDataLst>
-              <p:tags r:id="rId1"/>
-            </p:custDataLst>
-          </p:nvPr>
-        </p:nvSpPr>
-        <p:spPr/>
-        <p:txBody>
-          <a:bodyPr/>
-          <a:p>
-            <a:endParaRPr lang="zh-CN" altLang="zh-CN"/>
-          </a:p>
-        </p:txBody>
-      </p:sp>
-      <p:sp>
-        <p:nvSpPr>
-          <p:cNvPr id="3" name="副标题 2"/>
-          <p:cNvSpPr>
-            <a:spLocks noGrp="1"/>
-          </p:cNvSpPr>
-          <p:nvPr>
-            <p:ph type="subTitle" idx="1"/>
-            <p:custDataLst>
-              <p:tags r:id="rId2"/>
-            </p:custDataLst>
-          </p:nvPr>
-        </p:nvSpPr>
-        <p:spPr/>
-        <p:txBody>
-          <a:bodyPr/>
-          <a:p>
-            <a:endParaRPr lang="zh-CN" altLang="en-US"/>
-          </a:p>
-        </p:txBody>
-      </p:sp>
-    </p:spTree>
-    <p:custDataLst>
-      <p:tags r:id="rId3"/>
-    </p:custDataLst>
-  </p:cSld>
-  <p:clrMapOvr>
-    <a:masterClrMapping/>
-  </p:clrMapOvr>
-</p:sld>
-</file>
-
-<file path=ppt/slides/slide11.xml><?xml version="1.0" encoding="utf-8"?>
-<p:sld xmlns:a="http://schemas.openxmlformats.org/drawingml/2006/main" xmlns:r="http://schemas.openxmlformats.org/officeDocument/2006/relationships" xmlns:p="http://schemas.openxmlformats.org/presentationml/2006/main">
-  <p:cSld>
-    <p:spTree>
-      <p:nvGrpSpPr>
-        <p:cNvPr id="1" name=""/>
-        <p:cNvGrpSpPr/>
-        <p:nvPr/>
-      </p:nvGrpSpPr>
-      <p:grpSpPr>
-        <a:xfrm>
-          <a:off x="0" y="0"/>
-          <a:ext cx="0" cy="0"/>
-          <a:chOff x="0" y="0"/>
-          <a:chExt cx="0" cy="0"/>
-        </a:xfrm>
-      </p:grpSpPr>
-      <p:sp>
-        <p:nvSpPr>
-          <p:cNvPr id="9" name="文本框 8"/>
+      <p:pic>
+        <p:nvPicPr>
+          <p:cNvPr id="4" name="图片 3"/>
+          <p:cNvPicPr>
+            <a:picLocks noChangeAspect="1"/>
+          </p:cNvPicPr>
+          <p:nvPr/>
+        </p:nvPicPr>
+        <p:blipFill>
+          <a:blip r:embed="rId1"/>
+          <a:stretch>
+            <a:fillRect/>
+          </a:stretch>
+        </p:blipFill>
+        <p:spPr>
+          <a:xfrm>
+            <a:off x="115570" y="908685"/>
+            <a:ext cx="6553200" cy="5619750"/>
+          </a:xfrm>
+          <a:prstGeom prst="rect">
+            <a:avLst/>
+          </a:prstGeom>
+        </p:spPr>
+      </p:pic>
+      <p:sp>
+        <p:nvSpPr>
+          <p:cNvPr id="5" name="文本框 4"/>
           <p:cNvSpPr txBox="1"/>
           <p:nvPr/>
         </p:nvSpPr>
         <p:spPr>
           <a:xfrm>
-            <a:off x="636905" y="2498090"/>
-            <a:ext cx="6096000" cy="1476375"/>
+            <a:off x="6989445" y="2338387"/>
+            <a:ext cx="5080000" cy="922020"/>
+          </a:xfrm>
+          <a:prstGeom prst="rect">
+            <a:avLst/>
+          </a:prstGeom>
+        </p:spPr>
+        <p:txBody>
+          <a:bodyPr>
+            <a:spAutoFit/>
+          </a:bodyPr>
+          <a:p>
+            <a:pPr marL="0" indent="0"/>
+            <a:r>
+              <a:rPr lang="en-US" altLang="zh-CN" b="0" i="0">
+                <a:latin typeface="Times New Roman" panose="02020503050405090304" charset="0"/>
+                <a:ea typeface="Menlo" panose="020B0609030804020204"/>
+                <a:cs typeface="Times New Roman" panose="02020503050405090304" charset="0"/>
+              </a:rPr>
+              <a:t>kw_old_hat: -1.000 ± 0.045 (true -1.000) </a:t>
+            </a:r>
+            <a:endParaRPr lang="en-US" altLang="zh-CN" b="0" i="0">
+              <a:latin typeface="Times New Roman" panose="02020503050405090304" charset="0"/>
+              <a:ea typeface="Menlo" panose="020B0609030804020204"/>
+              <a:cs typeface="Times New Roman" panose="02020503050405090304" charset="0"/>
+            </a:endParaRPr>
+          </a:p>
+          <a:p>
+            <a:pPr marL="0" indent="0"/>
+            <a:endParaRPr lang="en-US" altLang="zh-CN" b="0" i="0">
+              <a:latin typeface="Times New Roman" panose="02020503050405090304" charset="0"/>
+              <a:ea typeface="Menlo" panose="020B0609030804020204"/>
+              <a:cs typeface="Times New Roman" panose="02020503050405090304" charset="0"/>
+            </a:endParaRPr>
+          </a:p>
+          <a:p>
+            <a:pPr marL="0" indent="0"/>
+            <a:r>
+              <a:rPr lang="en-US" altLang="zh-CN" b="0" i="0">
+                <a:latin typeface="Times New Roman" panose="02020503050405090304" charset="0"/>
+                <a:ea typeface="Menlo" panose="020B0609030804020204"/>
+                <a:cs typeface="Times New Roman" panose="02020503050405090304" charset="0"/>
+              </a:rPr>
+              <a:t>kw_new_hat: -0.054 ± 0.009 </a:t>
+            </a:r>
+            <a:r>
+              <a:rPr lang="en-US" altLang="zh-CN">
+                <a:latin typeface="Times New Roman" panose="02020503050405090304" charset="0"/>
+                <a:ea typeface="Menlo" panose="020B0609030804020204"/>
+                <a:cs typeface="Times New Roman" panose="02020503050405090304" charset="0"/>
+                <a:sym typeface="+mn-ea"/>
+              </a:rPr>
+              <a:t>(std low)</a:t>
+            </a:r>
+            <a:r>
+              <a:rPr lang="en-US" altLang="zh-CN" b="0" i="0">
+                <a:latin typeface="Times New Roman" panose="02020503050405090304" charset="0"/>
+                <a:ea typeface="Menlo" panose="020B0609030804020204"/>
+                <a:cs typeface="Times New Roman" panose="02020503050405090304" charset="0"/>
+              </a:rPr>
+              <a:t> (true -0.050)</a:t>
+            </a:r>
+            <a:endParaRPr lang="en-US" altLang="zh-CN" b="0" i="0">
+              <a:latin typeface="Times New Roman" panose="02020503050405090304" charset="0"/>
+              <a:ea typeface="Menlo" panose="020B0609030804020204"/>
+              <a:cs typeface="Times New Roman" panose="02020503050405090304" charset="0"/>
+            </a:endParaRPr>
+          </a:p>
+        </p:txBody>
+      </p:sp>
+      <p:sp>
+        <p:nvSpPr>
+          <p:cNvPr id="7" name="文本框 6"/>
+          <p:cNvSpPr txBox="1"/>
+          <p:nvPr/>
+        </p:nvSpPr>
+        <p:spPr>
+          <a:xfrm>
+            <a:off x="6808470" y="4777740"/>
+            <a:ext cx="5261610" cy="922020"/>
           </a:xfrm>
           <a:prstGeom prst="rect">
             <a:avLst/>
@@ -3768,30 +4196,29 @@
           </a:bodyPr>
           <a:p>
             <a:r>
-              <a:rPr lang="en-US" altLang="zh-CN"/>
-              <a:t>During inversion, monitoring points can be weighted according to wall sensitivity. </a:t>
-            </a:r>
-            <a:endParaRPr lang="en-US" altLang="zh-CN"/>
-          </a:p>
-          <a:p>
-            <a:r>
-              <a:rPr lang="en-US" altLang="zh-CN"/>
-              <a:t>Points that are too close to the tank or dominated by bulk (such as Node 20) are not suitable, otherwise during kw calibration, they will be driven by kb/tank.</a:t>
-            </a:r>
-            <a:endParaRPr lang="zh-CN" altLang="en-US"/>
-          </a:p>
-        </p:txBody>
-      </p:sp>
-      <p:sp>
-        <p:nvSpPr>
-          <p:cNvPr id="10" name="文本框 9"/>
+              <a:rPr lang="en-US" altLang="zh-CN">
+                <a:latin typeface="Times New Roman" panose="02020503050405090304" charset="0"/>
+                <a:cs typeface="Times New Roman" panose="02020503050405090304" charset="0"/>
+              </a:rPr>
+              <a:t>The old pipe area is relatively localized and primarily affects node 15, so the information sources for kw_old are limited.</a:t>
+            </a:r>
+            <a:endParaRPr lang="en-US" altLang="zh-CN">
+              <a:latin typeface="Times New Roman" panose="02020503050405090304" charset="0"/>
+              <a:cs typeface="Times New Roman" panose="02020503050405090304" charset="0"/>
+            </a:endParaRPr>
+          </a:p>
+        </p:txBody>
+      </p:sp>
+      <p:sp>
+        <p:nvSpPr>
+          <p:cNvPr id="8" name="文本框 7"/>
           <p:cNvSpPr txBox="1"/>
           <p:nvPr/>
         </p:nvSpPr>
         <p:spPr>
           <a:xfrm>
-            <a:off x="636905" y="4695825"/>
-            <a:ext cx="6096000" cy="1198880"/>
+            <a:off x="6814185" y="5699760"/>
+            <a:ext cx="5377815" cy="645160"/>
           </a:xfrm>
           <a:prstGeom prst="rect">
             <a:avLst/>
@@ -3804,436 +4231,69 @@
           </a:bodyPr>
           <a:p>
             <a:r>
-              <a:rPr lang="en-US" altLang="zh-CN"/>
-              <a:t>Last week, there was a mistake: the node with the lowest average residual chlorine in node20 is not the point most sensitive to kw. It is greatly influenced by tank. The main source of change is kb.</a:t>
-            </a:r>
-            <a:endParaRPr lang="en-US" altLang="zh-CN"/>
+              <a:rPr lang="en-US" altLang="zh-CN">
+                <a:latin typeface="Times New Roman" panose="02020503050405090304" charset="0"/>
+                <a:cs typeface="Times New Roman" panose="02020503050405090304" charset="0"/>
+              </a:rPr>
+              <a:t>There are a large number of new pipes, affecting the entire network.</a:t>
+            </a:r>
+            <a:endParaRPr lang="en-US" altLang="zh-CN">
+              <a:latin typeface="Times New Roman" panose="02020503050405090304" charset="0"/>
+              <a:cs typeface="Times New Roman" panose="02020503050405090304" charset="0"/>
+            </a:endParaRPr>
+          </a:p>
+        </p:txBody>
+      </p:sp>
+      <p:sp>
+        <p:nvSpPr>
+          <p:cNvPr id="9" name="文本框 8"/>
+          <p:cNvSpPr txBox="1"/>
+          <p:nvPr/>
+        </p:nvSpPr>
+        <p:spPr>
+          <a:xfrm>
+            <a:off x="115570" y="175895"/>
+            <a:ext cx="7833360" cy="644525"/>
+          </a:xfrm>
+          <a:prstGeom prst="rect">
+            <a:avLst/>
+          </a:prstGeom>
+        </p:spPr>
+        <p:txBody>
+          <a:bodyPr wrap="square">
+            <a:noAutofit/>
+          </a:bodyPr>
+          <a:p>
+            <a:pPr>
+              <a:lnSpc>
+                <a:spcPts val="1800"/>
+              </a:lnSpc>
+            </a:pPr>
+            <a:r>
+              <a:rPr lang="en-US" altLang="zh-CN" sz="3200" b="1">
+                <a:solidFill>
+                  <a:schemeClr val="tx1"/>
+                </a:solidFill>
+                <a:latin typeface="Times New Roman" panose="02020503050405090304" charset="0"/>
+                <a:ea typeface="Menlo" panose="020B0609030804020204"/>
+                <a:cs typeface="Times New Roman" panose="02020503050405090304" charset="0"/>
+              </a:rPr>
+              <a:t>Forward → Noise → Inverse → Recover</a:t>
+            </a:r>
+            <a:endParaRPr lang="en-US" altLang="zh-CN" sz="3200" b="1">
+              <a:solidFill>
+                <a:schemeClr val="tx1"/>
+              </a:solidFill>
+              <a:latin typeface="Times New Roman" panose="02020503050405090304" charset="0"/>
+              <a:ea typeface="Menlo" panose="020B0609030804020204"/>
+              <a:cs typeface="Times New Roman" panose="02020503050405090304" charset="0"/>
+            </a:endParaRPr>
           </a:p>
         </p:txBody>
       </p:sp>
     </p:spTree>
     <p:custDataLst>
-      <p:tags r:id="rId1"/>
-    </p:custDataLst>
-  </p:cSld>
-  <p:clrMapOvr>
-    <a:masterClrMapping/>
-  </p:clrMapOvr>
-</p:sld>
-</file>
-
-<file path=ppt/slides/slide12.xml><?xml version="1.0" encoding="utf-8"?>
-<p:sld xmlns:a="http://schemas.openxmlformats.org/drawingml/2006/main" xmlns:r="http://schemas.openxmlformats.org/officeDocument/2006/relationships" xmlns:p="http://schemas.openxmlformats.org/presentationml/2006/main">
-  <p:cSld>
-    <p:spTree>
-      <p:nvGrpSpPr>
-        <p:cNvPr id="1" name=""/>
-        <p:cNvGrpSpPr/>
-        <p:nvPr/>
-      </p:nvGrpSpPr>
-      <p:grpSpPr>
-        <a:xfrm>
-          <a:off x="0" y="0"/>
-          <a:ext cx="0" cy="0"/>
-          <a:chOff x="0" y="0"/>
-          <a:chExt cx="0" cy="0"/>
-        </a:xfrm>
-      </p:grpSpPr>
-      <p:sp>
-        <p:nvSpPr>
-          <p:cNvPr id="2" name="标题 1"/>
-          <p:cNvSpPr>
-            <a:spLocks noGrp="1"/>
-          </p:cNvSpPr>
-          <p:nvPr>
-            <p:ph type="ctrTitle"/>
-            <p:custDataLst>
-              <p:tags r:id="rId1"/>
-            </p:custDataLst>
-          </p:nvPr>
-        </p:nvSpPr>
-        <p:spPr/>
-        <p:txBody>
-          <a:bodyPr/>
-          <a:p>
-            <a:endParaRPr lang="zh-CN" altLang="zh-CN"/>
-          </a:p>
-        </p:txBody>
-      </p:sp>
-      <p:sp>
-        <p:nvSpPr>
-          <p:cNvPr id="3" name="副标题 2"/>
-          <p:cNvSpPr>
-            <a:spLocks noGrp="1"/>
-          </p:cNvSpPr>
-          <p:nvPr>
-            <p:ph type="subTitle" idx="1"/>
-            <p:custDataLst>
-              <p:tags r:id="rId2"/>
-            </p:custDataLst>
-          </p:nvPr>
-        </p:nvSpPr>
-        <p:spPr/>
-        <p:txBody>
-          <a:bodyPr/>
-          <a:p>
-            <a:endParaRPr lang="zh-CN" altLang="en-US"/>
-          </a:p>
-        </p:txBody>
-      </p:sp>
-    </p:spTree>
-    <p:custDataLst>
-      <p:tags r:id="rId3"/>
-    </p:custDataLst>
-  </p:cSld>
-  <p:clrMapOvr>
-    <a:masterClrMapping/>
-  </p:clrMapOvr>
-</p:sld>
-</file>
-
-<file path=ppt/slides/slide13.xml><?xml version="1.0" encoding="utf-8"?>
-<p:sld xmlns:a="http://schemas.openxmlformats.org/drawingml/2006/main" xmlns:r="http://schemas.openxmlformats.org/officeDocument/2006/relationships" xmlns:p="http://schemas.openxmlformats.org/presentationml/2006/main">
-  <p:cSld>
-    <p:spTree>
-      <p:nvGrpSpPr>
-        <p:cNvPr id="1" name=""/>
-        <p:cNvGrpSpPr/>
-        <p:nvPr/>
-      </p:nvGrpSpPr>
-      <p:grpSpPr>
-        <a:xfrm>
-          <a:off x="0" y="0"/>
-          <a:ext cx="0" cy="0"/>
-          <a:chOff x="0" y="0"/>
-          <a:chExt cx="0" cy="0"/>
-        </a:xfrm>
-      </p:grpSpPr>
-      <p:sp>
-        <p:nvSpPr>
-          <p:cNvPr id="2" name="标题 1"/>
-          <p:cNvSpPr>
-            <a:spLocks noGrp="1"/>
-          </p:cNvSpPr>
-          <p:nvPr>
-            <p:ph type="ctrTitle"/>
-            <p:custDataLst>
-              <p:tags r:id="rId1"/>
-            </p:custDataLst>
-          </p:nvPr>
-        </p:nvSpPr>
-        <p:spPr/>
-        <p:txBody>
-          <a:bodyPr/>
-          <a:p>
-            <a:endParaRPr lang="zh-CN" altLang="zh-CN"/>
-          </a:p>
-        </p:txBody>
-      </p:sp>
-      <p:sp>
-        <p:nvSpPr>
-          <p:cNvPr id="3" name="副标题 2"/>
-          <p:cNvSpPr>
-            <a:spLocks noGrp="1"/>
-          </p:cNvSpPr>
-          <p:nvPr>
-            <p:ph type="subTitle" idx="1"/>
-            <p:custDataLst>
-              <p:tags r:id="rId2"/>
-            </p:custDataLst>
-          </p:nvPr>
-        </p:nvSpPr>
-        <p:spPr/>
-        <p:txBody>
-          <a:bodyPr/>
-          <a:p>
-            <a:endParaRPr lang="zh-CN" altLang="en-US"/>
-          </a:p>
-        </p:txBody>
-      </p:sp>
-    </p:spTree>
-    <p:custDataLst>
-      <p:tags r:id="rId3"/>
-    </p:custDataLst>
-  </p:cSld>
-  <p:clrMapOvr>
-    <a:masterClrMapping/>
-  </p:clrMapOvr>
-</p:sld>
-</file>
-
-<file path=ppt/slides/slide14.xml><?xml version="1.0" encoding="utf-8"?>
-<p:sld xmlns:a="http://schemas.openxmlformats.org/drawingml/2006/main" xmlns:r="http://schemas.openxmlformats.org/officeDocument/2006/relationships" xmlns:p="http://schemas.openxmlformats.org/presentationml/2006/main">
-  <p:cSld>
-    <p:spTree>
-      <p:nvGrpSpPr>
-        <p:cNvPr id="1" name=""/>
-        <p:cNvGrpSpPr/>
-        <p:nvPr/>
-      </p:nvGrpSpPr>
-      <p:grpSpPr>
-        <a:xfrm>
-          <a:off x="0" y="0"/>
-          <a:ext cx="0" cy="0"/>
-          <a:chOff x="0" y="0"/>
-          <a:chExt cx="0" cy="0"/>
-        </a:xfrm>
-      </p:grpSpPr>
-      <p:sp>
-        <p:nvSpPr>
-          <p:cNvPr id="2" name="标题 1"/>
-          <p:cNvSpPr>
-            <a:spLocks noGrp="1"/>
-          </p:cNvSpPr>
-          <p:nvPr>
-            <p:ph type="ctrTitle"/>
-            <p:custDataLst>
-              <p:tags r:id="rId1"/>
-            </p:custDataLst>
-          </p:nvPr>
-        </p:nvSpPr>
-        <p:spPr/>
-        <p:txBody>
-          <a:bodyPr/>
-          <a:p>
-            <a:endParaRPr lang="zh-CN" altLang="zh-CN"/>
-          </a:p>
-        </p:txBody>
-      </p:sp>
-      <p:sp>
-        <p:nvSpPr>
-          <p:cNvPr id="3" name="副标题 2"/>
-          <p:cNvSpPr>
-            <a:spLocks noGrp="1"/>
-          </p:cNvSpPr>
-          <p:nvPr>
-            <p:ph type="subTitle" idx="1"/>
-            <p:custDataLst>
-              <p:tags r:id="rId2"/>
-            </p:custDataLst>
-          </p:nvPr>
-        </p:nvSpPr>
-        <p:spPr/>
-        <p:txBody>
-          <a:bodyPr/>
-          <a:p>
-            <a:endParaRPr lang="zh-CN" altLang="en-US"/>
-          </a:p>
-        </p:txBody>
-      </p:sp>
-    </p:spTree>
-    <p:custDataLst>
-      <p:tags r:id="rId3"/>
-    </p:custDataLst>
-  </p:cSld>
-  <p:clrMapOvr>
-    <a:masterClrMapping/>
-  </p:clrMapOvr>
-</p:sld>
-</file>
-
-<file path=ppt/slides/slide15.xml><?xml version="1.0" encoding="utf-8"?>
-<p:sld xmlns:a="http://schemas.openxmlformats.org/drawingml/2006/main" xmlns:r="http://schemas.openxmlformats.org/officeDocument/2006/relationships" xmlns:p="http://schemas.openxmlformats.org/presentationml/2006/main">
-  <p:cSld>
-    <p:spTree>
-      <p:nvGrpSpPr>
-        <p:cNvPr id="1" name=""/>
-        <p:cNvGrpSpPr/>
-        <p:nvPr/>
-      </p:nvGrpSpPr>
-      <p:grpSpPr>
-        <a:xfrm>
-          <a:off x="0" y="0"/>
-          <a:ext cx="0" cy="0"/>
-          <a:chOff x="0" y="0"/>
-          <a:chExt cx="0" cy="0"/>
-        </a:xfrm>
-      </p:grpSpPr>
-      <p:sp>
-        <p:nvSpPr>
-          <p:cNvPr id="2" name="标题 1"/>
-          <p:cNvSpPr>
-            <a:spLocks noGrp="1"/>
-          </p:cNvSpPr>
-          <p:nvPr>
-            <p:ph type="ctrTitle"/>
-            <p:custDataLst>
-              <p:tags r:id="rId1"/>
-            </p:custDataLst>
-          </p:nvPr>
-        </p:nvSpPr>
-        <p:spPr/>
-        <p:txBody>
-          <a:bodyPr/>
-          <a:p>
-            <a:endParaRPr lang="zh-CN" altLang="zh-CN"/>
-          </a:p>
-        </p:txBody>
-      </p:sp>
-      <p:sp>
-        <p:nvSpPr>
-          <p:cNvPr id="3" name="副标题 2"/>
-          <p:cNvSpPr>
-            <a:spLocks noGrp="1"/>
-          </p:cNvSpPr>
-          <p:nvPr>
-            <p:ph type="subTitle" idx="1"/>
-            <p:custDataLst>
-              <p:tags r:id="rId2"/>
-            </p:custDataLst>
-          </p:nvPr>
-        </p:nvSpPr>
-        <p:spPr/>
-        <p:txBody>
-          <a:bodyPr/>
-          <a:p>
-            <a:endParaRPr lang="zh-CN" altLang="en-US"/>
-          </a:p>
-        </p:txBody>
-      </p:sp>
-    </p:spTree>
-    <p:custDataLst>
-      <p:tags r:id="rId3"/>
-    </p:custDataLst>
-  </p:cSld>
-  <p:clrMapOvr>
-    <a:masterClrMapping/>
-  </p:clrMapOvr>
-</p:sld>
-</file>
-
-<file path=ppt/slides/slide16.xml><?xml version="1.0" encoding="utf-8"?>
-<p:sld xmlns:a="http://schemas.openxmlformats.org/drawingml/2006/main" xmlns:r="http://schemas.openxmlformats.org/officeDocument/2006/relationships" xmlns:p="http://schemas.openxmlformats.org/presentationml/2006/main">
-  <p:cSld>
-    <p:spTree>
-      <p:nvGrpSpPr>
-        <p:cNvPr id="1" name=""/>
-        <p:cNvGrpSpPr/>
-        <p:nvPr/>
-      </p:nvGrpSpPr>
-      <p:grpSpPr>
-        <a:xfrm>
-          <a:off x="0" y="0"/>
-          <a:ext cx="0" cy="0"/>
-          <a:chOff x="0" y="0"/>
-          <a:chExt cx="0" cy="0"/>
-        </a:xfrm>
-      </p:grpSpPr>
-      <p:sp>
-        <p:nvSpPr>
-          <p:cNvPr id="2" name="标题 1"/>
-          <p:cNvSpPr>
-            <a:spLocks noGrp="1"/>
-          </p:cNvSpPr>
-          <p:nvPr>
-            <p:ph type="ctrTitle"/>
-            <p:custDataLst>
-              <p:tags r:id="rId1"/>
-            </p:custDataLst>
-          </p:nvPr>
-        </p:nvSpPr>
-        <p:spPr/>
-        <p:txBody>
-          <a:bodyPr/>
-          <a:p>
-            <a:endParaRPr lang="zh-CN" altLang="zh-CN"/>
-          </a:p>
-        </p:txBody>
-      </p:sp>
-      <p:sp>
-        <p:nvSpPr>
-          <p:cNvPr id="3" name="副标题 2"/>
-          <p:cNvSpPr>
-            <a:spLocks noGrp="1"/>
-          </p:cNvSpPr>
-          <p:nvPr>
-            <p:ph type="subTitle" idx="1"/>
-            <p:custDataLst>
-              <p:tags r:id="rId2"/>
-            </p:custDataLst>
-          </p:nvPr>
-        </p:nvSpPr>
-        <p:spPr/>
-        <p:txBody>
-          <a:bodyPr/>
-          <a:p>
-            <a:endParaRPr lang="zh-CN" altLang="en-US"/>
-          </a:p>
-        </p:txBody>
-      </p:sp>
-    </p:spTree>
-    <p:custDataLst>
-      <p:tags r:id="rId3"/>
-    </p:custDataLst>
-  </p:cSld>
-  <p:clrMapOvr>
-    <a:masterClrMapping/>
-  </p:clrMapOvr>
-</p:sld>
-</file>
-
-<file path=ppt/slides/slide17.xml><?xml version="1.0" encoding="utf-8"?>
-<p:sld xmlns:a="http://schemas.openxmlformats.org/drawingml/2006/main" xmlns:r="http://schemas.openxmlformats.org/officeDocument/2006/relationships" xmlns:p="http://schemas.openxmlformats.org/presentationml/2006/main">
-  <p:cSld>
-    <p:spTree>
-      <p:nvGrpSpPr>
-        <p:cNvPr id="1" name=""/>
-        <p:cNvGrpSpPr/>
-        <p:nvPr/>
-      </p:nvGrpSpPr>
-      <p:grpSpPr>
-        <a:xfrm>
-          <a:off x="0" y="0"/>
-          <a:ext cx="0" cy="0"/>
-          <a:chOff x="0" y="0"/>
-          <a:chExt cx="0" cy="0"/>
-        </a:xfrm>
-      </p:grpSpPr>
-      <p:sp>
-        <p:nvSpPr>
-          <p:cNvPr id="2" name="标题 1"/>
-          <p:cNvSpPr>
-            <a:spLocks noGrp="1"/>
-          </p:cNvSpPr>
-          <p:nvPr>
-            <p:ph type="ctrTitle"/>
-            <p:custDataLst>
-              <p:tags r:id="rId1"/>
-            </p:custDataLst>
-          </p:nvPr>
-        </p:nvSpPr>
-        <p:spPr/>
-        <p:txBody>
-          <a:bodyPr/>
-          <a:p>
-            <a:endParaRPr lang="zh-CN" altLang="zh-CN"/>
-          </a:p>
-        </p:txBody>
-      </p:sp>
-      <p:sp>
-        <p:nvSpPr>
-          <p:cNvPr id="3" name="副标题 2"/>
-          <p:cNvSpPr>
-            <a:spLocks noGrp="1"/>
-          </p:cNvSpPr>
-          <p:nvPr>
-            <p:ph type="subTitle" idx="1"/>
-            <p:custDataLst>
-              <p:tags r:id="rId2"/>
-            </p:custDataLst>
-          </p:nvPr>
-        </p:nvSpPr>
-        <p:spPr/>
-        <p:txBody>
-          <a:bodyPr/>
-          <a:p>
-            <a:endParaRPr lang="zh-CN" altLang="en-US"/>
-          </a:p>
-        </p:txBody>
-      </p:sp>
-    </p:spTree>
-    <p:custDataLst>
-      <p:tags r:id="rId3"/>
+      <p:tags r:id="rId2"/>
     </p:custDataLst>
   </p:cSld>
   <p:clrMapOvr>
@@ -4269,14 +4329,15 @@
         </p:nvPicPr>
         <p:blipFill>
           <a:blip r:embed="rId1"/>
+          <a:srcRect l="6975" b="7230"/>
           <a:stretch>
             <a:fillRect/>
           </a:stretch>
         </p:blipFill>
         <p:spPr>
           <a:xfrm>
-            <a:off x="440055" y="319405"/>
-            <a:ext cx="5479415" cy="4966970"/>
+            <a:off x="204470" y="83820"/>
+            <a:ext cx="5041900" cy="4558030"/>
           </a:xfrm>
           <a:prstGeom prst="rect">
             <a:avLst/>
@@ -4293,23 +4354,101 @@
         </p:nvPicPr>
         <p:blipFill>
           <a:blip r:embed="rId2"/>
+          <a:srcRect l="6254" b="8127"/>
           <a:stretch>
             <a:fillRect/>
           </a:stretch>
         </p:blipFill>
         <p:spPr>
           <a:xfrm>
-            <a:off x="6365875" y="575945"/>
-            <a:ext cx="5443220" cy="4453890"/>
+            <a:off x="6096000" y="319405"/>
+            <a:ext cx="5406390" cy="4335780"/>
           </a:xfrm>
           <a:prstGeom prst="rect">
             <a:avLst/>
           </a:prstGeom>
         </p:spPr>
       </p:pic>
+      <p:sp>
+        <p:nvSpPr>
+          <p:cNvPr id="7" name="文本框 6"/>
+          <p:cNvSpPr txBox="1"/>
+          <p:nvPr/>
+        </p:nvSpPr>
+        <p:spPr>
+          <a:xfrm>
+            <a:off x="5610860" y="5087620"/>
+            <a:ext cx="6377305" cy="922020"/>
+          </a:xfrm>
+          <a:prstGeom prst="rect">
+            <a:avLst/>
+          </a:prstGeom>
+          <a:noFill/>
+        </p:spPr>
+        <p:txBody>
+          <a:bodyPr wrap="square" rtlCol="0" anchor="t">
+            <a:spAutoFit/>
+          </a:bodyPr>
+          <a:p>
+            <a:r>
+              <a:rPr lang="en-US" altLang="zh-CN">
+                <a:latin typeface="Times New Roman" panose="02020503050405090304" charset="0"/>
+                <a:cs typeface="Times New Roman" panose="02020503050405090304" charset="0"/>
+                <a:sym typeface="+mn-ea"/>
+              </a:rPr>
+              <a:t>Last week, there was a mistake: node 20 has the lowest mean chlorine mainly because of its long water age (residence time), so it is dominated by </a:t>
+            </a:r>
+            <a:r>
+              <a:rPr lang="en-US" altLang="zh-CN" b="1">
+                <a:latin typeface="Times New Roman" panose="02020503050405090304" charset="0"/>
+                <a:cs typeface="Times New Roman" panose="02020503050405090304" charset="0"/>
+                <a:sym typeface="+mn-ea"/>
+              </a:rPr>
+              <a:t>bulk decay × age</a:t>
+            </a:r>
+            <a:r>
+              <a:rPr lang="en-US" altLang="zh-CN">
+                <a:latin typeface="Times New Roman" panose="02020503050405090304" charset="0"/>
+                <a:cs typeface="Times New Roman" panose="02020503050405090304" charset="0"/>
+                <a:sym typeface="+mn-ea"/>
+              </a:rPr>
+              <a:t> and is insensitive to kw.</a:t>
+            </a:r>
+            <a:endParaRPr lang="en-US" altLang="zh-CN">
+              <a:latin typeface="Times New Roman" panose="02020503050405090304" charset="0"/>
+              <a:cs typeface="Times New Roman" panose="02020503050405090304" charset="0"/>
+              <a:sym typeface="+mn-ea"/>
+            </a:endParaRPr>
+          </a:p>
+        </p:txBody>
+      </p:sp>
+      <p:pic>
+        <p:nvPicPr>
+          <p:cNvPr id="8" name="图片 7"/>
+          <p:cNvPicPr>
+            <a:picLocks noChangeAspect="1"/>
+          </p:cNvPicPr>
+          <p:nvPr/>
+        </p:nvPicPr>
+        <p:blipFill>
+          <a:blip r:embed="rId3"/>
+          <a:stretch>
+            <a:fillRect/>
+          </a:stretch>
+        </p:blipFill>
+        <p:spPr>
+          <a:xfrm>
+            <a:off x="1102995" y="4515485"/>
+            <a:ext cx="3822065" cy="2342515"/>
+          </a:xfrm>
+          <a:prstGeom prst="rect">
+            <a:avLst/>
+          </a:prstGeom>
+        </p:spPr>
+      </p:pic>
     </p:spTree>
     <p:custDataLst>
-      <p:tags r:id="rId3"/>
+      <p:tags r:id="rId4"/>
     </p:custDataLst>
   </p:cSld>
   <p:clrMapOvr>
@@ -4351,14 +4490,289 @@
         </p:blipFill>
         <p:spPr>
           <a:xfrm>
-            <a:off x="0" y="0"/>
-            <a:ext cx="5291455" cy="3848735"/>
+            <a:off x="0" y="194310"/>
+            <a:ext cx="7041515" cy="5121910"/>
           </a:xfrm>
           <a:prstGeom prst="rect">
             <a:avLst/>
           </a:prstGeom>
         </p:spPr>
       </p:pic>
+      <p:sp>
+        <p:nvSpPr>
+          <p:cNvPr id="6" name="文本框 5"/>
+          <p:cNvSpPr txBox="1"/>
+          <p:nvPr/>
+        </p:nvSpPr>
+        <p:spPr>
+          <a:xfrm>
+            <a:off x="7386955" y="681990"/>
+            <a:ext cx="4675505" cy="4030980"/>
+          </a:xfrm>
+          <a:prstGeom prst="rect">
+            <a:avLst/>
+          </a:prstGeom>
+        </p:spPr>
+        <p:txBody>
+          <a:bodyPr wrap="square">
+            <a:spAutoFit/>
+          </a:bodyPr>
+          <a:p>
+            <a:pPr marL="0" indent="0">
+              <a:spcBef>
+                <a:spcPts val="600"/>
+              </a:spcBef>
+              <a:spcAft>
+                <a:spcPts val="600"/>
+              </a:spcAft>
+            </a:pPr>
+            <a:r>
+              <a:rPr lang="en-US" altLang="zh-CN" sz="1600" b="0" i="0">
+                <a:latin typeface="Times New Roman" panose="02020503050405090304" charset="0"/>
+                <a:ea typeface="-apple-system"/>
+                <a:cs typeface="Times New Roman" panose="02020503050405090304" charset="0"/>
+              </a:rPr>
+              <a:t>Assumed </a:t>
+            </a:r>
+            <a:endParaRPr lang="en-US" altLang="zh-CN" sz="1600" b="0" i="0">
+              <a:latin typeface="Times New Roman" panose="02020503050405090304" charset="0"/>
+              <a:ea typeface="-apple-system"/>
+              <a:cs typeface="Times New Roman" panose="02020503050405090304" charset="0"/>
+            </a:endParaRPr>
+          </a:p>
+          <a:p>
+            <a:pPr marL="0" indent="0">
+              <a:spcBef>
+                <a:spcPts val="600"/>
+              </a:spcBef>
+              <a:spcAft>
+                <a:spcPts val="600"/>
+              </a:spcAft>
+            </a:pPr>
+            <a:r>
+              <a:rPr lang="en-US" altLang="zh-CN" sz="1600" b="0" i="0">
+                <a:latin typeface="Times New Roman" panose="02020503050405090304" charset="0"/>
+                <a:ea typeface="-apple-system"/>
+                <a:cs typeface="Times New Roman" panose="02020503050405090304" charset="0"/>
+              </a:rPr>
+              <a:t>Source initial chlorine = </a:t>
+            </a:r>
+            <a:r>
+              <a:rPr lang="en-US" altLang="zh-CN" sz="1600" b="1" i="0">
+                <a:latin typeface="Times New Roman" panose="02020503050405090304" charset="0"/>
+                <a:ea typeface="-apple-system"/>
+                <a:cs typeface="Times New Roman" panose="02020503050405090304" charset="0"/>
+              </a:rPr>
+              <a:t>1.0 mg/L</a:t>
+            </a:r>
+            <a:endParaRPr lang="en-US" altLang="zh-CN" sz="1600" b="0" i="0">
+              <a:latin typeface="Times New Roman" panose="02020503050405090304" charset="0"/>
+              <a:ea typeface="-apple-system"/>
+              <a:cs typeface="Times New Roman" panose="02020503050405090304" charset="0"/>
+            </a:endParaRPr>
+          </a:p>
+          <a:p>
+            <a:pPr marL="0" indent="0">
+              <a:spcBef>
+                <a:spcPts val="600"/>
+              </a:spcBef>
+              <a:spcAft>
+                <a:spcPts val="600"/>
+              </a:spcAft>
+            </a:pPr>
+            <a:r>
+              <a:rPr lang="en-US" altLang="zh-CN" sz="1600" b="0" i="0">
+                <a:latin typeface="Times New Roman" panose="02020503050405090304" charset="0"/>
+                <a:ea typeface="-apple-system"/>
+                <a:cs typeface="Times New Roman" panose="02020503050405090304" charset="0"/>
+              </a:rPr>
+              <a:t>(inlet boundary condition; original = 0)</a:t>
+            </a:r>
+            <a:endParaRPr lang="en-US" altLang="zh-CN" sz="1600" b="0" i="0">
+              <a:latin typeface="Times New Roman" panose="02020503050405090304" charset="0"/>
+              <a:ea typeface="-apple-system"/>
+              <a:cs typeface="Times New Roman" panose="02020503050405090304" charset="0"/>
+            </a:endParaRPr>
+          </a:p>
+          <a:p>
+            <a:pPr marL="0" indent="0">
+              <a:spcBef>
+                <a:spcPts val="600"/>
+              </a:spcBef>
+              <a:spcAft>
+                <a:spcPts val="600"/>
+              </a:spcAft>
+              <a:buFont typeface="Arial" panose="020B0604020202090204"/>
+              <a:buChar char="•"/>
+            </a:pPr>
+            <a:r>
+              <a:rPr lang="en-US" altLang="zh-CN" sz="1600" b="0" i="0">
+                <a:latin typeface="Times New Roman" panose="02020503050405090304" charset="0"/>
+                <a:ea typeface="-apple-system"/>
+                <a:cs typeface="Times New Roman" panose="02020503050405090304" charset="0"/>
+              </a:rPr>
+              <a:t>Tank initial chlorine = </a:t>
+            </a:r>
+            <a:r>
+              <a:rPr lang="en-US" altLang="zh-CN" sz="1600" b="0" i="0">
+                <a:highlight>
+                  <a:srgbClr val="FFFF00"/>
+                </a:highlight>
+                <a:latin typeface="Times New Roman" panose="02020503050405090304" charset="0"/>
+                <a:ea typeface="-apple-system"/>
+                <a:cs typeface="Times New Roman" panose="02020503050405090304" charset="0"/>
+              </a:rPr>
+              <a:t>0.5</a:t>
+            </a:r>
+            <a:r>
+              <a:rPr lang="en-US" altLang="zh-CN" sz="1600" b="0" i="0">
+                <a:latin typeface="Times New Roman" panose="02020503050405090304" charset="0"/>
+                <a:ea typeface="-apple-system"/>
+                <a:cs typeface="Times New Roman" panose="02020503050405090304" charset="0"/>
+              </a:rPr>
+              <a:t> (kept .inp / starter default — not set)</a:t>
+            </a:r>
+            <a:endParaRPr lang="en-US" altLang="zh-CN" sz="1600" b="0" i="0">
+              <a:latin typeface="Times New Roman" panose="02020503050405090304" charset="0"/>
+              <a:ea typeface="-apple-system"/>
+              <a:cs typeface="Times New Roman" panose="02020503050405090304" charset="0"/>
+            </a:endParaRPr>
+          </a:p>
+          <a:p>
+            <a:pPr marL="0" indent="0">
+              <a:spcBef>
+                <a:spcPts val="600"/>
+              </a:spcBef>
+              <a:spcAft>
+                <a:spcPts val="600"/>
+              </a:spcAft>
+              <a:buFont typeface="Arial" panose="020B0604020202090204"/>
+              <a:buChar char="•"/>
+            </a:pPr>
+            <a:r>
+              <a:rPr lang="en-US" altLang="zh-CN" sz="1600" b="0" i="0">
+                <a:latin typeface="Times New Roman" panose="02020503050405090304" charset="0"/>
+                <a:ea typeface="-apple-system"/>
+                <a:cs typeface="Times New Roman" panose="02020503050405090304" charset="0"/>
+              </a:rPr>
+              <a:t>kb = −0.5 /day (original = 0, no decay)</a:t>
+            </a:r>
+            <a:endParaRPr lang="en-US" altLang="zh-CN" sz="1600" b="0" i="0">
+              <a:latin typeface="Times New Roman" panose="02020503050405090304" charset="0"/>
+              <a:ea typeface="-apple-system"/>
+              <a:cs typeface="Times New Roman" panose="02020503050405090304" charset="0"/>
+            </a:endParaRPr>
+          </a:p>
+          <a:p>
+            <a:pPr marL="0" indent="0">
+              <a:spcBef>
+                <a:spcPts val="600"/>
+              </a:spcBef>
+              <a:spcAft>
+                <a:spcPts val="600"/>
+              </a:spcAft>
+              <a:buFont typeface="Arial" panose="020B0604020202090204"/>
+              <a:buChar char="•"/>
+            </a:pPr>
+            <a:r>
+              <a:rPr lang="en-US" altLang="zh-CN" sz="1600" b="0" i="0">
+                <a:latin typeface="Times New Roman" panose="02020503050405090304" charset="0"/>
+                <a:ea typeface="-apple-system"/>
+                <a:cs typeface="Times New Roman" panose="02020503050405090304" charset="0"/>
+              </a:rPr>
+              <a:t>kw_old = -1.0/</a:t>
+            </a:r>
+            <a:r>
+              <a:rPr lang="en-US" altLang="zh-CN" sz="1600" b="0" i="0">
+                <a:latin typeface="Times New Roman" panose="02020503050405090304" charset="0"/>
+                <a:ea typeface="-apple-system"/>
+                <a:cs typeface="Times New Roman" panose="02020503050405090304" charset="0"/>
+              </a:rPr>
+              <a:t>day </a:t>
+            </a:r>
+            <a:endParaRPr lang="en-US" altLang="zh-CN" sz="1600" b="0" i="0">
+              <a:latin typeface="Times New Roman" panose="02020503050405090304" charset="0"/>
+              <a:ea typeface="-apple-system"/>
+              <a:cs typeface="Times New Roman" panose="02020503050405090304" charset="0"/>
+            </a:endParaRPr>
+          </a:p>
+          <a:p>
+            <a:pPr marL="0" indent="0">
+              <a:spcBef>
+                <a:spcPts val="600"/>
+              </a:spcBef>
+              <a:spcAft>
+                <a:spcPts val="600"/>
+              </a:spcAft>
+              <a:buFont typeface="Arial" panose="020B0604020202090204"/>
+              <a:buChar char="•"/>
+            </a:pPr>
+            <a:r>
+              <a:rPr lang="en-US" altLang="zh-CN" sz="1600" b="0" i="0">
+                <a:latin typeface="Times New Roman" panose="02020503050405090304" charset="0"/>
+                <a:ea typeface="-apple-system"/>
+                <a:cs typeface="Times New Roman" panose="02020503050405090304" charset="0"/>
+              </a:rPr>
+              <a:t>kw_new =   -0.05 /day(original = 0)</a:t>
+            </a:r>
+            <a:endParaRPr lang="en-US" altLang="zh-CN" sz="1600" b="0" i="0">
+              <a:latin typeface="Times New Roman" panose="02020503050405090304" charset="0"/>
+              <a:ea typeface="-apple-system"/>
+              <a:cs typeface="Times New Roman" panose="02020503050405090304" charset="0"/>
+            </a:endParaRPr>
+          </a:p>
+          <a:p>
+            <a:pPr marL="0" indent="0">
+              <a:spcBef>
+                <a:spcPts val="600"/>
+              </a:spcBef>
+              <a:spcAft>
+                <a:spcPts val="600"/>
+              </a:spcAft>
+              <a:buFont typeface="Arial" panose="020B0604020202090204"/>
+              <a:buChar char="•"/>
+            </a:pPr>
+            <a:r>
+              <a:rPr lang="en-US" altLang="zh-CN" sz="1600" b="0" i="0">
+                <a:latin typeface="Times New Roman" panose="02020503050405090304" charset="0"/>
+                <a:ea typeface="-apple-system"/>
+                <a:cs typeface="Times New Roman" panose="02020503050405090304" charset="0"/>
+              </a:rPr>
+              <a:t>Reaction order: zero-order/ first-order</a:t>
+            </a:r>
+            <a:endParaRPr lang="en-US" altLang="zh-CN" sz="1600" b="0" i="0">
+              <a:latin typeface="Times New Roman" panose="02020503050405090304" charset="0"/>
+              <a:ea typeface="-apple-system"/>
+              <a:cs typeface="Times New Roman" panose="02020503050405090304" charset="0"/>
+            </a:endParaRPr>
+          </a:p>
+          <a:p>
+            <a:pPr marL="0" indent="0">
+              <a:spcBef>
+                <a:spcPts val="600"/>
+              </a:spcBef>
+              <a:spcAft>
+                <a:spcPts val="600"/>
+              </a:spcAft>
+              <a:buFont typeface="Arial" panose="020B0604020202090204"/>
+              <a:buChar char="•"/>
+            </a:pPr>
+            <a:r>
+              <a:rPr lang="en-US" altLang="zh-CN" sz="1600" b="0" i="0">
+                <a:latin typeface="Times New Roman" panose="02020503050405090304" charset="0"/>
+                <a:ea typeface="-apple-system"/>
+                <a:cs typeface="Times New Roman" panose="02020503050405090304" charset="0"/>
+              </a:rPr>
+              <a:t>Old-pipe grouping (contiguous DMA): no material data in Net3, fully assumed</a:t>
+            </a:r>
+            <a:endParaRPr lang="en-US" altLang="zh-CN" sz="1600" b="0" i="0">
+              <a:latin typeface="Times New Roman" panose="02020503050405090304" charset="0"/>
+              <a:ea typeface="-apple-system"/>
+              <a:cs typeface="Times New Roman" panose="02020503050405090304" charset="0"/>
+            </a:endParaRPr>
+          </a:p>
+        </p:txBody>
+      </p:sp>
     </p:spTree>
     <p:custDataLst>
       <p:tags r:id="rId2"/>
@@ -4379,14 +4793,544 @@
         <p:cNvGrpSpPr/>
         <p:nvPr/>
       </p:nvGrpSpPr>
-      <p:grpSpPr>
-        <a:xfrm>
-          <a:off x="0" y="0"/>
-          <a:ext cx="0" cy="0"/>
-          <a:chOff x="0" y="0"/>
-          <a:chExt cx="0" cy="0"/>
-        </a:xfrm>
-      </p:grpSpPr>
+      <p:grpSpPr/>
+      <p:pic>
+        <p:nvPicPr>
+          <p:cNvPr id="5" name="图片 4"/>
+          <p:cNvPicPr>
+            <a:picLocks noChangeAspect="1"/>
+          </p:cNvPicPr>
+          <p:nvPr/>
+        </p:nvPicPr>
+        <p:blipFill>
+          <a:blip r:embed="rId1"/>
+          <a:stretch>
+            <a:fillRect/>
+          </a:stretch>
+        </p:blipFill>
+        <p:spPr>
+          <a:xfrm>
+            <a:off x="242570" y="2533650"/>
+            <a:ext cx="8893810" cy="3380740"/>
+          </a:xfrm>
+          <a:prstGeom prst="rect">
+            <a:avLst/>
+          </a:prstGeom>
+        </p:spPr>
+      </p:pic>
+      <p:sp>
+        <p:nvSpPr>
+          <p:cNvPr id="6" name="文本框 5"/>
+          <p:cNvSpPr txBox="1"/>
+          <p:nvPr/>
+        </p:nvSpPr>
+        <p:spPr>
+          <a:xfrm>
+            <a:off x="101600" y="260985"/>
+            <a:ext cx="5608320" cy="583565"/>
+          </a:xfrm>
+          <a:prstGeom prst="rect">
+            <a:avLst/>
+          </a:prstGeom>
+          <a:noFill/>
+        </p:spPr>
+        <p:txBody>
+          <a:bodyPr wrap="square" rtlCol="0" anchor="t">
+            <a:spAutoFit/>
+          </a:bodyPr>
+          <a:p>
+            <a:r>
+              <a:rPr lang="en-US" altLang="zh-CN" sz="3200" b="1">
+                <a:solidFill>
+                  <a:schemeClr val="tx1"/>
+                </a:solidFill>
+                <a:latin typeface="Times New Roman" panose="02020503050405090304" charset="0"/>
+                <a:cs typeface="Times New Roman" panose="02020503050405090304" charset="0"/>
+              </a:rPr>
+              <a:t>Zero order</a:t>
+            </a:r>
+            <a:endParaRPr lang="en-US" altLang="zh-CN" sz="3200" b="1">
+              <a:solidFill>
+                <a:schemeClr val="tx1"/>
+              </a:solidFill>
+              <a:latin typeface="Times New Roman" panose="02020503050405090304" charset="0"/>
+              <a:cs typeface="Times New Roman" panose="02020503050405090304" charset="0"/>
+            </a:endParaRPr>
+          </a:p>
+        </p:txBody>
+      </p:sp>
+      <p:sp>
+        <p:nvSpPr>
+          <p:cNvPr id="7" name="文本框 6"/>
+          <p:cNvSpPr txBox="1"/>
+          <p:nvPr/>
+        </p:nvSpPr>
+        <p:spPr>
+          <a:xfrm>
+            <a:off x="242570" y="977900"/>
+            <a:ext cx="5608320" cy="706755"/>
+          </a:xfrm>
+          <a:prstGeom prst="rect">
+            <a:avLst/>
+          </a:prstGeom>
+          <a:noFill/>
+        </p:spPr>
+        <p:txBody>
+          <a:bodyPr wrap="square" rtlCol="0" anchor="t">
+            <a:spAutoFit/>
+          </a:bodyPr>
+          <a:p>
+            <a:r>
+              <a:rPr lang="en-US" altLang="zh-CN" sz="2000">
+                <a:latin typeface="Times New Roman" panose="02020503050405090304" charset="0"/>
+                <a:cs typeface="Times New Roman" panose="02020503050405090304" charset="0"/>
+              </a:rPr>
+              <a:t>k</a:t>
+            </a:r>
+            <a:r>
+              <a:rPr lang="en-US" altLang="zh-CN" sz="2000" baseline="-25000">
+                <a:latin typeface="Times New Roman" panose="02020503050405090304" charset="0"/>
+                <a:cs typeface="Times New Roman" panose="02020503050405090304" charset="0"/>
+              </a:rPr>
+              <a:t>b</a:t>
+            </a:r>
+            <a:r>
+              <a:rPr lang="en-US" altLang="zh-CN" sz="2000">
+                <a:latin typeface="Times New Roman" panose="02020503050405090304" charset="0"/>
+                <a:cs typeface="Times New Roman" panose="02020503050405090304" charset="0"/>
+              </a:rPr>
+              <a:t>_per_day= -0.5, k</a:t>
+            </a:r>
+            <a:r>
+              <a:rPr lang="en-US" altLang="zh-CN" sz="2000" baseline="-25000">
+                <a:latin typeface="Times New Roman" panose="02020503050405090304" charset="0"/>
+                <a:cs typeface="Times New Roman" panose="02020503050405090304" charset="0"/>
+              </a:rPr>
+              <a:t>w</a:t>
+            </a:r>
+            <a:r>
+              <a:rPr lang="en-US" altLang="zh-CN" sz="2000">
+                <a:latin typeface="Times New Roman" panose="02020503050405090304" charset="0"/>
+                <a:cs typeface="Times New Roman" panose="02020503050405090304" charset="0"/>
+              </a:rPr>
+              <a:t>_per_day = 0.0,</a:t>
+            </a:r>
+            <a:endParaRPr lang="en-US" altLang="zh-CN" sz="2000">
+              <a:latin typeface="Times New Roman" panose="02020503050405090304" charset="0"/>
+              <a:cs typeface="Times New Roman" panose="02020503050405090304" charset="0"/>
+            </a:endParaRPr>
+          </a:p>
+          <a:p>
+            <a:r>
+              <a:rPr lang="en-US" altLang="zh-CN" sz="2000">
+                <a:latin typeface="Times New Roman" panose="02020503050405090304" charset="0"/>
+                <a:cs typeface="Times New Roman" panose="02020503050405090304" charset="0"/>
+              </a:rPr>
+              <a:t>bulk_order=0, wall_order=0, duration_hours=72</a:t>
+            </a:r>
+            <a:endParaRPr lang="zh-CN" altLang="en-US" sz="2000">
+              <a:latin typeface="Times New Roman" panose="02020503050405090304" charset="0"/>
+              <a:cs typeface="Times New Roman" panose="02020503050405090304" charset="0"/>
+            </a:endParaRPr>
+          </a:p>
+        </p:txBody>
+      </p:sp>
+      <p:sp>
+        <p:nvSpPr>
+          <p:cNvPr id="8" name="文本框 7"/>
+          <p:cNvSpPr txBox="1"/>
+          <p:nvPr/>
+        </p:nvSpPr>
+        <p:spPr>
+          <a:xfrm>
+            <a:off x="5930900" y="789305"/>
+            <a:ext cx="6096000" cy="706755"/>
+          </a:xfrm>
+          <a:prstGeom prst="rect">
+            <a:avLst/>
+          </a:prstGeom>
+          <a:noFill/>
+        </p:spPr>
+        <p:txBody>
+          <a:bodyPr wrap="square" rtlCol="0" anchor="t">
+            <a:spAutoFit/>
+          </a:bodyPr>
+          <a:p>
+            <a:r>
+              <a:rPr lang="en-US" altLang="zh-CN" sz="2000">
+                <a:latin typeface="Times New Roman" panose="02020503050405090304" charset="0"/>
+                <a:cs typeface="Times New Roman" panose="02020503050405090304" charset="0"/>
+              </a:rPr>
+              <a:t>Water age = average residence time of the mixed water body at the current node</a:t>
+            </a:r>
+            <a:endParaRPr lang="en-US" altLang="zh-CN" sz="2000">
+              <a:latin typeface="Times New Roman" panose="02020503050405090304" charset="0"/>
+              <a:cs typeface="Times New Roman" panose="02020503050405090304" charset="0"/>
+            </a:endParaRPr>
+          </a:p>
+        </p:txBody>
+      </p:sp>
+      <p:sp>
+        <p:nvSpPr>
+          <p:cNvPr id="9" name="文本框 8"/>
+          <p:cNvSpPr txBox="1"/>
+          <p:nvPr/>
+        </p:nvSpPr>
+        <p:spPr>
+          <a:xfrm>
+            <a:off x="5930900" y="1595120"/>
+            <a:ext cx="5765165" cy="706755"/>
+          </a:xfrm>
+          <a:prstGeom prst="rect">
+            <a:avLst/>
+          </a:prstGeom>
+          <a:noFill/>
+        </p:spPr>
+        <p:txBody>
+          <a:bodyPr wrap="square" rtlCol="0" anchor="t">
+            <a:spAutoFit/>
+          </a:bodyPr>
+          <a:p>
+            <a:r>
+              <a:rPr lang="en-US" altLang="zh-CN" sz="2000">
+                <a:solidFill>
+                  <a:schemeClr val="tx1"/>
+                </a:solidFill>
+                <a:latin typeface="Times New Roman" panose="02020503050405090304" charset="0"/>
+                <a:cs typeface="Times New Roman" panose="02020503050405090304" charset="0"/>
+              </a:rPr>
+              <a:t>Bulk decay, </a:t>
+            </a:r>
+            <a:r>
+              <a:rPr lang="en-US" altLang="zh-CN" sz="2000">
+                <a:solidFill>
+                  <a:schemeClr val="tx1"/>
+                </a:solidFill>
+                <a:latin typeface="Times New Roman" panose="02020503050405090304" charset="0"/>
+                <a:cs typeface="Times New Roman" panose="02020503050405090304" charset="0"/>
+              </a:rPr>
+              <a:t>initial chlorine concentration in the </a:t>
+            </a:r>
+            <a:r>
+              <a:rPr lang="en-US" altLang="zh-CN" sz="2000">
+                <a:solidFill>
+                  <a:srgbClr val="FF0000"/>
+                </a:solidFill>
+                <a:latin typeface="Times New Roman" panose="02020503050405090304" charset="0"/>
+                <a:cs typeface="Times New Roman" panose="02020503050405090304" charset="0"/>
+              </a:rPr>
+              <a:t>tank </a:t>
+            </a:r>
+            <a:r>
+              <a:rPr lang="en-US" altLang="zh-CN" sz="2000">
+                <a:solidFill>
+                  <a:schemeClr val="tx1"/>
+                </a:solidFill>
+                <a:latin typeface="Times New Roman" panose="02020503050405090304" charset="0"/>
+                <a:cs typeface="Times New Roman" panose="02020503050405090304" charset="0"/>
+              </a:rPr>
+              <a:t>has not been set</a:t>
+            </a:r>
+            <a:endParaRPr lang="en-US" altLang="zh-CN" sz="2000">
+              <a:solidFill>
+                <a:schemeClr val="tx1"/>
+              </a:solidFill>
+              <a:latin typeface="Times New Roman" panose="02020503050405090304" charset="0"/>
+              <a:cs typeface="Times New Roman" panose="02020503050405090304" charset="0"/>
+            </a:endParaRPr>
+          </a:p>
+        </p:txBody>
+      </p:sp>
+      <p:sp>
+        <p:nvSpPr>
+          <p:cNvPr id="10" name="文本框 9"/>
+          <p:cNvSpPr txBox="1"/>
+          <p:nvPr/>
+        </p:nvSpPr>
+        <p:spPr>
+          <a:xfrm>
+            <a:off x="242570" y="1818005"/>
+            <a:ext cx="4218940" cy="645160"/>
+          </a:xfrm>
+          <a:prstGeom prst="rect">
+            <a:avLst/>
+          </a:prstGeom>
+          <a:noFill/>
+        </p:spPr>
+        <p:txBody>
+          <a:bodyPr wrap="square" rtlCol="0" anchor="t">
+            <a:spAutoFit/>
+          </a:bodyPr>
+          <a:p>
+            <a:r>
+              <a:rPr lang="en-US" altLang="zh-CN">
+                <a:latin typeface="Times New Roman Regular" panose="02020503050405090304" charset="0"/>
+                <a:cs typeface="Times New Roman Regular" panose="02020503050405090304" charset="0"/>
+              </a:rPr>
+              <a:t>Average water age and average concentration over the last 24 hours</a:t>
+            </a:r>
+            <a:endParaRPr lang="en-US" altLang="zh-CN">
+              <a:latin typeface="Times New Roman Regular" panose="02020503050405090304" charset="0"/>
+              <a:cs typeface="Times New Roman Regular" panose="02020503050405090304" charset="0"/>
+            </a:endParaRPr>
+          </a:p>
+        </p:txBody>
+      </p:sp>
+      <p:sp>
+        <p:nvSpPr>
+          <p:cNvPr id="17" name="文本框 16"/>
+          <p:cNvSpPr txBox="1"/>
+          <p:nvPr/>
+        </p:nvSpPr>
+        <p:spPr>
+          <a:xfrm>
+            <a:off x="3880485" y="6168390"/>
+            <a:ext cx="2215515" cy="398780"/>
+          </a:xfrm>
+          <a:prstGeom prst="rect">
+            <a:avLst/>
+          </a:prstGeom>
+        </p:spPr>
+        <p:txBody>
+          <a:bodyPr wrap="square">
+            <a:spAutoFit/>
+          </a:bodyPr>
+          <a:p>
+            <a:pPr marL="0" indent="0" latinLnBrk="0"/>
+            <a:r>
+              <a:rPr lang="en-US" altLang="zh-CN" sz="2000" b="0" i="0">
+                <a:latin typeface="Times New Roman Regular" panose="02020503050405090304" charset="0"/>
+                <a:ea typeface="Menlo" panose="020B0609030804020204"/>
+                <a:cs typeface="Times New Roman Regular" panose="02020503050405090304" charset="0"/>
+              </a:rPr>
+              <a:t>k</a:t>
+            </a:r>
+            <a:r>
+              <a:rPr lang="zh-CN" altLang="en-US" sz="2000" b="0" i="0">
+                <a:latin typeface="Times New Roman Regular" panose="02020503050405090304" charset="0"/>
+                <a:ea typeface="-apple-system"/>
+                <a:cs typeface="Times New Roman Regular" panose="02020503050405090304" charset="0"/>
+              </a:rPr>
+              <a:t>：</a:t>
+            </a:r>
+            <a:r>
+              <a:rPr lang="en-US" altLang="zh-CN" sz="2000" b="0" i="0">
+                <a:latin typeface="Times New Roman Regular" panose="02020503050405090304" charset="0"/>
+                <a:ea typeface="-apple-system"/>
+                <a:cs typeface="Times New Roman Regular" panose="02020503050405090304" charset="0"/>
+              </a:rPr>
+              <a:t>(mg/L)/day</a:t>
+            </a:r>
+            <a:endParaRPr lang="zh-CN" altLang="en-US" sz="2000" b="0" i="0">
+              <a:latin typeface="Times New Roman Regular" panose="02020503050405090304" charset="0"/>
+              <a:ea typeface="-apple-system"/>
+              <a:cs typeface="Times New Roman Regular" panose="02020503050405090304" charset="0"/>
+            </a:endParaRPr>
+          </a:p>
+        </p:txBody>
+      </p:sp>
+      <p:sp>
+        <p:nvSpPr>
+          <p:cNvPr id="16" name="文本框 15"/>
+          <p:cNvSpPr txBox="1"/>
+          <p:nvPr/>
+        </p:nvSpPr>
+        <p:spPr>
+          <a:xfrm>
+            <a:off x="601980" y="6168390"/>
+            <a:ext cx="2872105" cy="398780"/>
+          </a:xfrm>
+          <a:prstGeom prst="rect">
+            <a:avLst/>
+          </a:prstGeom>
+          <a:noFill/>
+        </p:spPr>
+        <p:txBody>
+          <a:bodyPr wrap="square" rtlCol="0" anchor="t">
+            <a:spAutoFit/>
+          </a:bodyPr>
+          <a:p>
+            <a:pPr algn="l"/>
+            <a:r>
+              <a:rPr lang="en-US" altLang="zh-CN" sz="2000">
+                <a:latin typeface="Times New Roman Regular" panose="02020503050405090304" charset="0"/>
+                <a:cs typeface="Times New Roman Regular" panose="02020503050405090304" charset="0"/>
+              </a:rPr>
+              <a:t>dC/dt = k（k &lt; 0</a:t>
+            </a:r>
+            <a:r>
+              <a:rPr lang="zh-CN" altLang="en-US" sz="2000">
+                <a:latin typeface="Times New Roman Regular" panose="02020503050405090304" charset="0"/>
+                <a:cs typeface="Times New Roman Regular" panose="02020503050405090304" charset="0"/>
+              </a:rPr>
+              <a:t>）</a:t>
+            </a:r>
+            <a:endParaRPr lang="zh-CN" altLang="en-US" sz="2000">
+              <a:latin typeface="Times New Roman Regular" panose="02020503050405090304" charset="0"/>
+              <a:cs typeface="Times New Roman Regular" panose="02020503050405090304" charset="0"/>
+            </a:endParaRPr>
+          </a:p>
+        </p:txBody>
+      </p:sp>
+      <p:sp>
+        <p:nvSpPr>
+          <p:cNvPr id="11" name="文本框 10"/>
+          <p:cNvSpPr txBox="1"/>
+          <p:nvPr/>
+        </p:nvSpPr>
+        <p:spPr>
+          <a:xfrm>
+            <a:off x="9344660" y="5645150"/>
+            <a:ext cx="2682240" cy="922020"/>
+          </a:xfrm>
+          <a:prstGeom prst="rect">
+            <a:avLst/>
+          </a:prstGeom>
+          <a:noFill/>
+        </p:spPr>
+        <p:txBody>
+          <a:bodyPr wrap="square" rtlCol="0" anchor="t">
+            <a:spAutoFit/>
+          </a:bodyPr>
+          <a:p>
+            <a:r>
+              <a:rPr lang="en-US" altLang="zh-CN">
+                <a:solidFill>
+                  <a:srgbClr val="FF0000"/>
+                </a:solidFill>
+                <a:latin typeface="Times New Roman Regular" panose="02020503050405090304" charset="0"/>
+                <a:cs typeface="Times New Roman Regular" panose="02020503050405090304" charset="0"/>
+              </a:rPr>
+              <a:t>In practice, the fitting result is k</a:t>
+            </a:r>
+            <a:r>
+              <a:rPr lang="en-US" altLang="zh-CN" baseline="-25000">
+                <a:solidFill>
+                  <a:srgbClr val="FF0000"/>
+                </a:solidFill>
+                <a:latin typeface="Times New Roman Regular" panose="02020503050405090304" charset="0"/>
+                <a:cs typeface="Times New Roman Regular" panose="02020503050405090304" charset="0"/>
+              </a:rPr>
+              <a:t>b</a:t>
+            </a:r>
+            <a:r>
+              <a:rPr lang="en-US" altLang="zh-CN">
+                <a:solidFill>
+                  <a:srgbClr val="FF0000"/>
+                </a:solidFill>
+                <a:latin typeface="Times New Roman Regular" panose="02020503050405090304" charset="0"/>
+                <a:cs typeface="Times New Roman Regular" panose="02020503050405090304" charset="0"/>
+              </a:rPr>
+              <a:t> + k</a:t>
+            </a:r>
+            <a:r>
+              <a:rPr lang="en-US" altLang="zh-CN" baseline="-25000">
+                <a:solidFill>
+                  <a:srgbClr val="FF0000"/>
+                </a:solidFill>
+                <a:latin typeface="Times New Roman Regular" panose="02020503050405090304" charset="0"/>
+                <a:cs typeface="Times New Roman Regular" panose="02020503050405090304" charset="0"/>
+              </a:rPr>
+              <a:t>w</a:t>
+            </a:r>
+            <a:r>
+              <a:rPr lang="en-US" altLang="zh-CN">
+                <a:solidFill>
+                  <a:srgbClr val="FF0000"/>
+                </a:solidFill>
+                <a:latin typeface="Times New Roman Regular" panose="02020503050405090304" charset="0"/>
+                <a:cs typeface="Times New Roman Regular" panose="02020503050405090304" charset="0"/>
+              </a:rPr>
+              <a:t>; how can we obtain k</a:t>
+            </a:r>
+            <a:r>
+              <a:rPr lang="en-US" altLang="zh-CN" baseline="-25000">
+                <a:solidFill>
+                  <a:srgbClr val="FF0000"/>
+                </a:solidFill>
+                <a:latin typeface="Times New Roman Regular" panose="02020503050405090304" charset="0"/>
+                <a:cs typeface="Times New Roman Regular" panose="02020503050405090304" charset="0"/>
+              </a:rPr>
+              <a:t>b </a:t>
+            </a:r>
+            <a:r>
+              <a:rPr lang="en-US" altLang="zh-CN">
+                <a:solidFill>
+                  <a:srgbClr val="FF0000"/>
+                </a:solidFill>
+                <a:latin typeface="Times New Roman Regular" panose="02020503050405090304" charset="0"/>
+                <a:cs typeface="Times New Roman Regular" panose="02020503050405090304" charset="0"/>
+              </a:rPr>
+              <a:t>?  (jar test?)</a:t>
+            </a:r>
+            <a:endParaRPr lang="zh-CN" altLang="en-US">
+              <a:solidFill>
+                <a:srgbClr val="FF0000"/>
+              </a:solidFill>
+              <a:latin typeface="Times New Roman Regular" panose="02020503050405090304" charset="0"/>
+              <a:cs typeface="Times New Roman Regular" panose="02020503050405090304" charset="0"/>
+            </a:endParaRPr>
+          </a:p>
+        </p:txBody>
+      </p:sp>
+      <p:sp>
+        <p:nvSpPr>
+          <p:cNvPr id="12" name="文本框 11"/>
+          <p:cNvSpPr txBox="1"/>
+          <p:nvPr/>
+        </p:nvSpPr>
+        <p:spPr>
+          <a:xfrm>
+            <a:off x="2270760" y="409258"/>
+            <a:ext cx="5080000" cy="368300"/>
+          </a:xfrm>
+          <a:prstGeom prst="rect">
+            <a:avLst/>
+          </a:prstGeom>
+        </p:spPr>
+        <p:txBody>
+          <a:bodyPr>
+            <a:spAutoFit/>
+          </a:bodyPr>
+          <a:p>
+            <a:pPr marL="0" indent="0"/>
+            <a:r>
+              <a:rPr lang="en-US" altLang="zh-CN" b="0" i="0">
+                <a:latin typeface="Times New Roman" panose="02020503050405090304" charset="0"/>
+                <a:ea typeface="Menlo" panose="020B0609030804020204"/>
+                <a:cs typeface="Times New Roman" panose="02020503050405090304" charset="0"/>
+              </a:rPr>
+              <a:t>→ time / residence</a:t>
+            </a:r>
+            <a:endParaRPr lang="en-US" altLang="zh-CN" b="0" i="0">
+              <a:latin typeface="Times New Roman" panose="02020503050405090304" charset="0"/>
+              <a:ea typeface="Menlo" panose="020B0609030804020204"/>
+              <a:cs typeface="Times New Roman" panose="02020503050405090304" charset="0"/>
+            </a:endParaRPr>
+          </a:p>
+        </p:txBody>
+      </p:sp>
+    </p:spTree>
+    <p:custDataLst>
+      <p:tags r:id="rId2"/>
+    </p:custDataLst>
+  </p:cSld>
+  <p:clrMapOvr>
+    <a:masterClrMapping/>
+  </p:clrMapOvr>
+</p:sld>
+</file>
+
+<file path=ppt/slides/slide5.xml><?xml version="1.0" encoding="utf-8"?>
+<p:sld xmlns:a="http://schemas.openxmlformats.org/drawingml/2006/main" xmlns:r="http://schemas.openxmlformats.org/officeDocument/2006/relationships" xmlns:p="http://schemas.openxmlformats.org/presentationml/2006/main">
+  <p:cSld>
+    <p:spTree>
+      <p:nvGrpSpPr>
+        <p:cNvPr id="1" name=""/>
+        <p:cNvGrpSpPr/>
+        <p:nvPr/>
+      </p:nvGrpSpPr>
+      <p:grpSpPr/>
       <p:pic>
         <p:nvPicPr>
           <p:cNvPr id="4" name="图片 3"/>
@@ -4403,8 +5347,8 @@
         </p:blipFill>
         <p:spPr>
           <a:xfrm>
-            <a:off x="234315" y="0"/>
-            <a:ext cx="5368290" cy="3758565"/>
+            <a:off x="101600" y="644525"/>
+            <a:ext cx="4334510" cy="3078480"/>
           </a:xfrm>
           <a:prstGeom prst="rect">
             <a:avLst/>
@@ -4427,17 +5371,112 @@
         </p:blipFill>
         <p:spPr>
           <a:xfrm>
-            <a:off x="6051550" y="0"/>
-            <a:ext cx="5050790" cy="3520440"/>
+            <a:off x="6090285" y="2672715"/>
+            <a:ext cx="5608320" cy="3909695"/>
           </a:xfrm>
           <a:prstGeom prst="rect">
             <a:avLst/>
           </a:prstGeom>
         </p:spPr>
       </p:pic>
+      <p:sp>
+        <p:nvSpPr>
+          <p:cNvPr id="6" name="文本框 5"/>
+          <p:cNvSpPr txBox="1"/>
+          <p:nvPr/>
+        </p:nvSpPr>
+        <p:spPr>
+          <a:xfrm>
+            <a:off x="101600" y="60960"/>
+            <a:ext cx="5608320" cy="583565"/>
+          </a:xfrm>
+          <a:prstGeom prst="rect">
+            <a:avLst/>
+          </a:prstGeom>
+          <a:noFill/>
+        </p:spPr>
+        <p:txBody>
+          <a:bodyPr wrap="square" rtlCol="0" anchor="t">
+            <a:spAutoFit/>
+          </a:bodyPr>
+          <a:p>
+            <a:r>
+              <a:rPr lang="en-US" altLang="zh-CN" sz="3200" b="1">
+                <a:solidFill>
+                  <a:schemeClr val="tx1"/>
+                </a:solidFill>
+                <a:latin typeface="Times New Roman" panose="02020503050405090304" charset="0"/>
+                <a:cs typeface="Times New Roman" panose="02020503050405090304" charset="0"/>
+              </a:rPr>
+              <a:t>Zero order</a:t>
+            </a:r>
+            <a:endParaRPr lang="en-US" altLang="zh-CN" sz="3200" b="1">
+              <a:solidFill>
+                <a:schemeClr val="tx1"/>
+              </a:solidFill>
+              <a:latin typeface="Times New Roman" panose="02020503050405090304" charset="0"/>
+              <a:cs typeface="Times New Roman" panose="02020503050405090304" charset="0"/>
+            </a:endParaRPr>
+          </a:p>
+        </p:txBody>
+      </p:sp>
+      <p:sp>
+        <p:nvSpPr>
+          <p:cNvPr id="7" name="文本框 6"/>
+          <p:cNvSpPr txBox="1"/>
+          <p:nvPr/>
+        </p:nvSpPr>
+        <p:spPr>
+          <a:xfrm>
+            <a:off x="6573520" y="1380490"/>
+            <a:ext cx="5356860" cy="1291590"/>
+          </a:xfrm>
+          <a:prstGeom prst="rect">
+            <a:avLst/>
+          </a:prstGeom>
+          <a:noFill/>
+        </p:spPr>
+        <p:txBody>
+          <a:bodyPr wrap="square" rtlCol="0" anchor="t">
+            <a:noAutofit/>
+          </a:bodyPr>
+          <a:p>
+            <a:r>
+              <a:rPr lang="en-US" altLang="zh-CN">
+                <a:latin typeface="Times New Roman" panose="02020503050405090304" charset="0"/>
+                <a:cs typeface="Times New Roman" panose="02020503050405090304" charset="0"/>
+              </a:rPr>
+              <a:t>eg. Node 20 sometimes receives old water, and sometimes suddenly switches to new water.</a:t>
+            </a:r>
+            <a:endParaRPr lang="en-US" altLang="zh-CN">
+              <a:latin typeface="Times New Roman" panose="02020503050405090304" charset="0"/>
+              <a:cs typeface="Times New Roman" panose="02020503050405090304" charset="0"/>
+            </a:endParaRPr>
+          </a:p>
+          <a:p>
+            <a:endParaRPr lang="en-US" altLang="zh-CN">
+              <a:latin typeface="Times New Roman" panose="02020503050405090304" charset="0"/>
+              <a:cs typeface="Times New Roman" panose="02020503050405090304" charset="0"/>
+            </a:endParaRPr>
+          </a:p>
+          <a:p>
+            <a:r>
+              <a:rPr lang="en-US" altLang="zh-CN">
+                <a:latin typeface="Times New Roman" panose="02020503050405090304" charset="0"/>
+                <a:cs typeface="Times New Roman" panose="02020503050405090304" charset="0"/>
+              </a:rPr>
+              <a:t>Concentration platform + increased water age</a:t>
+            </a:r>
+            <a:endParaRPr lang="en-US" altLang="zh-CN">
+              <a:latin typeface="Times New Roman" panose="02020503050405090304" charset="0"/>
+              <a:cs typeface="Times New Roman" panose="02020503050405090304" charset="0"/>
+            </a:endParaRPr>
+          </a:p>
+        </p:txBody>
+      </p:sp>
       <p:pic>
         <p:nvPicPr>
-          <p:cNvPr id="6" name="图片 5"/>
+          <p:cNvPr id="8" name="图片 7"/>
           <p:cNvPicPr>
             <a:picLocks noChangeAspect="1"/>
           </p:cNvPicPr>
@@ -4451,8 +5490,8 @@
         </p:blipFill>
         <p:spPr>
           <a:xfrm>
-            <a:off x="422275" y="3675380"/>
-            <a:ext cx="4561840" cy="3182620"/>
+            <a:off x="101600" y="3876040"/>
+            <a:ext cx="5273675" cy="2907030"/>
           </a:xfrm>
           <a:prstGeom prst="rect">
             <a:avLst/>
@@ -4462,123 +5501,6 @@
     </p:spTree>
     <p:custDataLst>
       <p:tags r:id="rId4"/>
-    </p:custDataLst>
-  </p:cSld>
-  <p:clrMapOvr>
-    <a:masterClrMapping/>
-  </p:clrMapOvr>
-</p:sld>
-</file>
-
-<file path=ppt/slides/slide5.xml><?xml version="1.0" encoding="utf-8"?>
-<p:sld xmlns:a="http://schemas.openxmlformats.org/drawingml/2006/main" xmlns:r="http://schemas.openxmlformats.org/officeDocument/2006/relationships" xmlns:p="http://schemas.openxmlformats.org/presentationml/2006/main">
-  <p:cSld>
-    <p:spTree>
-      <p:nvGrpSpPr>
-        <p:cNvPr id="1" name=""/>
-        <p:cNvGrpSpPr/>
-        <p:nvPr/>
-      </p:nvGrpSpPr>
-      <p:grpSpPr>
-        <a:xfrm>
-          <a:off x="0" y="0"/>
-          <a:ext cx="0" cy="0"/>
-          <a:chOff x="0" y="0"/>
-          <a:chExt cx="0" cy="0"/>
-        </a:xfrm>
-      </p:grpSpPr>
-      <p:sp>
-        <p:nvSpPr>
-          <p:cNvPr id="4" name="文本框 3"/>
-          <p:cNvSpPr txBox="1"/>
-          <p:nvPr/>
-        </p:nvSpPr>
-        <p:spPr>
-          <a:xfrm>
-            <a:off x="101600" y="260985"/>
-            <a:ext cx="9237980" cy="645160"/>
-          </a:xfrm>
-          <a:prstGeom prst="rect">
-            <a:avLst/>
-          </a:prstGeom>
-          <a:noFill/>
-        </p:spPr>
-        <p:txBody>
-          <a:bodyPr wrap="square" rtlCol="0" anchor="t">
-            <a:spAutoFit/>
-          </a:bodyPr>
-          <a:p>
-            <a:r>
-              <a:rPr lang="en-US" altLang="zh-CN"/>
-              <a:t>kb_per_day=-0.3, kw_per_day=0.0,</a:t>
-            </a:r>
-            <a:endParaRPr lang="en-US" altLang="zh-CN"/>
-          </a:p>
-          <a:p>
-            <a:r>
-              <a:rPr lang="en-US" altLang="zh-CN"/>
-              <a:t>bulk_order=0, wall_order=0, duration_hours=72</a:t>
-            </a:r>
-            <a:endParaRPr lang="zh-CN" altLang="en-US"/>
-          </a:p>
-        </p:txBody>
-      </p:sp>
-      <p:sp>
-        <p:nvSpPr>
-          <p:cNvPr id="5" name="文本框 4"/>
-          <p:cNvSpPr txBox="1"/>
-          <p:nvPr/>
-        </p:nvSpPr>
-        <p:spPr>
-          <a:xfrm>
-            <a:off x="101600" y="1142365"/>
-            <a:ext cx="6096000" cy="645160"/>
-          </a:xfrm>
-          <a:prstGeom prst="rect">
-            <a:avLst/>
-          </a:prstGeom>
-          <a:noFill/>
-        </p:spPr>
-        <p:txBody>
-          <a:bodyPr wrap="square" rtlCol="0" anchor="t">
-            <a:spAutoFit/>
-          </a:bodyPr>
-          <a:p>
-            <a:r>
-              <a:rPr lang="en-US" altLang="zh-CN"/>
-              <a:t>Water age = average residence time of the mixed water body at the current node</a:t>
-            </a:r>
-            <a:endParaRPr lang="zh-CN" altLang="en-US"/>
-          </a:p>
-        </p:txBody>
-      </p:sp>
-      <p:pic>
-        <p:nvPicPr>
-          <p:cNvPr id="7" name="图片 6"/>
-          <p:cNvPicPr>
-            <a:picLocks noChangeAspect="1"/>
-          </p:cNvPicPr>
-          <p:nvPr/>
-        </p:nvPicPr>
-        <p:blipFill>
-          <a:blip r:embed="rId1"/>
-          <a:stretch>
-            <a:fillRect/>
-          </a:stretch>
-        </p:blipFill>
-        <p:spPr>
-          <a:xfrm>
-            <a:off x="4923155" y="1787525"/>
-            <a:ext cx="6572250" cy="4667250"/>
-          </a:xfrm>
-          <a:prstGeom prst="rect">
-            <a:avLst/>
-          </a:prstGeom>
-        </p:spPr>
-      </p:pic>
-    </p:spTree>
-    <p:custDataLst>
-      <p:tags r:id="rId2"/>
     </p:custDataLst>
   </p:cSld>
   <p:clrMapOvr>
@@ -4620,7 +5542,7 @@
         </p:blipFill>
         <p:spPr>
           <a:xfrm>
-            <a:off x="5802630" y="553720"/>
+            <a:off x="5790565" y="2111375"/>
             <a:ext cx="5921375" cy="3263900"/>
           </a:xfrm>
           <a:prstGeom prst="rect">
@@ -4636,8 +5558,8 @@
         </p:nvSpPr>
         <p:spPr>
           <a:xfrm>
-            <a:off x="2926080" y="5050155"/>
-            <a:ext cx="6096000" cy="645160"/>
+            <a:off x="2914015" y="5548630"/>
+            <a:ext cx="6096000" cy="706755"/>
           </a:xfrm>
           <a:prstGeom prst="rect">
             <a:avLst/>
@@ -4650,10 +5572,16 @@
           </a:bodyPr>
           <a:p>
             <a:r>
-              <a:rPr lang="en-US" altLang="zh-CN"/>
+              <a:rPr lang="en-US" altLang="zh-CN" sz="2000">
+                <a:latin typeface="Times New Roman" panose="02020503050405090304" charset="0"/>
+                <a:cs typeface="Times New Roman" panose="02020503050405090304" charset="0"/>
+              </a:rPr>
               <a:t>The first time, I randomly selected 20% of the old pipes and found little change.</a:t>
             </a:r>
-            <a:endParaRPr lang="zh-CN" altLang="en-US"/>
+            <a:endParaRPr lang="en-US" altLang="zh-CN" sz="2000">
+              <a:latin typeface="Times New Roman" panose="02020503050405090304" charset="0"/>
+              <a:cs typeface="Times New Roman" panose="02020503050405090304" charset="0"/>
+            </a:endParaRPr>
           </a:p>
         </p:txBody>
       </p:sp>
@@ -4673,14 +5601,189 @@
         </p:blipFill>
         <p:spPr>
           <a:xfrm>
-            <a:off x="94615" y="553720"/>
-            <a:ext cx="5497195" cy="3030220"/>
+            <a:off x="82550" y="2044065"/>
+            <a:ext cx="5756275" cy="3173095"/>
           </a:xfrm>
           <a:prstGeom prst="rect">
             <a:avLst/>
           </a:prstGeom>
         </p:spPr>
       </p:pic>
+      <p:sp>
+        <p:nvSpPr>
+          <p:cNvPr id="8" name="文本框 7"/>
+          <p:cNvSpPr txBox="1"/>
+          <p:nvPr/>
+        </p:nvSpPr>
+        <p:spPr>
+          <a:xfrm>
+            <a:off x="398780" y="1539240"/>
+            <a:ext cx="2872105" cy="398780"/>
+          </a:xfrm>
+          <a:prstGeom prst="rect">
+            <a:avLst/>
+          </a:prstGeom>
+          <a:noFill/>
+        </p:spPr>
+        <p:txBody>
+          <a:bodyPr wrap="square" rtlCol="0" anchor="t">
+            <a:spAutoFit/>
+          </a:bodyPr>
+          <a:p>
+            <a:pPr algn="l"/>
+            <a:r>
+              <a:rPr lang="en-US" altLang="zh-CN" sz="2000">
+                <a:latin typeface="Times New Roman Regular" panose="02020503050405090304" charset="0"/>
+                <a:cs typeface="Times New Roman Regular" panose="02020503050405090304" charset="0"/>
+              </a:rPr>
+              <a:t>dC/dt = k·C        （k &lt; 0</a:t>
+            </a:r>
+            <a:r>
+              <a:rPr lang="zh-CN" altLang="en-US" sz="2000">
+                <a:latin typeface="Times New Roman Regular" panose="02020503050405090304" charset="0"/>
+                <a:cs typeface="Times New Roman Regular" panose="02020503050405090304" charset="0"/>
+              </a:rPr>
+              <a:t>）</a:t>
+            </a:r>
+            <a:endParaRPr lang="zh-CN" altLang="en-US" sz="2000">
+              <a:latin typeface="Times New Roman Regular" panose="02020503050405090304" charset="0"/>
+              <a:cs typeface="Times New Roman Regular" panose="02020503050405090304" charset="0"/>
+            </a:endParaRPr>
+          </a:p>
+        </p:txBody>
+      </p:sp>
+      <p:sp>
+        <p:nvSpPr>
+          <p:cNvPr id="9" name="文本框 8"/>
+          <p:cNvSpPr txBox="1"/>
+          <p:nvPr/>
+        </p:nvSpPr>
+        <p:spPr>
+          <a:xfrm>
+            <a:off x="5431155" y="1539240"/>
+            <a:ext cx="1946275" cy="398780"/>
+          </a:xfrm>
+          <a:prstGeom prst="rect">
+            <a:avLst/>
+          </a:prstGeom>
+        </p:spPr>
+        <p:txBody>
+          <a:bodyPr wrap="square">
+            <a:spAutoFit/>
+          </a:bodyPr>
+          <a:p>
+            <a:pPr marL="0" indent="0" latinLnBrk="0"/>
+            <a:r>
+              <a:rPr lang="en-US" altLang="zh-CN" sz="2000" b="0" i="0">
+                <a:latin typeface="Times New Roman Regular" panose="02020503050405090304" charset="0"/>
+                <a:ea typeface="Menlo" panose="020B0609030804020204"/>
+                <a:cs typeface="Times New Roman Regular" panose="02020503050405090304" charset="0"/>
+              </a:rPr>
+              <a:t>k</a:t>
+            </a:r>
+            <a:r>
+              <a:rPr lang="zh-CN" altLang="en-US" sz="2000" b="0" i="0">
+                <a:latin typeface="Times New Roman Regular" panose="02020503050405090304" charset="0"/>
+                <a:ea typeface="-apple-system"/>
+                <a:cs typeface="Times New Roman Regular" panose="02020503050405090304" charset="0"/>
+              </a:rPr>
+              <a:t>：</a:t>
+            </a:r>
+            <a:r>
+              <a:rPr lang="en-US" altLang="zh-CN" sz="2000" b="0" i="0">
+                <a:latin typeface="Times New Roman Regular" panose="02020503050405090304" charset="0"/>
+                <a:ea typeface="-apple-system"/>
+                <a:cs typeface="Times New Roman Regular" panose="02020503050405090304" charset="0"/>
+              </a:rPr>
+              <a:t>1/day </a:t>
+            </a:r>
+            <a:r>
+              <a:rPr lang="en-US" altLang="zh-CN" sz="2000" b="0" i="0">
+                <a:latin typeface="Times New Roman Regular" panose="02020503050405090304" charset="0"/>
+                <a:ea typeface="-apple-system"/>
+                <a:cs typeface="Times New Roman Regular" panose="02020503050405090304" charset="0"/>
+              </a:rPr>
+              <a:t>→ 1/s</a:t>
+            </a:r>
+            <a:endParaRPr lang="zh-CN" altLang="en-US" sz="2000" b="0" i="0">
+              <a:latin typeface="Times New Roman Regular" panose="02020503050405090304" charset="0"/>
+              <a:ea typeface="-apple-system"/>
+              <a:cs typeface="Times New Roman Regular" panose="02020503050405090304" charset="0"/>
+            </a:endParaRPr>
+          </a:p>
+        </p:txBody>
+      </p:sp>
+      <p:sp>
+        <p:nvSpPr>
+          <p:cNvPr id="10" name="文本框 9"/>
+          <p:cNvSpPr txBox="1"/>
+          <p:nvPr/>
+        </p:nvSpPr>
+        <p:spPr>
+          <a:xfrm>
+            <a:off x="398780" y="960755"/>
+            <a:ext cx="2872105" cy="398780"/>
+          </a:xfrm>
+          <a:prstGeom prst="rect">
+            <a:avLst/>
+          </a:prstGeom>
+          <a:noFill/>
+        </p:spPr>
+        <p:txBody>
+          <a:bodyPr wrap="square" rtlCol="0" anchor="t">
+            <a:spAutoFit/>
+          </a:bodyPr>
+          <a:p>
+            <a:pPr algn="l"/>
+            <a:r>
+              <a:rPr lang="en-US" altLang="zh-CN" sz="2000" b="1">
+                <a:latin typeface="Times New Roman" panose="02020503050405090304" charset="0"/>
+                <a:cs typeface="Times New Roman" panose="02020503050405090304" charset="0"/>
+              </a:rPr>
+              <a:t>First order</a:t>
+            </a:r>
+            <a:endParaRPr lang="en-US" altLang="zh-CN" sz="2000" b="1">
+              <a:latin typeface="Times New Roman" panose="02020503050405090304" charset="0"/>
+              <a:cs typeface="Times New Roman" panose="02020503050405090304" charset="0"/>
+            </a:endParaRPr>
+          </a:p>
+        </p:txBody>
+      </p:sp>
+      <p:sp>
+        <p:nvSpPr>
+          <p:cNvPr id="11" name="文本框 10"/>
+          <p:cNvSpPr txBox="1"/>
+          <p:nvPr/>
+        </p:nvSpPr>
+        <p:spPr>
+          <a:xfrm>
+            <a:off x="196215" y="267335"/>
+            <a:ext cx="6096000" cy="583565"/>
+          </a:xfrm>
+          <a:prstGeom prst="rect">
+            <a:avLst/>
+          </a:prstGeom>
+          <a:noFill/>
+        </p:spPr>
+        <p:txBody>
+          <a:bodyPr wrap="square" rtlCol="0" anchor="t">
+            <a:spAutoFit/>
+          </a:bodyPr>
+          <a:p>
+            <a:r>
+              <a:rPr lang="en-US" altLang="zh-CN" sz="3200" b="1">
+                <a:latin typeface="Times New Roman" panose="02020503050405090304" charset="0"/>
+                <a:cs typeface="Times New Roman" panose="02020503050405090304" charset="0"/>
+              </a:rPr>
+              <a:t>Forward Simulation</a:t>
+            </a:r>
+            <a:endParaRPr lang="en-US" altLang="zh-CN" sz="3200" b="1">
+              <a:latin typeface="Times New Roman" panose="02020503050405090304" charset="0"/>
+              <a:cs typeface="Times New Roman" panose="02020503050405090304" charset="0"/>
+            </a:endParaRPr>
+          </a:p>
+        </p:txBody>
+      </p:sp>
     </p:spTree>
     <p:custDataLst>
       <p:tags r:id="rId3"/>
@@ -4693,6 +5796,398 @@
 </file>
 
 <file path=ppt/slides/slide7.xml><?xml version="1.0" encoding="utf-8"?>
+<p:sld xmlns:a="http://schemas.openxmlformats.org/drawingml/2006/main" xmlns:r="http://schemas.openxmlformats.org/officeDocument/2006/relationships" xmlns:p="http://schemas.openxmlformats.org/presentationml/2006/main">
+  <p:cSld>
+    <p:spTree>
+      <p:nvGrpSpPr>
+        <p:cNvPr id="1" name=""/>
+        <p:cNvGrpSpPr/>
+        <p:nvPr/>
+      </p:nvGrpSpPr>
+      <p:grpSpPr>
+        <a:xfrm>
+          <a:off x="0" y="0"/>
+          <a:ext cx="0" cy="0"/>
+          <a:chOff x="0" y="0"/>
+          <a:chExt cx="0" cy="0"/>
+        </a:xfrm>
+      </p:grpSpPr>
+      <p:pic>
+        <p:nvPicPr>
+          <p:cNvPr id="4" name="图片 3"/>
+          <p:cNvPicPr>
+            <a:picLocks noChangeAspect="1"/>
+          </p:cNvPicPr>
+          <p:nvPr/>
+        </p:nvPicPr>
+        <p:blipFill>
+          <a:blip r:embed="rId1"/>
+          <a:srcRect l="6575" b="7594"/>
+          <a:stretch>
+            <a:fillRect/>
+          </a:stretch>
+        </p:blipFill>
+        <p:spPr>
+          <a:xfrm>
+            <a:off x="399415" y="683895"/>
+            <a:ext cx="4033520" cy="3233420"/>
+          </a:xfrm>
+          <a:prstGeom prst="rect">
+            <a:avLst/>
+          </a:prstGeom>
+        </p:spPr>
+      </p:pic>
+      <p:pic>
+        <p:nvPicPr>
+          <p:cNvPr id="5" name="图片 4"/>
+          <p:cNvPicPr>
+            <a:picLocks noChangeAspect="1"/>
+          </p:cNvPicPr>
+          <p:nvPr/>
+        </p:nvPicPr>
+        <p:blipFill>
+          <a:blip r:embed="rId2"/>
+          <a:stretch>
+            <a:fillRect/>
+          </a:stretch>
+        </p:blipFill>
+        <p:spPr>
+          <a:xfrm>
+            <a:off x="6354445" y="111125"/>
+            <a:ext cx="5633720" cy="3105785"/>
+          </a:xfrm>
+          <a:prstGeom prst="rect">
+            <a:avLst/>
+          </a:prstGeom>
+        </p:spPr>
+      </p:pic>
+      <p:pic>
+        <p:nvPicPr>
+          <p:cNvPr id="6" name="图片 5"/>
+          <p:cNvPicPr>
+            <a:picLocks noChangeAspect="1"/>
+          </p:cNvPicPr>
+          <p:nvPr/>
+        </p:nvPicPr>
+        <p:blipFill>
+          <a:blip r:embed="rId3"/>
+          <a:stretch>
+            <a:fillRect/>
+          </a:stretch>
+        </p:blipFill>
+        <p:spPr>
+          <a:xfrm>
+            <a:off x="6150610" y="3217545"/>
+            <a:ext cx="6041390" cy="3330575"/>
+          </a:xfrm>
+          <a:prstGeom prst="rect">
+            <a:avLst/>
+          </a:prstGeom>
+        </p:spPr>
+      </p:pic>
+      <p:pic>
+        <p:nvPicPr>
+          <p:cNvPr id="7" name="图片 6"/>
+          <p:cNvPicPr>
+            <a:picLocks noChangeAspect="1"/>
+          </p:cNvPicPr>
+          <p:nvPr/>
+        </p:nvPicPr>
+        <p:blipFill>
+          <a:blip r:embed="rId4"/>
+          <a:stretch>
+            <a:fillRect/>
+          </a:stretch>
+        </p:blipFill>
+        <p:spPr>
+          <a:xfrm>
+            <a:off x="165100" y="3869690"/>
+            <a:ext cx="4663440" cy="2045970"/>
+          </a:xfrm>
+          <a:prstGeom prst="rect">
+            <a:avLst/>
+          </a:prstGeom>
+        </p:spPr>
+      </p:pic>
+      <p:sp>
+        <p:nvSpPr>
+          <p:cNvPr id="8" name="文本框 7"/>
+          <p:cNvSpPr txBox="1"/>
+          <p:nvPr/>
+        </p:nvSpPr>
+        <p:spPr>
+          <a:xfrm>
+            <a:off x="54610" y="5915660"/>
+            <a:ext cx="5746750" cy="922020"/>
+          </a:xfrm>
+          <a:prstGeom prst="rect">
+            <a:avLst/>
+          </a:prstGeom>
+          <a:noFill/>
+        </p:spPr>
+        <p:txBody>
+          <a:bodyPr wrap="square" rtlCol="0" anchor="t">
+            <a:spAutoFit/>
+          </a:bodyPr>
+          <a:p>
+            <a:r>
+              <a:rPr lang="en-US" altLang="zh-CN">
+                <a:latin typeface="Times New Roman" panose="02020503050405090304" charset="0"/>
+                <a:cs typeface="Times New Roman" panose="02020503050405090304" charset="0"/>
+              </a:rPr>
+              <a:t>To make the change more apparent, the result can be obtained through subsequent inversion, so I fixed the position of the old pipe.</a:t>
+            </a:r>
+            <a:endParaRPr lang="zh-CN" altLang="en-US">
+              <a:latin typeface="Times New Roman" panose="02020503050405090304" charset="0"/>
+              <a:cs typeface="Times New Roman" panose="02020503050405090304" charset="0"/>
+            </a:endParaRPr>
+          </a:p>
+        </p:txBody>
+      </p:sp>
+      <p:sp>
+        <p:nvSpPr>
+          <p:cNvPr id="11" name="文本框 10"/>
+          <p:cNvSpPr txBox="1"/>
+          <p:nvPr/>
+        </p:nvSpPr>
+        <p:spPr>
+          <a:xfrm>
+            <a:off x="165100" y="48895"/>
+            <a:ext cx="6096000" cy="583565"/>
+          </a:xfrm>
+          <a:prstGeom prst="rect">
+            <a:avLst/>
+          </a:prstGeom>
+          <a:noFill/>
+        </p:spPr>
+        <p:txBody>
+          <a:bodyPr wrap="square" rtlCol="0" anchor="t">
+            <a:spAutoFit/>
+          </a:bodyPr>
+          <a:p>
+            <a:r>
+              <a:rPr lang="en-US" altLang="zh-CN" sz="3200" b="1">
+                <a:latin typeface="Times New Roman" panose="02020503050405090304" charset="0"/>
+                <a:cs typeface="Times New Roman" panose="02020503050405090304" charset="0"/>
+              </a:rPr>
+              <a:t>Forward Simulation</a:t>
+            </a:r>
+            <a:endParaRPr lang="en-US" altLang="zh-CN" sz="3200" b="1">
+              <a:latin typeface="Times New Roman" panose="02020503050405090304" charset="0"/>
+              <a:cs typeface="Times New Roman" panose="02020503050405090304" charset="0"/>
+            </a:endParaRPr>
+          </a:p>
+        </p:txBody>
+      </p:sp>
+    </p:spTree>
+    <p:custDataLst>
+      <p:tags r:id="rId5"/>
+    </p:custDataLst>
+  </p:cSld>
+  <p:clrMapOvr>
+    <a:masterClrMapping/>
+  </p:clrMapOvr>
+</p:sld>
+</file>
+
+<file path=ppt/slides/slide8.xml><?xml version="1.0" encoding="utf-8"?>
+<p:sld xmlns:a="http://schemas.openxmlformats.org/drawingml/2006/main" xmlns:r="http://schemas.openxmlformats.org/officeDocument/2006/relationships" xmlns:p="http://schemas.openxmlformats.org/presentationml/2006/main">
+  <p:cSld>
+    <p:spTree>
+      <p:nvGrpSpPr>
+        <p:cNvPr id="1" name=""/>
+        <p:cNvGrpSpPr/>
+        <p:nvPr/>
+      </p:nvGrpSpPr>
+      <p:grpSpPr>
+        <a:xfrm>
+          <a:off x="0" y="0"/>
+          <a:ext cx="0" cy="0"/>
+          <a:chOff x="0" y="0"/>
+          <a:chExt cx="0" cy="0"/>
+        </a:xfrm>
+      </p:grpSpPr>
+      <p:sp>
+        <p:nvSpPr>
+          <p:cNvPr id="4" name="文本框 3"/>
+          <p:cNvSpPr txBox="1"/>
+          <p:nvPr/>
+        </p:nvSpPr>
+        <p:spPr>
+          <a:xfrm>
+            <a:off x="6449060" y="261938"/>
+            <a:ext cx="5080000" cy="321945"/>
+          </a:xfrm>
+          <a:prstGeom prst="rect">
+            <a:avLst/>
+          </a:prstGeom>
+        </p:spPr>
+        <p:txBody>
+          <a:bodyPr>
+            <a:spAutoFit/>
+          </a:bodyPr>
+          <a:p>
+            <a:pPr>
+              <a:lnSpc>
+                <a:spcPts val="1800"/>
+              </a:lnSpc>
+            </a:pPr>
+            <a:r>
+              <a:rPr lang="en-US" altLang="zh-CN" sz="1600" b="0">
+                <a:solidFill>
+                  <a:schemeClr val="tx1"/>
+                </a:solidFill>
+                <a:latin typeface="Times New Roman" panose="02020503050405090304" charset="0"/>
+                <a:ea typeface="Menlo" panose="020B0609030804020204"/>
+                <a:cs typeface="Times New Roman" panose="02020503050405090304" charset="0"/>
+              </a:rPr>
+              <a:t>C_meas(t) = C_sim(t) + ε, ε ~ Normal(0, σ²)  </a:t>
+            </a:r>
+            <a:r>
+              <a:rPr lang="en-US" altLang="zh-CN" sz="1600">
+                <a:latin typeface="Times New Roman" panose="02020503050405090304" charset="0"/>
+                <a:ea typeface="Menlo" panose="020B0609030804020204"/>
+                <a:cs typeface="Times New Roman" panose="02020503050405090304" charset="0"/>
+                <a:sym typeface="+mn-ea"/>
+              </a:rPr>
+              <a:t>σ = 0.02</a:t>
+            </a:r>
+            <a:r>
+              <a:rPr lang="en-US" altLang="zh-CN" sz="1600">
+                <a:latin typeface="Times New Roman" panose="02020503050405090304" charset="0"/>
+                <a:ea typeface="Menlo" panose="020B0609030804020204"/>
+                <a:cs typeface="Times New Roman" panose="02020503050405090304" charset="0"/>
+                <a:sym typeface="+mn-ea"/>
+              </a:rPr>
+              <a:t>mg/L</a:t>
+            </a:r>
+            <a:endParaRPr lang="en-US" altLang="zh-CN" sz="1600">
+              <a:latin typeface="Times New Roman" panose="02020503050405090304" charset="0"/>
+              <a:ea typeface="Menlo" panose="020B0609030804020204"/>
+              <a:cs typeface="Times New Roman" panose="02020503050405090304" charset="0"/>
+              <a:sym typeface="+mn-ea"/>
+            </a:endParaRPr>
+          </a:p>
+        </p:txBody>
+      </p:sp>
+      <p:pic>
+        <p:nvPicPr>
+          <p:cNvPr id="6" name="图片 5"/>
+          <p:cNvPicPr>
+            <a:picLocks noChangeAspect="1"/>
+          </p:cNvPicPr>
+          <p:nvPr/>
+        </p:nvPicPr>
+        <p:blipFill>
+          <a:blip r:embed="rId1"/>
+          <a:stretch>
+            <a:fillRect/>
+          </a:stretch>
+        </p:blipFill>
+        <p:spPr>
+          <a:xfrm>
+            <a:off x="294640" y="675005"/>
+            <a:ext cx="10913745" cy="6009640"/>
+          </a:xfrm>
+          <a:prstGeom prst="rect">
+            <a:avLst/>
+          </a:prstGeom>
+        </p:spPr>
+      </p:pic>
+      <p:sp>
+        <p:nvSpPr>
+          <p:cNvPr id="7" name="文本框 6"/>
+          <p:cNvSpPr txBox="1"/>
+          <p:nvPr/>
+        </p:nvSpPr>
+        <p:spPr>
+          <a:xfrm>
+            <a:off x="8063865" y="584200"/>
+            <a:ext cx="3394710" cy="321945"/>
+          </a:xfrm>
+          <a:prstGeom prst="rect">
+            <a:avLst/>
+          </a:prstGeom>
+        </p:spPr>
+        <p:txBody>
+          <a:bodyPr wrap="square">
+            <a:spAutoFit/>
+          </a:bodyPr>
+          <a:p>
+            <a:pPr>
+              <a:lnSpc>
+                <a:spcPts val="1800"/>
+              </a:lnSpc>
+            </a:pPr>
+            <a:r>
+              <a:rPr lang="en-US" altLang="zh-CN" sz="1600" b="0">
+                <a:solidFill>
+                  <a:schemeClr val="tx1"/>
+                </a:solidFill>
+                <a:latin typeface="Times New Roman" panose="02020503050405090304" charset="0"/>
+                <a:ea typeface="Menlo" panose="020B0609030804020204"/>
+                <a:cs typeface="Times New Roman" panose="02020503050405090304" charset="0"/>
+              </a:rPr>
+              <a:t>RMSE ≈  0.019 mg/L</a:t>
+            </a:r>
+            <a:endParaRPr lang="en-US" altLang="zh-CN" sz="1600" b="0">
+              <a:solidFill>
+                <a:schemeClr val="tx1"/>
+              </a:solidFill>
+              <a:latin typeface="Times New Roman" panose="02020503050405090304" charset="0"/>
+              <a:ea typeface="Menlo" panose="020B0609030804020204"/>
+              <a:cs typeface="Times New Roman" panose="02020503050405090304" charset="0"/>
+            </a:endParaRPr>
+          </a:p>
+        </p:txBody>
+      </p:sp>
+      <p:sp>
+        <p:nvSpPr>
+          <p:cNvPr id="8" name="文本框 7"/>
+          <p:cNvSpPr txBox="1"/>
+          <p:nvPr/>
+        </p:nvSpPr>
+        <p:spPr>
+          <a:xfrm>
+            <a:off x="0" y="262255"/>
+            <a:ext cx="6096000" cy="521970"/>
+          </a:xfrm>
+          <a:prstGeom prst="rect">
+            <a:avLst/>
+          </a:prstGeom>
+          <a:noFill/>
+        </p:spPr>
+        <p:txBody>
+          <a:bodyPr wrap="square" rtlCol="0" anchor="t">
+            <a:spAutoFit/>
+          </a:bodyPr>
+          <a:p>
+            <a:r>
+              <a:rPr lang="en-US" altLang="zh-CN" sz="2800" b="1">
+                <a:latin typeface="Times New Roman" panose="02020503050405090304" charset="0"/>
+                <a:cs typeface="Times New Roman" panose="02020503050405090304" charset="0"/>
+              </a:rPr>
+              <a:t>Add random noise to the observations</a:t>
+            </a:r>
+            <a:endParaRPr lang="en-US" altLang="zh-CN" sz="2800" b="1">
+              <a:latin typeface="Times New Roman" panose="02020503050405090304" charset="0"/>
+              <a:cs typeface="Times New Roman" panose="02020503050405090304" charset="0"/>
+            </a:endParaRPr>
+          </a:p>
+        </p:txBody>
+      </p:sp>
+    </p:spTree>
+    <p:custDataLst>
+      <p:tags r:id="rId2"/>
+    </p:custDataLst>
+  </p:cSld>
+  <p:clrMapOvr>
+    <a:masterClrMapping/>
+  </p:clrMapOvr>
+</p:sld>
+</file>
+
+<file path=ppt/slides/slide9.xml><?xml version="1.0" encoding="utf-8"?>
 <p:sld xmlns:a="http://schemas.openxmlformats.org/drawingml/2006/main" xmlns:r="http://schemas.openxmlformats.org/officeDocument/2006/relationships" xmlns:p="http://schemas.openxmlformats.org/presentationml/2006/main">
   <p:cSld>
     <p:spTree>
@@ -4725,96 +6220,197 @@
         </p:blipFill>
         <p:spPr>
           <a:xfrm>
-            <a:off x="0" y="0"/>
-            <a:ext cx="4373245" cy="3869690"/>
+            <a:off x="302260" y="1024890"/>
+            <a:ext cx="6717665" cy="5133975"/>
           </a:xfrm>
           <a:prstGeom prst="rect">
             <a:avLst/>
           </a:prstGeom>
         </p:spPr>
       </p:pic>
-      <p:pic>
-        <p:nvPicPr>
-          <p:cNvPr id="5" name="图片 4"/>
-          <p:cNvPicPr>
-            <a:picLocks noChangeAspect="1"/>
-          </p:cNvPicPr>
+      <p:sp>
+        <p:nvSpPr>
+          <p:cNvPr id="5" name="文本框 4"/>
+          <p:cNvSpPr txBox="1"/>
           <p:nvPr/>
-        </p:nvPicPr>
-        <p:blipFill>
-          <a:blip r:embed="rId2"/>
-          <a:stretch>
-            <a:fillRect/>
-          </a:stretch>
-        </p:blipFill>
-        <p:spPr>
-          <a:xfrm>
-            <a:off x="6422390" y="0"/>
-            <a:ext cx="5497195" cy="3030220"/>
+        </p:nvSpPr>
+        <p:spPr>
+          <a:xfrm>
+            <a:off x="7097395" y="2776855"/>
+            <a:ext cx="5257165" cy="1630045"/>
           </a:xfrm>
           <a:prstGeom prst="rect">
             <a:avLst/>
           </a:prstGeom>
         </p:spPr>
-      </p:pic>
-      <p:pic>
-        <p:nvPicPr>
-          <p:cNvPr id="6" name="图片 5"/>
-          <p:cNvPicPr>
-            <a:picLocks noChangeAspect="1"/>
-          </p:cNvPicPr>
+        <p:txBody>
+          <a:bodyPr wrap="square">
+            <a:spAutoFit/>
+          </a:bodyPr>
+          <a:p>
+            <a:pPr marL="0" indent="0"/>
+            <a:r>
+              <a:rPr lang="en-US" altLang="zh-CN" sz="2000" b="1" i="0">
+                <a:latin typeface="Times New Roman" panose="02020503050405090304" charset="0"/>
+                <a:ea typeface="Menlo" panose="020B0609030804020204"/>
+                <a:cs typeface="Times New Roman" panose="02020503050405090304" charset="0"/>
+              </a:rPr>
+              <a:t>Best grid:</a:t>
+            </a:r>
+            <a:r>
+              <a:rPr lang="en-US" altLang="zh-CN" sz="2000" b="0" i="0">
+                <a:latin typeface="Times New Roman" panose="02020503050405090304" charset="0"/>
+                <a:ea typeface="Menlo" panose="020B0609030804020204"/>
+                <a:cs typeface="Times New Roman" panose="02020503050405090304" charset="0"/>
+              </a:rPr>
+              <a:t> </a:t>
+            </a:r>
+            <a:endParaRPr lang="en-US" altLang="zh-CN" sz="2000" b="0" i="0">
+              <a:latin typeface="Times New Roman" panose="02020503050405090304" charset="0"/>
+              <a:ea typeface="Menlo" panose="020B0609030804020204"/>
+              <a:cs typeface="Times New Roman" panose="02020503050405090304" charset="0"/>
+            </a:endParaRPr>
+          </a:p>
+          <a:p>
+            <a:pPr marL="0" indent="0"/>
+            <a:r>
+              <a:rPr lang="en-US" altLang="zh-CN" sz="2000" b="0" i="0">
+                <a:latin typeface="Times New Roman" panose="02020503050405090304" charset="0"/>
+                <a:ea typeface="Menlo" panose="020B0609030804020204"/>
+                <a:cs typeface="Times New Roman" panose="02020503050405090304" charset="0"/>
+              </a:rPr>
+              <a:t>kw_old_hat = -1.000,  kw_new</a:t>
+            </a:r>
+            <a:r>
+              <a:rPr lang="en-US" altLang="zh-CN" sz="2000">
+                <a:latin typeface="Times New Roman" panose="02020503050405090304" charset="0"/>
+                <a:ea typeface="Menlo" panose="020B0609030804020204"/>
+                <a:cs typeface="Times New Roman" panose="02020503050405090304" charset="0"/>
+                <a:sym typeface="+mn-ea"/>
+              </a:rPr>
+              <a:t>_hat</a:t>
+            </a:r>
+            <a:r>
+              <a:rPr lang="en-US" altLang="zh-CN" sz="2000" b="0" i="0">
+                <a:latin typeface="Times New Roman" panose="02020503050405090304" charset="0"/>
+                <a:ea typeface="Menlo" panose="020B0609030804020204"/>
+                <a:cs typeface="Times New Roman" panose="02020503050405090304" charset="0"/>
+              </a:rPr>
+              <a:t> = -0.037</a:t>
+            </a:r>
+            <a:endParaRPr lang="en-US" altLang="zh-CN" sz="2000" b="0" i="0">
+              <a:latin typeface="Times New Roman" panose="02020503050405090304" charset="0"/>
+              <a:ea typeface="Menlo" panose="020B0609030804020204"/>
+              <a:cs typeface="Times New Roman" panose="02020503050405090304" charset="0"/>
+            </a:endParaRPr>
+          </a:p>
+          <a:p>
+            <a:pPr marL="0" indent="0"/>
+            <a:r>
+              <a:rPr lang="en-US" altLang="zh-CN" sz="2000" b="0" i="0">
+                <a:latin typeface="Times New Roman" panose="02020503050405090304" charset="0"/>
+                <a:ea typeface="Menlo" panose="020B0609030804020204"/>
+                <a:cs typeface="Times New Roman" panose="02020503050405090304" charset="0"/>
+              </a:rPr>
+              <a:t> </a:t>
+            </a:r>
+            <a:endParaRPr lang="en-US" altLang="zh-CN" sz="2000" b="0" i="0">
+              <a:latin typeface="Times New Roman" panose="02020503050405090304" charset="0"/>
+              <a:ea typeface="Menlo" panose="020B0609030804020204"/>
+              <a:cs typeface="Times New Roman" panose="02020503050405090304" charset="0"/>
+            </a:endParaRPr>
+          </a:p>
+          <a:p>
+            <a:pPr marL="0" indent="0"/>
+            <a:r>
+              <a:rPr lang="en-US" altLang="zh-CN" sz="2000" b="1" i="0">
+                <a:latin typeface="Times New Roman" panose="02020503050405090304" charset="0"/>
+                <a:ea typeface="Menlo" panose="020B0609030804020204"/>
+                <a:cs typeface="Times New Roman" panose="02020503050405090304" charset="0"/>
+              </a:rPr>
+              <a:t>True : </a:t>
+            </a:r>
+            <a:endParaRPr lang="en-US" altLang="zh-CN" sz="2000" b="1" i="0">
+              <a:latin typeface="Times New Roman" panose="02020503050405090304" charset="0"/>
+              <a:ea typeface="Menlo" panose="020B0609030804020204"/>
+              <a:cs typeface="Times New Roman" panose="02020503050405090304" charset="0"/>
+            </a:endParaRPr>
+          </a:p>
+          <a:p>
+            <a:pPr marL="0" indent="0"/>
+            <a:r>
+              <a:rPr lang="en-US" altLang="zh-CN" sz="2000" b="0" i="0">
+                <a:latin typeface="Times New Roman" panose="02020503050405090304" charset="0"/>
+                <a:ea typeface="Menlo" panose="020B0609030804020204"/>
+                <a:cs typeface="Times New Roman" panose="02020503050405090304" charset="0"/>
+              </a:rPr>
+              <a:t>kw_old = -1.000, kw_new = -0.050</a:t>
+            </a:r>
+            <a:endParaRPr lang="en-US" altLang="zh-CN" sz="2000" b="0" i="0">
+              <a:latin typeface="Times New Roman" panose="02020503050405090304" charset="0"/>
+              <a:ea typeface="Menlo" panose="020B0609030804020204"/>
+              <a:cs typeface="Times New Roman" panose="02020503050405090304" charset="0"/>
+            </a:endParaRPr>
+          </a:p>
+        </p:txBody>
+      </p:sp>
+      <p:sp>
+        <p:nvSpPr>
+          <p:cNvPr id="6" name="文本框 5"/>
+          <p:cNvSpPr txBox="1"/>
           <p:nvPr/>
-        </p:nvPicPr>
-        <p:blipFill>
-          <a:blip r:embed="rId3"/>
-          <a:stretch>
-            <a:fillRect/>
-          </a:stretch>
-        </p:blipFill>
-        <p:spPr>
-          <a:xfrm>
-            <a:off x="6150610" y="2915920"/>
-            <a:ext cx="6041390" cy="3330575"/>
+        </p:nvSpPr>
+        <p:spPr>
+          <a:xfrm>
+            <a:off x="302260" y="343535"/>
+            <a:ext cx="5080000" cy="519430"/>
           </a:xfrm>
           <a:prstGeom prst="rect">
             <a:avLst/>
           </a:prstGeom>
         </p:spPr>
-      </p:pic>
-      <p:pic>
-        <p:nvPicPr>
-          <p:cNvPr id="7" name="图片 6"/>
-          <p:cNvPicPr>
-            <a:picLocks noChangeAspect="1"/>
-          </p:cNvPicPr>
-          <p:nvPr/>
-        </p:nvPicPr>
-        <p:blipFill>
-          <a:blip r:embed="rId4"/>
-          <a:stretch>
-            <a:fillRect/>
-          </a:stretch>
-        </p:blipFill>
-        <p:spPr>
-          <a:xfrm>
-            <a:off x="165100" y="3869690"/>
-            <a:ext cx="4663440" cy="2045970"/>
-          </a:xfrm>
-          <a:prstGeom prst="rect">
-            <a:avLst/>
-          </a:prstGeom>
-        </p:spPr>
-      </p:pic>
-      <p:sp>
-        <p:nvSpPr>
-          <p:cNvPr id="8" name="文本框 7"/>
+        <p:txBody>
+          <a:bodyPr>
+            <a:noAutofit/>
+          </a:bodyPr>
+          <a:p>
+            <a:pPr>
+              <a:lnSpc>
+                <a:spcPts val="1800"/>
+              </a:lnSpc>
+            </a:pPr>
+            <a:r>
+              <a:rPr lang="en-US" altLang="zh-CN" sz="3200" b="1">
+                <a:solidFill>
+                  <a:schemeClr val="tx1"/>
+                </a:solidFill>
+                <a:latin typeface="Times New Roman" panose="02020503050405090304" charset="0"/>
+                <a:ea typeface="Menlo" panose="020B0609030804020204"/>
+                <a:cs typeface="Times New Roman" panose="02020503050405090304" charset="0"/>
+              </a:rPr>
+              <a:t>Inverse</a:t>
+            </a:r>
+            <a:endParaRPr lang="en-US" altLang="zh-CN" sz="3200" b="1">
+              <a:solidFill>
+                <a:schemeClr val="tx1"/>
+              </a:solidFill>
+              <a:latin typeface="Times New Roman" panose="02020503050405090304" charset="0"/>
+              <a:ea typeface="Menlo" panose="020B0609030804020204"/>
+              <a:cs typeface="Times New Roman" panose="02020503050405090304" charset="0"/>
+            </a:endParaRPr>
+          </a:p>
+        </p:txBody>
+      </p:sp>
+      <p:sp>
+        <p:nvSpPr>
+          <p:cNvPr id="2" name="文本框 1"/>
           <p:cNvSpPr txBox="1"/>
           <p:nvPr/>
         </p:nvSpPr>
         <p:spPr>
           <a:xfrm>
-            <a:off x="54610" y="5915660"/>
-            <a:ext cx="6096000" cy="922020"/>
+            <a:off x="7019925" y="1409065"/>
+            <a:ext cx="2843530" cy="368300"/>
           </a:xfrm>
           <a:prstGeom prst="rect">
             <a:avLst/>
@@ -4827,156 +6423,24 @@
           </a:bodyPr>
           <a:p>
             <a:r>
-              <a:rPr lang="en-US" altLang="zh-CN"/>
-              <a:t>To make the change more apparent, the result can be obtained through subsequent inversion, so I fixed the position of the old pipe.</a:t>
-            </a:r>
-            <a:endParaRPr lang="zh-CN" altLang="en-US"/>
+              <a:rPr lang="en-US" altLang="zh-CN">
+                <a:latin typeface="Times New Roman Regular" panose="02020503050405090304" charset="0"/>
+                <a:cs typeface="Times New Roman Regular" panose="02020503050405090304" charset="0"/>
+                <a:sym typeface="+mn-ea"/>
+              </a:rPr>
+              <a:t>sum of squared errors (SSE) </a:t>
+            </a:r>
+            <a:endParaRPr lang="en-US" altLang="zh-CN">
+              <a:latin typeface="Times New Roman Regular" panose="02020503050405090304" charset="0"/>
+              <a:cs typeface="Times New Roman Regular" panose="02020503050405090304" charset="0"/>
+              <a:sym typeface="+mn-ea"/>
+            </a:endParaRPr>
           </a:p>
         </p:txBody>
       </p:sp>
     </p:spTree>
     <p:custDataLst>
-      <p:tags r:id="rId5"/>
-    </p:custDataLst>
-  </p:cSld>
-  <p:clrMapOvr>
-    <a:masterClrMapping/>
-  </p:clrMapOvr>
-</p:sld>
-</file>
-
-<file path=ppt/slides/slide8.xml><?xml version="1.0" encoding="utf-8"?>
-<p:sld xmlns:a="http://schemas.openxmlformats.org/drawingml/2006/main" xmlns:r="http://schemas.openxmlformats.org/officeDocument/2006/relationships" xmlns:p="http://schemas.openxmlformats.org/presentationml/2006/main">
-  <p:cSld>
-    <p:spTree>
-      <p:nvGrpSpPr>
-        <p:cNvPr id="1" name=""/>
-        <p:cNvGrpSpPr/>
-        <p:nvPr/>
-      </p:nvGrpSpPr>
-      <p:grpSpPr>
-        <a:xfrm>
-          <a:off x="0" y="0"/>
-          <a:ext cx="0" cy="0"/>
-          <a:chOff x="0" y="0"/>
-          <a:chExt cx="0" cy="0"/>
-        </a:xfrm>
-      </p:grpSpPr>
-      <p:sp>
-        <p:nvSpPr>
-          <p:cNvPr id="2" name="标题 1"/>
-          <p:cNvSpPr>
-            <a:spLocks noGrp="1"/>
-          </p:cNvSpPr>
-          <p:nvPr>
-            <p:ph type="ctrTitle"/>
-            <p:custDataLst>
-              <p:tags r:id="rId1"/>
-            </p:custDataLst>
-          </p:nvPr>
-        </p:nvSpPr>
-        <p:spPr/>
-        <p:txBody>
-          <a:bodyPr/>
-          <a:p>
-            <a:endParaRPr lang="zh-CN" altLang="zh-CN"/>
-          </a:p>
-        </p:txBody>
-      </p:sp>
-      <p:sp>
-        <p:nvSpPr>
-          <p:cNvPr id="3" name="副标题 2"/>
-          <p:cNvSpPr>
-            <a:spLocks noGrp="1"/>
-          </p:cNvSpPr>
-          <p:nvPr>
-            <p:ph type="subTitle" idx="1"/>
-            <p:custDataLst>
-              <p:tags r:id="rId2"/>
-            </p:custDataLst>
-          </p:nvPr>
-        </p:nvSpPr>
-        <p:spPr/>
-        <p:txBody>
-          <a:bodyPr/>
-          <a:p>
-            <a:endParaRPr lang="zh-CN" altLang="en-US"/>
-          </a:p>
-        </p:txBody>
-      </p:sp>
-    </p:spTree>
-    <p:custDataLst>
-      <p:tags r:id="rId3"/>
-    </p:custDataLst>
-  </p:cSld>
-  <p:clrMapOvr>
-    <a:masterClrMapping/>
-  </p:clrMapOvr>
-</p:sld>
-</file>
-
-<file path=ppt/slides/slide9.xml><?xml version="1.0" encoding="utf-8"?>
-<p:sld xmlns:a="http://schemas.openxmlformats.org/drawingml/2006/main" xmlns:r="http://schemas.openxmlformats.org/officeDocument/2006/relationships" xmlns:p="http://schemas.openxmlformats.org/presentationml/2006/main">
-  <p:cSld>
-    <p:spTree>
-      <p:nvGrpSpPr>
-        <p:cNvPr id="1" name=""/>
-        <p:cNvGrpSpPr/>
-        <p:nvPr/>
-      </p:nvGrpSpPr>
-      <p:grpSpPr>
-        <a:xfrm>
-          <a:off x="0" y="0"/>
-          <a:ext cx="0" cy="0"/>
-          <a:chOff x="0" y="0"/>
-          <a:chExt cx="0" cy="0"/>
-        </a:xfrm>
-      </p:grpSpPr>
-      <p:sp>
-        <p:nvSpPr>
-          <p:cNvPr id="2" name="标题 1"/>
-          <p:cNvSpPr>
-            <a:spLocks noGrp="1"/>
-          </p:cNvSpPr>
-          <p:nvPr>
-            <p:ph type="ctrTitle"/>
-            <p:custDataLst>
-              <p:tags r:id="rId1"/>
-            </p:custDataLst>
-          </p:nvPr>
-        </p:nvSpPr>
-        <p:spPr/>
-        <p:txBody>
-          <a:bodyPr/>
-          <a:p>
-            <a:endParaRPr lang="zh-CN" altLang="zh-CN"/>
-          </a:p>
-        </p:txBody>
-      </p:sp>
-      <p:sp>
-        <p:nvSpPr>
-          <p:cNvPr id="3" name="副标题 2"/>
-          <p:cNvSpPr>
-            <a:spLocks noGrp="1"/>
-          </p:cNvSpPr>
-          <p:nvPr>
-            <p:ph type="subTitle" idx="1"/>
-            <p:custDataLst>
-              <p:tags r:id="rId2"/>
-            </p:custDataLst>
-          </p:nvPr>
-        </p:nvSpPr>
-        <p:spPr/>
-        <p:txBody>
-          <a:bodyPr/>
-          <a:p>
-            <a:endParaRPr lang="zh-CN" altLang="en-US"/>
-          </a:p>
-        </p:txBody>
-      </p:sp>
-    </p:spTree>
-    <p:custDataLst>
-      <p:tags r:id="rId3"/>
+      <p:tags r:id="rId2"/>
     </p:custDataLst>
   </p:cSld>
   <p:clrMapOvr>
@@ -5758,50 +7222,6 @@
 </file>
 
 <file path=ppt/tags/tag63.xml><?xml version="1.0" encoding="utf-8"?>
-<p:tagLst xmlns:p="http://schemas.openxmlformats.org/presentationml/2006/main">
-  <p:tag name="KSO_WM_UNIT_ISCONTENTSTITLE" val="0"/>
-  <p:tag name="KSO_WM_UNIT_ISNUMDGMTITLE" val="0"/>
-  <p:tag name="KSO_WM_UNIT_NOCLEAR" val="0"/>
-  <p:tag name="KSO_WM_UNIT_SHOW_EDIT_AREA_INDICATION" val="1"/>
-  <p:tag name="KSO_WM_UNIT_VALUE" val="28"/>
-  <p:tag name="KSO_WM_UNIT_HIGHLIGHT" val="0"/>
-  <p:tag name="KSO_WM_UNIT_COMPATIBLE" val="0"/>
-  <p:tag name="KSO_WM_UNIT_DIAGRAM_ISNUMVISUAL" val="0"/>
-  <p:tag name="KSO_WM_UNIT_DIAGRAM_ISREFERUNIT" val="0"/>
-  <p:tag name="KSO_WM_UNIT_TYPE" val="a"/>
-  <p:tag name="KSO_WM_UNIT_INDEX" val="1"/>
-  <p:tag name="KSO_WM_UNIT_ID" val="custom20205081_1*a*1"/>
-  <p:tag name="KSO_WM_TEMPLATE_CATEGORY" val="custom"/>
-  <p:tag name="KSO_WM_TEMPLATE_INDEX" val="20205081"/>
-  <p:tag name="KSO_WM_UNIT_LAYERLEVEL" val="1"/>
-  <p:tag name="KSO_WM_TAG_VERSION" val="1.0"/>
-  <p:tag name="KSO_WM_BEAUTIFY_FLAG" val="#wm#"/>
-</p:tagLst>
-</file>
-
-<file path=ppt/tags/tag64.xml><?xml version="1.0" encoding="utf-8"?>
-<p:tagLst xmlns:p="http://schemas.openxmlformats.org/presentationml/2006/main">
-  <p:tag name="KSO_WM_UNIT_ISCONTENTSTITLE" val="0"/>
-  <p:tag name="KSO_WM_UNIT_ISNUMDGMTITLE" val="0"/>
-  <p:tag name="KSO_WM_UNIT_NOCLEAR" val="0"/>
-  <p:tag name="KSO_WM_UNIT_SHOW_EDIT_AREA_INDICATION" val="1"/>
-  <p:tag name="KSO_WM_UNIT_VALUE" val="111"/>
-  <p:tag name="KSO_WM_UNIT_HIGHLIGHT" val="0"/>
-  <p:tag name="KSO_WM_UNIT_COMPATIBLE" val="0"/>
-  <p:tag name="KSO_WM_UNIT_DIAGRAM_ISNUMVISUAL" val="0"/>
-  <p:tag name="KSO_WM_UNIT_DIAGRAM_ISREFERUNIT" val="0"/>
-  <p:tag name="KSO_WM_UNIT_TYPE" val="b"/>
-  <p:tag name="KSO_WM_UNIT_INDEX" val="1"/>
-  <p:tag name="KSO_WM_UNIT_ID" val="custom20205081_1*b*1"/>
-  <p:tag name="KSO_WM_TEMPLATE_CATEGORY" val="custom"/>
-  <p:tag name="KSO_WM_TEMPLATE_INDEX" val="20205081"/>
-  <p:tag name="KSO_WM_UNIT_LAYERLEVEL" val="1"/>
-  <p:tag name="KSO_WM_TAG_VERSION" val="1.0"/>
-  <p:tag name="KSO_WM_BEAUTIFY_FLAG" val="#wm#"/>
-</p:tagLst>
-</file>
-
-<file path=ppt/tags/tag65.xml><?xml version="1.0" encoding="utf-8"?>
 <p:tagLst xmlns:p="http://schemas.openxmlformats.org/presentationml/2006/main">
   <p:tag name="KSO_WM_SLIDE_ID" val="custom20205081_1"/>
   <p:tag name="KSO_WM_TEMPLATE_SUBCATEGORY" val="19"/>
@@ -5822,7 +7242,7 @@
 </p:tagLst>
 </file>
 
-<file path=ppt/tags/tag66.xml><?xml version="1.0" encoding="utf-8"?>
+<file path=ppt/tags/tag64.xml><?xml version="1.0" encoding="utf-8"?>
 <p:tagLst xmlns:p="http://schemas.openxmlformats.org/presentationml/2006/main">
   <p:tag name="KSO_WM_SLIDE_ID" val="custom20205081_1"/>
   <p:tag name="KSO_WM_TEMPLATE_SUBCATEGORY" val="19"/>
@@ -5840,6 +7260,22 @@
   <p:tag name="KSO_WM_SLIDE_LAYOUT_CNT" val="1_1"/>
   <p:tag name="KSO_WM_UNIT_SHOW_EDIT_AREA_INDICATION" val="1"/>
   <p:tag name="KSO_WM_TEMPLATE_THUMBS_INDEX" val="1、4、7、12、13、14、15、16、17、18、20、24、25、28、33、36、40、43、44"/>
+</p:tagLst>
+</file>
+
+<file path=ppt/tags/tag65.xml><?xml version="1.0" encoding="utf-8"?>
+<p:tagLst xmlns:p="http://schemas.openxmlformats.org/presentationml/2006/main">
+  <p:tag name="KSO_WM_BEAUTIFY_FLAG" val="#wm#"/>
+  <p:tag name="KSO_WM_TEMPLATE_CATEGORY" val="custom"/>
+  <p:tag name="KSO_WM_TEMPLATE_INDEX" val="20205081"/>
+</p:tagLst>
+</file>
+
+<file path=ppt/tags/tag66.xml><?xml version="1.0" encoding="utf-8"?>
+<p:tagLst xmlns:p="http://schemas.openxmlformats.org/presentationml/2006/main">
+  <p:tag name="KSO_WM_BEAUTIFY_FLAG" val="#wm#"/>
+  <p:tag name="KSO_WM_TEMPLATE_CATEGORY" val="custom"/>
+  <p:tag name="KSO_WM_TEMPLATE_INDEX" val="20205081"/>
 </p:tagLst>
 </file>
 
@@ -5961,180 +7397,6 @@
 </p:tagLst>
 </file>
 
-<file path=ppt/tags/tag72.xml><?xml version="1.0" encoding="utf-8"?>
-<p:tagLst xmlns:p="http://schemas.openxmlformats.org/presentationml/2006/main">
-  <p:tag name="KSO_WM_UNIT_ISCONTENTSTITLE" val="0"/>
-  <p:tag name="KSO_WM_UNIT_ISNUMDGMTITLE" val="0"/>
-  <p:tag name="KSO_WM_UNIT_NOCLEAR" val="0"/>
-  <p:tag name="KSO_WM_UNIT_SHOW_EDIT_AREA_INDICATION" val="1"/>
-  <p:tag name="KSO_WM_UNIT_VALUE" val="28"/>
-  <p:tag name="KSO_WM_UNIT_HIGHLIGHT" val="0"/>
-  <p:tag name="KSO_WM_UNIT_COMPATIBLE" val="0"/>
-  <p:tag name="KSO_WM_UNIT_DIAGRAM_ISNUMVISUAL" val="0"/>
-  <p:tag name="KSO_WM_UNIT_DIAGRAM_ISREFERUNIT" val="0"/>
-  <p:tag name="KSO_WM_UNIT_TYPE" val="a"/>
-  <p:tag name="KSO_WM_UNIT_INDEX" val="1"/>
-  <p:tag name="KSO_WM_UNIT_ID" val="custom20205081_1*a*1"/>
-  <p:tag name="KSO_WM_TEMPLATE_CATEGORY" val="custom"/>
-  <p:tag name="KSO_WM_TEMPLATE_INDEX" val="20205081"/>
-  <p:tag name="KSO_WM_UNIT_LAYERLEVEL" val="1"/>
-  <p:tag name="KSO_WM_TAG_VERSION" val="1.0"/>
-  <p:tag name="KSO_WM_BEAUTIFY_FLAG" val="#wm#"/>
-</p:tagLst>
-</file>
-
-<file path=ppt/tags/tag73.xml><?xml version="1.0" encoding="utf-8"?>
-<p:tagLst xmlns:p="http://schemas.openxmlformats.org/presentationml/2006/main">
-  <p:tag name="KSO_WM_UNIT_ISCONTENTSTITLE" val="0"/>
-  <p:tag name="KSO_WM_UNIT_ISNUMDGMTITLE" val="0"/>
-  <p:tag name="KSO_WM_UNIT_NOCLEAR" val="0"/>
-  <p:tag name="KSO_WM_UNIT_SHOW_EDIT_AREA_INDICATION" val="1"/>
-  <p:tag name="KSO_WM_UNIT_VALUE" val="111"/>
-  <p:tag name="KSO_WM_UNIT_HIGHLIGHT" val="0"/>
-  <p:tag name="KSO_WM_UNIT_COMPATIBLE" val="0"/>
-  <p:tag name="KSO_WM_UNIT_DIAGRAM_ISNUMVISUAL" val="0"/>
-  <p:tag name="KSO_WM_UNIT_DIAGRAM_ISREFERUNIT" val="0"/>
-  <p:tag name="KSO_WM_UNIT_TYPE" val="b"/>
-  <p:tag name="KSO_WM_UNIT_INDEX" val="1"/>
-  <p:tag name="KSO_WM_UNIT_ID" val="custom20205081_1*b*1"/>
-  <p:tag name="KSO_WM_TEMPLATE_CATEGORY" val="custom"/>
-  <p:tag name="KSO_WM_TEMPLATE_INDEX" val="20205081"/>
-  <p:tag name="KSO_WM_UNIT_LAYERLEVEL" val="1"/>
-  <p:tag name="KSO_WM_TAG_VERSION" val="1.0"/>
-  <p:tag name="KSO_WM_BEAUTIFY_FLAG" val="#wm#"/>
-</p:tagLst>
-</file>
-
-<file path=ppt/tags/tag74.xml><?xml version="1.0" encoding="utf-8"?>
-<p:tagLst xmlns:p="http://schemas.openxmlformats.org/presentationml/2006/main">
-  <p:tag name="KSO_WM_SLIDE_ID" val="custom20205081_1"/>
-  <p:tag name="KSO_WM_TEMPLATE_SUBCATEGORY" val="19"/>
-  <p:tag name="KSO_WM_TEMPLATE_MASTER_TYPE" val="0"/>
-  <p:tag name="KSO_WM_TEMPLATE_COLOR_TYPE" val="1"/>
-  <p:tag name="KSO_WM_SLIDE_TYPE" val="title"/>
-  <p:tag name="KSO_WM_SLIDE_SUBTYPE" val="defaultBlank"/>
-  <p:tag name="KSO_WM_SLIDE_ITEM_CNT" val="0"/>
-  <p:tag name="KSO_WM_SLIDE_INDEX" val="1"/>
-  <p:tag name="KSO_WM_TAG_VERSION" val="1.0"/>
-  <p:tag name="KSO_WM_BEAUTIFY_FLAG" val="#wm#"/>
-  <p:tag name="KSO_WM_TEMPLATE_CATEGORY" val="custom"/>
-  <p:tag name="KSO_WM_TEMPLATE_INDEX" val="20205081"/>
-  <p:tag name="KSO_WM_SLIDE_LAYOUT" val="a_b"/>
-  <p:tag name="KSO_WM_SLIDE_LAYOUT_CNT" val="1_1"/>
-  <p:tag name="KSO_WM_UNIT_SHOW_EDIT_AREA_INDICATION" val="1"/>
-  <p:tag name="KSO_WM_TEMPLATE_THUMBS_INDEX" val="1、4、7、12、13、14、15、16、17、18、20、24、25、28、33、36、40、43、44"/>
-</p:tagLst>
-</file>
-
-<file path=ppt/tags/tag75.xml><?xml version="1.0" encoding="utf-8"?>
-<p:tagLst xmlns:p="http://schemas.openxmlformats.org/presentationml/2006/main">
-  <p:tag name="KSO_WM_UNIT_ISCONTENTSTITLE" val="0"/>
-  <p:tag name="KSO_WM_UNIT_ISNUMDGMTITLE" val="0"/>
-  <p:tag name="KSO_WM_UNIT_NOCLEAR" val="0"/>
-  <p:tag name="KSO_WM_UNIT_SHOW_EDIT_AREA_INDICATION" val="1"/>
-  <p:tag name="KSO_WM_UNIT_VALUE" val="28"/>
-  <p:tag name="KSO_WM_UNIT_HIGHLIGHT" val="0"/>
-  <p:tag name="KSO_WM_UNIT_COMPATIBLE" val="0"/>
-  <p:tag name="KSO_WM_UNIT_DIAGRAM_ISNUMVISUAL" val="0"/>
-  <p:tag name="KSO_WM_UNIT_DIAGRAM_ISREFERUNIT" val="0"/>
-  <p:tag name="KSO_WM_UNIT_TYPE" val="a"/>
-  <p:tag name="KSO_WM_UNIT_INDEX" val="1"/>
-  <p:tag name="KSO_WM_UNIT_ID" val="custom20205081_1*a*1"/>
-  <p:tag name="KSO_WM_TEMPLATE_CATEGORY" val="custom"/>
-  <p:tag name="KSO_WM_TEMPLATE_INDEX" val="20205081"/>
-  <p:tag name="KSO_WM_UNIT_LAYERLEVEL" val="1"/>
-  <p:tag name="KSO_WM_TAG_VERSION" val="1.0"/>
-  <p:tag name="KSO_WM_BEAUTIFY_FLAG" val="#wm#"/>
-</p:tagLst>
-</file>
-
-<file path=ppt/tags/tag76.xml><?xml version="1.0" encoding="utf-8"?>
-<p:tagLst xmlns:p="http://schemas.openxmlformats.org/presentationml/2006/main">
-  <p:tag name="KSO_WM_UNIT_ISCONTENTSTITLE" val="0"/>
-  <p:tag name="KSO_WM_UNIT_ISNUMDGMTITLE" val="0"/>
-  <p:tag name="KSO_WM_UNIT_NOCLEAR" val="0"/>
-  <p:tag name="KSO_WM_UNIT_SHOW_EDIT_AREA_INDICATION" val="1"/>
-  <p:tag name="KSO_WM_UNIT_VALUE" val="111"/>
-  <p:tag name="KSO_WM_UNIT_HIGHLIGHT" val="0"/>
-  <p:tag name="KSO_WM_UNIT_COMPATIBLE" val="0"/>
-  <p:tag name="KSO_WM_UNIT_DIAGRAM_ISNUMVISUAL" val="0"/>
-  <p:tag name="KSO_WM_UNIT_DIAGRAM_ISREFERUNIT" val="0"/>
-  <p:tag name="KSO_WM_UNIT_TYPE" val="b"/>
-  <p:tag name="KSO_WM_UNIT_INDEX" val="1"/>
-  <p:tag name="KSO_WM_UNIT_ID" val="custom20205081_1*b*1"/>
-  <p:tag name="KSO_WM_TEMPLATE_CATEGORY" val="custom"/>
-  <p:tag name="KSO_WM_TEMPLATE_INDEX" val="20205081"/>
-  <p:tag name="KSO_WM_UNIT_LAYERLEVEL" val="1"/>
-  <p:tag name="KSO_WM_TAG_VERSION" val="1.0"/>
-  <p:tag name="KSO_WM_BEAUTIFY_FLAG" val="#wm#"/>
-</p:tagLst>
-</file>
-
-<file path=ppt/tags/tag77.xml><?xml version="1.0" encoding="utf-8"?>
-<p:tagLst xmlns:p="http://schemas.openxmlformats.org/presentationml/2006/main">
-  <p:tag name="KSO_WM_SLIDE_ID" val="custom20205081_1"/>
-  <p:tag name="KSO_WM_TEMPLATE_SUBCATEGORY" val="19"/>
-  <p:tag name="KSO_WM_TEMPLATE_MASTER_TYPE" val="0"/>
-  <p:tag name="KSO_WM_TEMPLATE_COLOR_TYPE" val="1"/>
-  <p:tag name="KSO_WM_SLIDE_TYPE" val="title"/>
-  <p:tag name="KSO_WM_SLIDE_SUBTYPE" val="defaultBlank"/>
-  <p:tag name="KSO_WM_SLIDE_ITEM_CNT" val="0"/>
-  <p:tag name="KSO_WM_SLIDE_INDEX" val="1"/>
-  <p:tag name="KSO_WM_TAG_VERSION" val="1.0"/>
-  <p:tag name="KSO_WM_BEAUTIFY_FLAG" val="#wm#"/>
-  <p:tag name="KSO_WM_TEMPLATE_CATEGORY" val="custom"/>
-  <p:tag name="KSO_WM_TEMPLATE_INDEX" val="20205081"/>
-  <p:tag name="KSO_WM_SLIDE_LAYOUT" val="a_b"/>
-  <p:tag name="KSO_WM_SLIDE_LAYOUT_CNT" val="1_1"/>
-  <p:tag name="KSO_WM_UNIT_SHOW_EDIT_AREA_INDICATION" val="1"/>
-  <p:tag name="KSO_WM_TEMPLATE_THUMBS_INDEX" val="1、4、7、12、13、14、15、16、17、18、20、24、25、28、33、36、40、43、44"/>
-</p:tagLst>
-</file>
-
-<file path=ppt/tags/tag78.xml><?xml version="1.0" encoding="utf-8"?>
-<p:tagLst xmlns:p="http://schemas.openxmlformats.org/presentationml/2006/main">
-  <p:tag name="KSO_WM_UNIT_ISCONTENTSTITLE" val="0"/>
-  <p:tag name="KSO_WM_UNIT_ISNUMDGMTITLE" val="0"/>
-  <p:tag name="KSO_WM_UNIT_NOCLEAR" val="0"/>
-  <p:tag name="KSO_WM_UNIT_SHOW_EDIT_AREA_INDICATION" val="1"/>
-  <p:tag name="KSO_WM_UNIT_VALUE" val="28"/>
-  <p:tag name="KSO_WM_UNIT_HIGHLIGHT" val="0"/>
-  <p:tag name="KSO_WM_UNIT_COMPATIBLE" val="0"/>
-  <p:tag name="KSO_WM_UNIT_DIAGRAM_ISNUMVISUAL" val="0"/>
-  <p:tag name="KSO_WM_UNIT_DIAGRAM_ISREFERUNIT" val="0"/>
-  <p:tag name="KSO_WM_UNIT_TYPE" val="a"/>
-  <p:tag name="KSO_WM_UNIT_INDEX" val="1"/>
-  <p:tag name="KSO_WM_UNIT_ID" val="custom20205081_1*a*1"/>
-  <p:tag name="KSO_WM_TEMPLATE_CATEGORY" val="custom"/>
-  <p:tag name="KSO_WM_TEMPLATE_INDEX" val="20205081"/>
-  <p:tag name="KSO_WM_UNIT_LAYERLEVEL" val="1"/>
-  <p:tag name="KSO_WM_TAG_VERSION" val="1.0"/>
-  <p:tag name="KSO_WM_BEAUTIFY_FLAG" val="#wm#"/>
-</p:tagLst>
-</file>
-
-<file path=ppt/tags/tag79.xml><?xml version="1.0" encoding="utf-8"?>
-<p:tagLst xmlns:p="http://schemas.openxmlformats.org/presentationml/2006/main">
-  <p:tag name="KSO_WM_UNIT_ISCONTENTSTITLE" val="0"/>
-  <p:tag name="KSO_WM_UNIT_ISNUMDGMTITLE" val="0"/>
-  <p:tag name="KSO_WM_UNIT_NOCLEAR" val="0"/>
-  <p:tag name="KSO_WM_UNIT_SHOW_EDIT_AREA_INDICATION" val="1"/>
-  <p:tag name="KSO_WM_UNIT_VALUE" val="111"/>
-  <p:tag name="KSO_WM_UNIT_HIGHLIGHT" val="0"/>
-  <p:tag name="KSO_WM_UNIT_COMPATIBLE" val="0"/>
-  <p:tag name="KSO_WM_UNIT_DIAGRAM_ISNUMVISUAL" val="0"/>
-  <p:tag name="KSO_WM_UNIT_DIAGRAM_ISREFERUNIT" val="0"/>
-  <p:tag name="KSO_WM_UNIT_TYPE" val="b"/>
-  <p:tag name="KSO_WM_UNIT_INDEX" val="1"/>
-  <p:tag name="KSO_WM_UNIT_ID" val="custom20205081_1*b*1"/>
-  <p:tag name="KSO_WM_TEMPLATE_CATEGORY" val="custom"/>
-  <p:tag name="KSO_WM_TEMPLATE_INDEX" val="20205081"/>
-  <p:tag name="KSO_WM_UNIT_LAYERLEVEL" val="1"/>
-  <p:tag name="KSO_WM_TAG_VERSION" val="1.0"/>
-  <p:tag name="KSO_WM_BEAUTIFY_FLAG" val="#wm#"/>
-</p:tagLst>
-</file>
-
 <file path=ppt/tags/tag8.xml><?xml version="1.0" encoding="utf-8"?>
 <p:tagLst xmlns:p="http://schemas.openxmlformats.org/presentationml/2006/main">
   <p:tag name="KSO_WM_UNIT_HIGHLIGHT" val="0"/>
@@ -6148,222 +7410,6 @@
 </p:tagLst>
 </file>
 
-<file path=ppt/tags/tag80.xml><?xml version="1.0" encoding="utf-8"?>
-<p:tagLst xmlns:p="http://schemas.openxmlformats.org/presentationml/2006/main">
-  <p:tag name="KSO_WM_SLIDE_ID" val="custom20205081_1"/>
-  <p:tag name="KSO_WM_TEMPLATE_SUBCATEGORY" val="19"/>
-  <p:tag name="KSO_WM_TEMPLATE_MASTER_TYPE" val="0"/>
-  <p:tag name="KSO_WM_TEMPLATE_COLOR_TYPE" val="1"/>
-  <p:tag name="KSO_WM_SLIDE_TYPE" val="title"/>
-  <p:tag name="KSO_WM_SLIDE_SUBTYPE" val="defaultBlank"/>
-  <p:tag name="KSO_WM_SLIDE_ITEM_CNT" val="0"/>
-  <p:tag name="KSO_WM_SLIDE_INDEX" val="1"/>
-  <p:tag name="KSO_WM_TAG_VERSION" val="1.0"/>
-  <p:tag name="KSO_WM_BEAUTIFY_FLAG" val="#wm#"/>
-  <p:tag name="KSO_WM_TEMPLATE_CATEGORY" val="custom"/>
-  <p:tag name="KSO_WM_TEMPLATE_INDEX" val="20205081"/>
-  <p:tag name="KSO_WM_SLIDE_LAYOUT" val="a_b"/>
-  <p:tag name="KSO_WM_SLIDE_LAYOUT_CNT" val="1_1"/>
-  <p:tag name="KSO_WM_UNIT_SHOW_EDIT_AREA_INDICATION" val="1"/>
-  <p:tag name="KSO_WM_TEMPLATE_THUMBS_INDEX" val="1、4、7、12、13、14、15、16、17、18、20、24、25、28、33、36、40、43、44"/>
-</p:tagLst>
-</file>
-
-<file path=ppt/tags/tag81.xml><?xml version="1.0" encoding="utf-8"?>
-<p:tagLst xmlns:p="http://schemas.openxmlformats.org/presentationml/2006/main">
-  <p:tag name="KSO_WM_SLIDE_ID" val="custom20205081_1"/>
-  <p:tag name="KSO_WM_TEMPLATE_SUBCATEGORY" val="19"/>
-  <p:tag name="KSO_WM_TEMPLATE_MASTER_TYPE" val="0"/>
-  <p:tag name="KSO_WM_TEMPLATE_COLOR_TYPE" val="1"/>
-  <p:tag name="KSO_WM_SLIDE_TYPE" val="title"/>
-  <p:tag name="KSO_WM_SLIDE_SUBTYPE" val="defaultBlank"/>
-  <p:tag name="KSO_WM_SLIDE_ITEM_CNT" val="0"/>
-  <p:tag name="KSO_WM_SLIDE_INDEX" val="1"/>
-  <p:tag name="KSO_WM_TAG_VERSION" val="1.0"/>
-  <p:tag name="KSO_WM_BEAUTIFY_FLAG" val="#wm#"/>
-  <p:tag name="KSO_WM_TEMPLATE_CATEGORY" val="custom"/>
-  <p:tag name="KSO_WM_TEMPLATE_INDEX" val="20205081"/>
-  <p:tag name="KSO_WM_SLIDE_LAYOUT" val="a_b"/>
-  <p:tag name="KSO_WM_SLIDE_LAYOUT_CNT" val="1_1"/>
-  <p:tag name="KSO_WM_UNIT_SHOW_EDIT_AREA_INDICATION" val="1"/>
-  <p:tag name="KSO_WM_TEMPLATE_THUMBS_INDEX" val="1、4、7、12、13、14、15、16、17、18、20、24、25、28、33、36、40、43、44"/>
-</p:tagLst>
-</file>
-
-<file path=ppt/tags/tag82.xml><?xml version="1.0" encoding="utf-8"?>
-<p:tagLst xmlns:p="http://schemas.openxmlformats.org/presentationml/2006/main">
-  <p:tag name="KSO_WM_UNIT_ISCONTENTSTITLE" val="0"/>
-  <p:tag name="KSO_WM_UNIT_ISNUMDGMTITLE" val="0"/>
-  <p:tag name="KSO_WM_UNIT_NOCLEAR" val="0"/>
-  <p:tag name="KSO_WM_UNIT_SHOW_EDIT_AREA_INDICATION" val="1"/>
-  <p:tag name="KSO_WM_UNIT_VALUE" val="28"/>
-  <p:tag name="KSO_WM_UNIT_HIGHLIGHT" val="0"/>
-  <p:tag name="KSO_WM_UNIT_COMPATIBLE" val="0"/>
-  <p:tag name="KSO_WM_UNIT_DIAGRAM_ISNUMVISUAL" val="0"/>
-  <p:tag name="KSO_WM_UNIT_DIAGRAM_ISREFERUNIT" val="0"/>
-  <p:tag name="KSO_WM_UNIT_TYPE" val="a"/>
-  <p:tag name="KSO_WM_UNIT_INDEX" val="1"/>
-  <p:tag name="KSO_WM_UNIT_ID" val="custom20205081_1*a*1"/>
-  <p:tag name="KSO_WM_TEMPLATE_CATEGORY" val="custom"/>
-  <p:tag name="KSO_WM_TEMPLATE_INDEX" val="20205081"/>
-  <p:tag name="KSO_WM_UNIT_LAYERLEVEL" val="1"/>
-  <p:tag name="KSO_WM_TAG_VERSION" val="1.0"/>
-  <p:tag name="KSO_WM_BEAUTIFY_FLAG" val="#wm#"/>
-</p:tagLst>
-</file>
-
-<file path=ppt/tags/tag83.xml><?xml version="1.0" encoding="utf-8"?>
-<p:tagLst xmlns:p="http://schemas.openxmlformats.org/presentationml/2006/main">
-  <p:tag name="KSO_WM_UNIT_ISCONTENTSTITLE" val="0"/>
-  <p:tag name="KSO_WM_UNIT_ISNUMDGMTITLE" val="0"/>
-  <p:tag name="KSO_WM_UNIT_NOCLEAR" val="0"/>
-  <p:tag name="KSO_WM_UNIT_SHOW_EDIT_AREA_INDICATION" val="1"/>
-  <p:tag name="KSO_WM_UNIT_VALUE" val="111"/>
-  <p:tag name="KSO_WM_UNIT_HIGHLIGHT" val="0"/>
-  <p:tag name="KSO_WM_UNIT_COMPATIBLE" val="0"/>
-  <p:tag name="KSO_WM_UNIT_DIAGRAM_ISNUMVISUAL" val="0"/>
-  <p:tag name="KSO_WM_UNIT_DIAGRAM_ISREFERUNIT" val="0"/>
-  <p:tag name="KSO_WM_UNIT_TYPE" val="b"/>
-  <p:tag name="KSO_WM_UNIT_INDEX" val="1"/>
-  <p:tag name="KSO_WM_UNIT_ID" val="custom20205081_1*b*1"/>
-  <p:tag name="KSO_WM_TEMPLATE_CATEGORY" val="custom"/>
-  <p:tag name="KSO_WM_TEMPLATE_INDEX" val="20205081"/>
-  <p:tag name="KSO_WM_UNIT_LAYERLEVEL" val="1"/>
-  <p:tag name="KSO_WM_TAG_VERSION" val="1.0"/>
-  <p:tag name="KSO_WM_BEAUTIFY_FLAG" val="#wm#"/>
-</p:tagLst>
-</file>
-
-<file path=ppt/tags/tag84.xml><?xml version="1.0" encoding="utf-8"?>
-<p:tagLst xmlns:p="http://schemas.openxmlformats.org/presentationml/2006/main">
-  <p:tag name="KSO_WM_SLIDE_ID" val="custom20205081_1"/>
-  <p:tag name="KSO_WM_TEMPLATE_SUBCATEGORY" val="19"/>
-  <p:tag name="KSO_WM_TEMPLATE_MASTER_TYPE" val="0"/>
-  <p:tag name="KSO_WM_TEMPLATE_COLOR_TYPE" val="1"/>
-  <p:tag name="KSO_WM_SLIDE_TYPE" val="title"/>
-  <p:tag name="KSO_WM_SLIDE_SUBTYPE" val="defaultBlank"/>
-  <p:tag name="KSO_WM_SLIDE_ITEM_CNT" val="0"/>
-  <p:tag name="KSO_WM_SLIDE_INDEX" val="1"/>
-  <p:tag name="KSO_WM_TAG_VERSION" val="1.0"/>
-  <p:tag name="KSO_WM_BEAUTIFY_FLAG" val="#wm#"/>
-  <p:tag name="KSO_WM_TEMPLATE_CATEGORY" val="custom"/>
-  <p:tag name="KSO_WM_TEMPLATE_INDEX" val="20205081"/>
-  <p:tag name="KSO_WM_SLIDE_LAYOUT" val="a_b"/>
-  <p:tag name="KSO_WM_SLIDE_LAYOUT_CNT" val="1_1"/>
-  <p:tag name="KSO_WM_UNIT_SHOW_EDIT_AREA_INDICATION" val="1"/>
-  <p:tag name="KSO_WM_TEMPLATE_THUMBS_INDEX" val="1、4、7、12、13、14、15、16、17、18、20、24、25、28、33、36、40、43、44"/>
-</p:tagLst>
-</file>
-
-<file path=ppt/tags/tag85.xml><?xml version="1.0" encoding="utf-8"?>
-<p:tagLst xmlns:p="http://schemas.openxmlformats.org/presentationml/2006/main">
-  <p:tag name="KSO_WM_UNIT_ISCONTENTSTITLE" val="0"/>
-  <p:tag name="KSO_WM_UNIT_ISNUMDGMTITLE" val="0"/>
-  <p:tag name="KSO_WM_UNIT_NOCLEAR" val="0"/>
-  <p:tag name="KSO_WM_UNIT_SHOW_EDIT_AREA_INDICATION" val="1"/>
-  <p:tag name="KSO_WM_UNIT_VALUE" val="28"/>
-  <p:tag name="KSO_WM_UNIT_HIGHLIGHT" val="0"/>
-  <p:tag name="KSO_WM_UNIT_COMPATIBLE" val="0"/>
-  <p:tag name="KSO_WM_UNIT_DIAGRAM_ISNUMVISUAL" val="0"/>
-  <p:tag name="KSO_WM_UNIT_DIAGRAM_ISREFERUNIT" val="0"/>
-  <p:tag name="KSO_WM_UNIT_TYPE" val="a"/>
-  <p:tag name="KSO_WM_UNIT_INDEX" val="1"/>
-  <p:tag name="KSO_WM_UNIT_ID" val="custom20205081_1*a*1"/>
-  <p:tag name="KSO_WM_TEMPLATE_CATEGORY" val="custom"/>
-  <p:tag name="KSO_WM_TEMPLATE_INDEX" val="20205081"/>
-  <p:tag name="KSO_WM_UNIT_LAYERLEVEL" val="1"/>
-  <p:tag name="KSO_WM_TAG_VERSION" val="1.0"/>
-  <p:tag name="KSO_WM_BEAUTIFY_FLAG" val="#wm#"/>
-</p:tagLst>
-</file>
-
-<file path=ppt/tags/tag86.xml><?xml version="1.0" encoding="utf-8"?>
-<p:tagLst xmlns:p="http://schemas.openxmlformats.org/presentationml/2006/main">
-  <p:tag name="KSO_WM_UNIT_ISCONTENTSTITLE" val="0"/>
-  <p:tag name="KSO_WM_UNIT_ISNUMDGMTITLE" val="0"/>
-  <p:tag name="KSO_WM_UNIT_NOCLEAR" val="0"/>
-  <p:tag name="KSO_WM_UNIT_SHOW_EDIT_AREA_INDICATION" val="1"/>
-  <p:tag name="KSO_WM_UNIT_VALUE" val="111"/>
-  <p:tag name="KSO_WM_UNIT_HIGHLIGHT" val="0"/>
-  <p:tag name="KSO_WM_UNIT_COMPATIBLE" val="0"/>
-  <p:tag name="KSO_WM_UNIT_DIAGRAM_ISNUMVISUAL" val="0"/>
-  <p:tag name="KSO_WM_UNIT_DIAGRAM_ISREFERUNIT" val="0"/>
-  <p:tag name="KSO_WM_UNIT_TYPE" val="b"/>
-  <p:tag name="KSO_WM_UNIT_INDEX" val="1"/>
-  <p:tag name="KSO_WM_UNIT_ID" val="custom20205081_1*b*1"/>
-  <p:tag name="KSO_WM_TEMPLATE_CATEGORY" val="custom"/>
-  <p:tag name="KSO_WM_TEMPLATE_INDEX" val="20205081"/>
-  <p:tag name="KSO_WM_UNIT_LAYERLEVEL" val="1"/>
-  <p:tag name="KSO_WM_TAG_VERSION" val="1.0"/>
-  <p:tag name="KSO_WM_BEAUTIFY_FLAG" val="#wm#"/>
-</p:tagLst>
-</file>
-
-<file path=ppt/tags/tag87.xml><?xml version="1.0" encoding="utf-8"?>
-<p:tagLst xmlns:p="http://schemas.openxmlformats.org/presentationml/2006/main">
-  <p:tag name="KSO_WM_SLIDE_ID" val="custom20205081_1"/>
-  <p:tag name="KSO_WM_TEMPLATE_SUBCATEGORY" val="19"/>
-  <p:tag name="KSO_WM_TEMPLATE_MASTER_TYPE" val="0"/>
-  <p:tag name="KSO_WM_TEMPLATE_COLOR_TYPE" val="1"/>
-  <p:tag name="KSO_WM_SLIDE_TYPE" val="title"/>
-  <p:tag name="KSO_WM_SLIDE_SUBTYPE" val="defaultBlank"/>
-  <p:tag name="KSO_WM_SLIDE_ITEM_CNT" val="0"/>
-  <p:tag name="KSO_WM_SLIDE_INDEX" val="1"/>
-  <p:tag name="KSO_WM_TAG_VERSION" val="1.0"/>
-  <p:tag name="KSO_WM_BEAUTIFY_FLAG" val="#wm#"/>
-  <p:tag name="KSO_WM_TEMPLATE_CATEGORY" val="custom"/>
-  <p:tag name="KSO_WM_TEMPLATE_INDEX" val="20205081"/>
-  <p:tag name="KSO_WM_SLIDE_LAYOUT" val="a_b"/>
-  <p:tag name="KSO_WM_SLIDE_LAYOUT_CNT" val="1_1"/>
-  <p:tag name="KSO_WM_UNIT_SHOW_EDIT_AREA_INDICATION" val="1"/>
-  <p:tag name="KSO_WM_TEMPLATE_THUMBS_INDEX" val="1、4、7、12、13、14、15、16、17、18、20、24、25、28、33、36、40、43、44"/>
-</p:tagLst>
-</file>
-
-<file path=ppt/tags/tag88.xml><?xml version="1.0" encoding="utf-8"?>
-<p:tagLst xmlns:p="http://schemas.openxmlformats.org/presentationml/2006/main">
-  <p:tag name="KSO_WM_UNIT_ISCONTENTSTITLE" val="0"/>
-  <p:tag name="KSO_WM_UNIT_ISNUMDGMTITLE" val="0"/>
-  <p:tag name="KSO_WM_UNIT_NOCLEAR" val="0"/>
-  <p:tag name="KSO_WM_UNIT_SHOW_EDIT_AREA_INDICATION" val="1"/>
-  <p:tag name="KSO_WM_UNIT_VALUE" val="28"/>
-  <p:tag name="KSO_WM_UNIT_HIGHLIGHT" val="0"/>
-  <p:tag name="KSO_WM_UNIT_COMPATIBLE" val="0"/>
-  <p:tag name="KSO_WM_UNIT_DIAGRAM_ISNUMVISUAL" val="0"/>
-  <p:tag name="KSO_WM_UNIT_DIAGRAM_ISREFERUNIT" val="0"/>
-  <p:tag name="KSO_WM_UNIT_TYPE" val="a"/>
-  <p:tag name="KSO_WM_UNIT_INDEX" val="1"/>
-  <p:tag name="KSO_WM_UNIT_ID" val="custom20205081_1*a*1"/>
-  <p:tag name="KSO_WM_TEMPLATE_CATEGORY" val="custom"/>
-  <p:tag name="KSO_WM_TEMPLATE_INDEX" val="20205081"/>
-  <p:tag name="KSO_WM_UNIT_LAYERLEVEL" val="1"/>
-  <p:tag name="KSO_WM_TAG_VERSION" val="1.0"/>
-  <p:tag name="KSO_WM_BEAUTIFY_FLAG" val="#wm#"/>
-</p:tagLst>
-</file>
-
-<file path=ppt/tags/tag89.xml><?xml version="1.0" encoding="utf-8"?>
-<p:tagLst xmlns:p="http://schemas.openxmlformats.org/presentationml/2006/main">
-  <p:tag name="KSO_WM_UNIT_ISCONTENTSTITLE" val="0"/>
-  <p:tag name="KSO_WM_UNIT_ISNUMDGMTITLE" val="0"/>
-  <p:tag name="KSO_WM_UNIT_NOCLEAR" val="0"/>
-  <p:tag name="KSO_WM_UNIT_SHOW_EDIT_AREA_INDICATION" val="1"/>
-  <p:tag name="KSO_WM_UNIT_VALUE" val="111"/>
-  <p:tag name="KSO_WM_UNIT_HIGHLIGHT" val="0"/>
-  <p:tag name="KSO_WM_UNIT_COMPATIBLE" val="0"/>
-  <p:tag name="KSO_WM_UNIT_DIAGRAM_ISNUMVISUAL" val="0"/>
-  <p:tag name="KSO_WM_UNIT_DIAGRAM_ISREFERUNIT" val="0"/>
-  <p:tag name="KSO_WM_UNIT_TYPE" val="b"/>
-  <p:tag name="KSO_WM_UNIT_INDEX" val="1"/>
-  <p:tag name="KSO_WM_UNIT_ID" val="custom20205081_1*b*1"/>
-  <p:tag name="KSO_WM_TEMPLATE_CATEGORY" val="custom"/>
-  <p:tag name="KSO_WM_TEMPLATE_INDEX" val="20205081"/>
-  <p:tag name="KSO_WM_UNIT_LAYERLEVEL" val="1"/>
-  <p:tag name="KSO_WM_TAG_VERSION" val="1.0"/>
-  <p:tag name="KSO_WM_BEAUTIFY_FLAG" val="#wm#"/>
-</p:tagLst>
-</file>
-
 <file path=ppt/tags/tag9.xml><?xml version="1.0" encoding="utf-8"?>
 <p:tagLst xmlns:p="http://schemas.openxmlformats.org/presentationml/2006/main">
   <p:tag name="KSO_WM_UNIT_HIGHLIGHT" val="0"/>
@@ -6374,222 +7420,6 @@
   <p:tag name="KSO_WM_UNIT_LAYERLEVEL" val="1"/>
   <p:tag name="KSO_WM_TAG_VERSION" val="1.0"/>
   <p:tag name="KSO_WM_BEAUTIFY_FLAG" val="#wm#"/>
-</p:tagLst>
-</file>
-
-<file path=ppt/tags/tag90.xml><?xml version="1.0" encoding="utf-8"?>
-<p:tagLst xmlns:p="http://schemas.openxmlformats.org/presentationml/2006/main">
-  <p:tag name="KSO_WM_SLIDE_ID" val="custom20205081_1"/>
-  <p:tag name="KSO_WM_TEMPLATE_SUBCATEGORY" val="19"/>
-  <p:tag name="KSO_WM_TEMPLATE_MASTER_TYPE" val="0"/>
-  <p:tag name="KSO_WM_TEMPLATE_COLOR_TYPE" val="1"/>
-  <p:tag name="KSO_WM_SLIDE_TYPE" val="title"/>
-  <p:tag name="KSO_WM_SLIDE_SUBTYPE" val="defaultBlank"/>
-  <p:tag name="KSO_WM_SLIDE_ITEM_CNT" val="0"/>
-  <p:tag name="KSO_WM_SLIDE_INDEX" val="1"/>
-  <p:tag name="KSO_WM_TAG_VERSION" val="1.0"/>
-  <p:tag name="KSO_WM_BEAUTIFY_FLAG" val="#wm#"/>
-  <p:tag name="KSO_WM_TEMPLATE_CATEGORY" val="custom"/>
-  <p:tag name="KSO_WM_TEMPLATE_INDEX" val="20205081"/>
-  <p:tag name="KSO_WM_SLIDE_LAYOUT" val="a_b"/>
-  <p:tag name="KSO_WM_SLIDE_LAYOUT_CNT" val="1_1"/>
-  <p:tag name="KSO_WM_UNIT_SHOW_EDIT_AREA_INDICATION" val="1"/>
-  <p:tag name="KSO_WM_TEMPLATE_THUMBS_INDEX" val="1、4、7、12、13、14、15、16、17、18、20、24、25、28、33、36、40、43、44"/>
-</p:tagLst>
-</file>
-
-<file path=ppt/tags/tag91.xml><?xml version="1.0" encoding="utf-8"?>
-<p:tagLst xmlns:p="http://schemas.openxmlformats.org/presentationml/2006/main">
-  <p:tag name="KSO_WM_UNIT_ISCONTENTSTITLE" val="0"/>
-  <p:tag name="KSO_WM_UNIT_ISNUMDGMTITLE" val="0"/>
-  <p:tag name="KSO_WM_UNIT_NOCLEAR" val="0"/>
-  <p:tag name="KSO_WM_UNIT_SHOW_EDIT_AREA_INDICATION" val="1"/>
-  <p:tag name="KSO_WM_UNIT_VALUE" val="28"/>
-  <p:tag name="KSO_WM_UNIT_HIGHLIGHT" val="0"/>
-  <p:tag name="KSO_WM_UNIT_COMPATIBLE" val="0"/>
-  <p:tag name="KSO_WM_UNIT_DIAGRAM_ISNUMVISUAL" val="0"/>
-  <p:tag name="KSO_WM_UNIT_DIAGRAM_ISREFERUNIT" val="0"/>
-  <p:tag name="KSO_WM_UNIT_TYPE" val="a"/>
-  <p:tag name="KSO_WM_UNIT_INDEX" val="1"/>
-  <p:tag name="KSO_WM_UNIT_ID" val="custom20205081_1*a*1"/>
-  <p:tag name="KSO_WM_TEMPLATE_CATEGORY" val="custom"/>
-  <p:tag name="KSO_WM_TEMPLATE_INDEX" val="20205081"/>
-  <p:tag name="KSO_WM_UNIT_LAYERLEVEL" val="1"/>
-  <p:tag name="KSO_WM_TAG_VERSION" val="1.0"/>
-  <p:tag name="KSO_WM_BEAUTIFY_FLAG" val="#wm#"/>
-</p:tagLst>
-</file>
-
-<file path=ppt/tags/tag92.xml><?xml version="1.0" encoding="utf-8"?>
-<p:tagLst xmlns:p="http://schemas.openxmlformats.org/presentationml/2006/main">
-  <p:tag name="KSO_WM_UNIT_ISCONTENTSTITLE" val="0"/>
-  <p:tag name="KSO_WM_UNIT_ISNUMDGMTITLE" val="0"/>
-  <p:tag name="KSO_WM_UNIT_NOCLEAR" val="0"/>
-  <p:tag name="KSO_WM_UNIT_SHOW_EDIT_AREA_INDICATION" val="1"/>
-  <p:tag name="KSO_WM_UNIT_VALUE" val="111"/>
-  <p:tag name="KSO_WM_UNIT_HIGHLIGHT" val="0"/>
-  <p:tag name="KSO_WM_UNIT_COMPATIBLE" val="0"/>
-  <p:tag name="KSO_WM_UNIT_DIAGRAM_ISNUMVISUAL" val="0"/>
-  <p:tag name="KSO_WM_UNIT_DIAGRAM_ISREFERUNIT" val="0"/>
-  <p:tag name="KSO_WM_UNIT_TYPE" val="b"/>
-  <p:tag name="KSO_WM_UNIT_INDEX" val="1"/>
-  <p:tag name="KSO_WM_UNIT_ID" val="custom20205081_1*b*1"/>
-  <p:tag name="KSO_WM_TEMPLATE_CATEGORY" val="custom"/>
-  <p:tag name="KSO_WM_TEMPLATE_INDEX" val="20205081"/>
-  <p:tag name="KSO_WM_UNIT_LAYERLEVEL" val="1"/>
-  <p:tag name="KSO_WM_TAG_VERSION" val="1.0"/>
-  <p:tag name="KSO_WM_BEAUTIFY_FLAG" val="#wm#"/>
-</p:tagLst>
-</file>
-
-<file path=ppt/tags/tag93.xml><?xml version="1.0" encoding="utf-8"?>
-<p:tagLst xmlns:p="http://schemas.openxmlformats.org/presentationml/2006/main">
-  <p:tag name="KSO_WM_SLIDE_ID" val="custom20205081_1"/>
-  <p:tag name="KSO_WM_TEMPLATE_SUBCATEGORY" val="19"/>
-  <p:tag name="KSO_WM_TEMPLATE_MASTER_TYPE" val="0"/>
-  <p:tag name="KSO_WM_TEMPLATE_COLOR_TYPE" val="1"/>
-  <p:tag name="KSO_WM_SLIDE_TYPE" val="title"/>
-  <p:tag name="KSO_WM_SLIDE_SUBTYPE" val="defaultBlank"/>
-  <p:tag name="KSO_WM_SLIDE_ITEM_CNT" val="0"/>
-  <p:tag name="KSO_WM_SLIDE_INDEX" val="1"/>
-  <p:tag name="KSO_WM_TAG_VERSION" val="1.0"/>
-  <p:tag name="KSO_WM_BEAUTIFY_FLAG" val="#wm#"/>
-  <p:tag name="KSO_WM_TEMPLATE_CATEGORY" val="custom"/>
-  <p:tag name="KSO_WM_TEMPLATE_INDEX" val="20205081"/>
-  <p:tag name="KSO_WM_SLIDE_LAYOUT" val="a_b"/>
-  <p:tag name="KSO_WM_SLIDE_LAYOUT_CNT" val="1_1"/>
-  <p:tag name="KSO_WM_UNIT_SHOW_EDIT_AREA_INDICATION" val="1"/>
-  <p:tag name="KSO_WM_TEMPLATE_THUMBS_INDEX" val="1、4、7、12、13、14、15、16、17、18、20、24、25、28、33、36、40、43、44"/>
-</p:tagLst>
-</file>
-
-<file path=ppt/tags/tag94.xml><?xml version="1.0" encoding="utf-8"?>
-<p:tagLst xmlns:p="http://schemas.openxmlformats.org/presentationml/2006/main">
-  <p:tag name="KSO_WM_UNIT_ISCONTENTSTITLE" val="0"/>
-  <p:tag name="KSO_WM_UNIT_ISNUMDGMTITLE" val="0"/>
-  <p:tag name="KSO_WM_UNIT_NOCLEAR" val="0"/>
-  <p:tag name="KSO_WM_UNIT_SHOW_EDIT_AREA_INDICATION" val="1"/>
-  <p:tag name="KSO_WM_UNIT_VALUE" val="28"/>
-  <p:tag name="KSO_WM_UNIT_HIGHLIGHT" val="0"/>
-  <p:tag name="KSO_WM_UNIT_COMPATIBLE" val="0"/>
-  <p:tag name="KSO_WM_UNIT_DIAGRAM_ISNUMVISUAL" val="0"/>
-  <p:tag name="KSO_WM_UNIT_DIAGRAM_ISREFERUNIT" val="0"/>
-  <p:tag name="KSO_WM_UNIT_TYPE" val="a"/>
-  <p:tag name="KSO_WM_UNIT_INDEX" val="1"/>
-  <p:tag name="KSO_WM_UNIT_ID" val="custom20205081_1*a*1"/>
-  <p:tag name="KSO_WM_TEMPLATE_CATEGORY" val="custom"/>
-  <p:tag name="KSO_WM_TEMPLATE_INDEX" val="20205081"/>
-  <p:tag name="KSO_WM_UNIT_LAYERLEVEL" val="1"/>
-  <p:tag name="KSO_WM_TAG_VERSION" val="1.0"/>
-  <p:tag name="KSO_WM_BEAUTIFY_FLAG" val="#wm#"/>
-</p:tagLst>
-</file>
-
-<file path=ppt/tags/tag95.xml><?xml version="1.0" encoding="utf-8"?>
-<p:tagLst xmlns:p="http://schemas.openxmlformats.org/presentationml/2006/main">
-  <p:tag name="KSO_WM_UNIT_ISCONTENTSTITLE" val="0"/>
-  <p:tag name="KSO_WM_UNIT_ISNUMDGMTITLE" val="0"/>
-  <p:tag name="KSO_WM_UNIT_NOCLEAR" val="0"/>
-  <p:tag name="KSO_WM_UNIT_SHOW_EDIT_AREA_INDICATION" val="1"/>
-  <p:tag name="KSO_WM_UNIT_VALUE" val="111"/>
-  <p:tag name="KSO_WM_UNIT_HIGHLIGHT" val="0"/>
-  <p:tag name="KSO_WM_UNIT_COMPATIBLE" val="0"/>
-  <p:tag name="KSO_WM_UNIT_DIAGRAM_ISNUMVISUAL" val="0"/>
-  <p:tag name="KSO_WM_UNIT_DIAGRAM_ISREFERUNIT" val="0"/>
-  <p:tag name="KSO_WM_UNIT_TYPE" val="b"/>
-  <p:tag name="KSO_WM_UNIT_INDEX" val="1"/>
-  <p:tag name="KSO_WM_UNIT_ID" val="custom20205081_1*b*1"/>
-  <p:tag name="KSO_WM_TEMPLATE_CATEGORY" val="custom"/>
-  <p:tag name="KSO_WM_TEMPLATE_INDEX" val="20205081"/>
-  <p:tag name="KSO_WM_UNIT_LAYERLEVEL" val="1"/>
-  <p:tag name="KSO_WM_TAG_VERSION" val="1.0"/>
-  <p:tag name="KSO_WM_BEAUTIFY_FLAG" val="#wm#"/>
-</p:tagLst>
-</file>
-
-<file path=ppt/tags/tag96.xml><?xml version="1.0" encoding="utf-8"?>
-<p:tagLst xmlns:p="http://schemas.openxmlformats.org/presentationml/2006/main">
-  <p:tag name="KSO_WM_SLIDE_ID" val="custom20205081_1"/>
-  <p:tag name="KSO_WM_TEMPLATE_SUBCATEGORY" val="19"/>
-  <p:tag name="KSO_WM_TEMPLATE_MASTER_TYPE" val="0"/>
-  <p:tag name="KSO_WM_TEMPLATE_COLOR_TYPE" val="1"/>
-  <p:tag name="KSO_WM_SLIDE_TYPE" val="title"/>
-  <p:tag name="KSO_WM_SLIDE_SUBTYPE" val="defaultBlank"/>
-  <p:tag name="KSO_WM_SLIDE_ITEM_CNT" val="0"/>
-  <p:tag name="KSO_WM_SLIDE_INDEX" val="1"/>
-  <p:tag name="KSO_WM_TAG_VERSION" val="1.0"/>
-  <p:tag name="KSO_WM_BEAUTIFY_FLAG" val="#wm#"/>
-  <p:tag name="KSO_WM_TEMPLATE_CATEGORY" val="custom"/>
-  <p:tag name="KSO_WM_TEMPLATE_INDEX" val="20205081"/>
-  <p:tag name="KSO_WM_SLIDE_LAYOUT" val="a_b"/>
-  <p:tag name="KSO_WM_SLIDE_LAYOUT_CNT" val="1_1"/>
-  <p:tag name="KSO_WM_UNIT_SHOW_EDIT_AREA_INDICATION" val="1"/>
-  <p:tag name="KSO_WM_TEMPLATE_THUMBS_INDEX" val="1、4、7、12、13、14、15、16、17、18、20、24、25、28、33、36、40、43、44"/>
-</p:tagLst>
-</file>
-
-<file path=ppt/tags/tag97.xml><?xml version="1.0" encoding="utf-8"?>
-<p:tagLst xmlns:p="http://schemas.openxmlformats.org/presentationml/2006/main">
-  <p:tag name="KSO_WM_UNIT_ISCONTENTSTITLE" val="0"/>
-  <p:tag name="KSO_WM_UNIT_ISNUMDGMTITLE" val="0"/>
-  <p:tag name="KSO_WM_UNIT_NOCLEAR" val="0"/>
-  <p:tag name="KSO_WM_UNIT_SHOW_EDIT_AREA_INDICATION" val="1"/>
-  <p:tag name="KSO_WM_UNIT_VALUE" val="28"/>
-  <p:tag name="KSO_WM_UNIT_HIGHLIGHT" val="0"/>
-  <p:tag name="KSO_WM_UNIT_COMPATIBLE" val="0"/>
-  <p:tag name="KSO_WM_UNIT_DIAGRAM_ISNUMVISUAL" val="0"/>
-  <p:tag name="KSO_WM_UNIT_DIAGRAM_ISREFERUNIT" val="0"/>
-  <p:tag name="KSO_WM_UNIT_TYPE" val="a"/>
-  <p:tag name="KSO_WM_UNIT_INDEX" val="1"/>
-  <p:tag name="KSO_WM_UNIT_ID" val="custom20205081_1*a*1"/>
-  <p:tag name="KSO_WM_TEMPLATE_CATEGORY" val="custom"/>
-  <p:tag name="KSO_WM_TEMPLATE_INDEX" val="20205081"/>
-  <p:tag name="KSO_WM_UNIT_LAYERLEVEL" val="1"/>
-  <p:tag name="KSO_WM_TAG_VERSION" val="1.0"/>
-  <p:tag name="KSO_WM_BEAUTIFY_FLAG" val="#wm#"/>
-</p:tagLst>
-</file>
-
-<file path=ppt/tags/tag98.xml><?xml version="1.0" encoding="utf-8"?>
-<p:tagLst xmlns:p="http://schemas.openxmlformats.org/presentationml/2006/main">
-  <p:tag name="KSO_WM_UNIT_ISCONTENTSTITLE" val="0"/>
-  <p:tag name="KSO_WM_UNIT_ISNUMDGMTITLE" val="0"/>
-  <p:tag name="KSO_WM_UNIT_NOCLEAR" val="0"/>
-  <p:tag name="KSO_WM_UNIT_SHOW_EDIT_AREA_INDICATION" val="1"/>
-  <p:tag name="KSO_WM_UNIT_VALUE" val="111"/>
-  <p:tag name="KSO_WM_UNIT_HIGHLIGHT" val="0"/>
-  <p:tag name="KSO_WM_UNIT_COMPATIBLE" val="0"/>
-  <p:tag name="KSO_WM_UNIT_DIAGRAM_ISNUMVISUAL" val="0"/>
-  <p:tag name="KSO_WM_UNIT_DIAGRAM_ISREFERUNIT" val="0"/>
-  <p:tag name="KSO_WM_UNIT_TYPE" val="b"/>
-  <p:tag name="KSO_WM_UNIT_INDEX" val="1"/>
-  <p:tag name="KSO_WM_UNIT_ID" val="custom20205081_1*b*1"/>
-  <p:tag name="KSO_WM_TEMPLATE_CATEGORY" val="custom"/>
-  <p:tag name="KSO_WM_TEMPLATE_INDEX" val="20205081"/>
-  <p:tag name="KSO_WM_UNIT_LAYERLEVEL" val="1"/>
-  <p:tag name="KSO_WM_TAG_VERSION" val="1.0"/>
-  <p:tag name="KSO_WM_BEAUTIFY_FLAG" val="#wm#"/>
-</p:tagLst>
-</file>
-
-<file path=ppt/tags/tag99.xml><?xml version="1.0" encoding="utf-8"?>
-<p:tagLst xmlns:p="http://schemas.openxmlformats.org/presentationml/2006/main">
-  <p:tag name="KSO_WM_SLIDE_ID" val="custom20205081_1"/>
-  <p:tag name="KSO_WM_TEMPLATE_SUBCATEGORY" val="19"/>
-  <p:tag name="KSO_WM_TEMPLATE_MASTER_TYPE" val="0"/>
-  <p:tag name="KSO_WM_TEMPLATE_COLOR_TYPE" val="1"/>
-  <p:tag name="KSO_WM_SLIDE_TYPE" val="title"/>
-  <p:tag name="KSO_WM_SLIDE_SUBTYPE" val="defaultBlank"/>
-  <p:tag name="KSO_WM_SLIDE_ITEM_CNT" val="0"/>
-  <p:tag name="KSO_WM_SLIDE_INDEX" val="1"/>
-  <p:tag name="KSO_WM_TAG_VERSION" val="1.0"/>
-  <p:tag name="KSO_WM_BEAUTIFY_FLAG" val="#wm#"/>
-  <p:tag name="KSO_WM_TEMPLATE_CATEGORY" val="custom"/>
-  <p:tag name="KSO_WM_TEMPLATE_INDEX" val="20205081"/>
-  <p:tag name="KSO_WM_SLIDE_LAYOUT" val="a_b"/>
-  <p:tag name="KSO_WM_SLIDE_LAYOUT_CNT" val="1_1"/>
-  <p:tag name="KSO_WM_UNIT_SHOW_EDIT_AREA_INDICATION" val="1"/>
-  <p:tag name="KSO_WM_TEMPLATE_THUMBS_INDEX" val="1、4、7、12、13、14、15、16、17、18、20、24、25、28、33、36、40、43、44"/>
 </p:tagLst>
 </file>
 

</xml_diff>